<commit_message>
Update deck to the source-based plant constants and SIMC gains; add data sources slide
Co-Authored-By: Claude Opus 5.5 <noreply@anthropic.com>
Claude-Session: https://claude.ai/code/session_01KYcVruEhgF1vnL4e2wj7fD
</commit_message>
<xml_diff>
--- a/PID_Thermal_Control_for_Heavy-Duty_Trucks_v2.pptx
+++ b/PID_Thermal_Control_for_Heavy-Duty_Trucks_v2.pptx
@@ -19,6 +19,7 @@
     <p:sldId id="269" r:id="rId15"/>
     <p:sldId id="267" r:id="rId13"/>
     <p:sldId id="273" r:id="rId19"/>
+    <p:sldId id="275" r:id="rId26"/>
     <p:sldId id="274" r:id="rId20"/>
   </p:sldIdLst>
   <p:notesMasterIdLst>
@@ -604,7 +605,7 @@
           <a:p>
             <a:r>
               <a:rPr lang="en-US" dirty="0"/>
-              <a:t>All the MATLAB code is in one file, pid_truck_cooling.m, split into sections. The parameters and gains are at the top, so every number is in one place. Then the plant transfer functions are defined with num, den and tf, and the three controllers P, PI and PID. feedback() closes the loop, and pole() prints the closed-loop poles: all of them are in the left half of the s-plane, so all three loops are stable. Experiment 1 is a set-point step analysed with step() and stepinfo(). Experiment 2 is a load step, where we find the settling time by walking backwards from the end of the response, the same method as in the time-domain lab.</a:t>
+              <a:t>All the MATLAB code is in one file, pid_truck_cooling.m, split into sections. The first section lists the physical data with its source, and the assumptions we had to make. The next section calculates the time constants and gains from that data, and then the PID gains with the SIMC rule, so no number is typed in by hand. Then the plant transfer functions are defined with num, den and tf, and the three controllers P, PI and PID. feedback() closes the loop, and pole() prints the closed-loop poles: all of them are in the left half of the s-plane, so all three loops are stable. Experiment 1 is a set-point step analysed with step() and stepinfo(). Experiment 2 is a load step, where we find the settling time by walking backwards from the end of the response, the same method as in the time-domain lab.</a:t>
             </a:r>
             <a:endParaRPr lang="en-US" dirty="0"/>
           </a:p>
@@ -692,7 +693,7 @@
           <a:p>
             <a:r>
               <a:rPr lang="en-US" dirty="0"/>
-              <a:t>We built the same loop by hand in Simulink. The Step block gives the set-point, 90 °C, stepping to 95 °C at 1200 seconds. The Sum block subtracts the set-point from the coolant temperature to get the error. The PID Controller block has the same gains as the MATLAB code, a filter coefficient of 0.1, output limits and clamping anti-windup. The limits are minus 0.8 and 2.2 because the block outputs the change from the normal command of 0.8, so the real command stays between 0 and 3. The cooling transfer function has a minus sign because more cooling lowers the temperature. A second Step adds 50 % engine load at 600 seconds through Gd(s). The plant output is 90 plus the two effects, and it is fed back to the error block. The Scope shows the temperature and the cooling command. [Add a screenshot of the model and the Scope here.]</a:t>
+              <a:t>We built the same loop by hand in Simulink. The Step block gives the set-point, 90 °C, stepping to 95 °C at 1200 seconds. The Sum block subtracts the set-point from the coolant temperature to get the error. The PID Controller block has the same gains as the MATLAB code, a filter coefficient of 1, output limits and clamping anti-windup. The limits are minus 0.83 and 2.17 because the block outputs the change from the normal command of 0.83, so the real command stays between 0 and 3. The cooling transfer function has a minus sign because more cooling lowers the temperature. A second Step adds 50 % engine load at 600 seconds through Gd(s). The plant output is 90 plus the two effects, and it is fed back to the error block. The Scope shows the temperature and the cooling command. [Add a screenshot of the model and the Scope here.]</a:t>
             </a:r>
             <a:endParaRPr lang="en-US" dirty="0"/>
           </a:p>
@@ -780,7 +781,7 @@
           <a:p>
             <a:r>
               <a:rPr lang="en-US" dirty="0"/>
-              <a:t>Second test, the one that matters most for a truck. At time zero the engine load jumps from 30 to 80 percent, as if the truck hits a hill. P only settles about 4 degrees too hot and stays there: that is the steady-state offset, exactly as theory predicts, and it is also why today's wax thermostat, which is a mechanical P controller, never reaches 90 °C. Adding the integral term brings the temperature back to exactly 90 °C. Adding the derivative term lowers the peak from about 4.9 to 4.1 K. Settling time here is the time to stay within ±0.5 K. The benefit of D is small because thermal systems are slow and smooth, which is why many industrial temperature loops use PI only. During this test the PID raises the cooling command from 0.8 to about 2.2, still below the limit of 3.</a:t>
+              <a:t>Second test, the one that matters most for a truck. At time zero the engine load jumps from 30 to 80 percent, as if the truck hits a hill. That adds 75 kW of heat to the coolant. P only settles about 3.9 degrees too hot and stays there: that is the steady-state offset, exactly as theory predicts, and it is also why today's wax thermostat, which is a mechanical P controller, never reaches its target. Adding the integral term brings the temperature back to exactly 90 °C in about three minutes. Adding the derivative term lowers the peak from 3.3 to 3.0 K. Settling time here is the time to stay within ±0.5 K. The benefit of D is small because thermal systems are slow and smooth, which is why many industrial temperature loops use PI only. During this test the PID raises the cooling command from 0.83 to about 2.2, still below the limit of 3.</a:t>
             </a:r>
             <a:endParaRPr lang="en-US" dirty="0"/>
           </a:p>
@@ -868,7 +869,7 @@
           <a:p>
             <a:r>
               <a:rPr lang="en-US" dirty="0"/>
-              <a:t>First test: we change the target from 90 to 95 °C and compare P only, PI and PID, using step() and stepinfo() in MATLAB. P only never reaches 95: it stops at about 94.3 °C, a steady-state offset of 0.7 K, because it needs an error to produce any output. PI removes the offset but overshoots by about 20 %. The full PID removes the offset and cuts the overshoot to 7.5 %, settling within 2 % in about 43 seconds. The closed-loop poles printed by pole() all have negative real parts, so all three loops are stable.</a:t>
+              <a:t>First test: we change the target from 90 to 95 °C and compare P only, PI and PID, using step() and stepinfo() in MATLAB. P only never quite reaches 95: it stops at about 94.8 °C, a small steady-state offset of 0.2 K, because it needs an error to produce any output. The offset is small here because the plant gain is large. PI removes the offset with 12.6 % overshoot. The full PID removes the offset and lowers the overshoot to 10.7 %, settling within 2 % in about 212 seconds. The closed-loop poles printed by pole() all have negative real parts, so all three loops are stable.</a:t>
             </a:r>
             <a:endParaRPr lang="en-US" dirty="0"/>
           </a:p>
@@ -956,7 +957,7 @@
           <a:p>
             <a:r>
               <a:rPr lang="en-US" dirty="0"/>
-              <a:t>To conclude: the PID holds the engine at 90 °C with no steady-state offset. A P-only controller, which is how today's wax thermostat behaves, stays about 4 degrees too hot, and adding D cuts the temperature peak by about 15 %. The limitations: our model is linear and keeps only the coolant temperature, so it has no oil temperature and does not model the valve, pump and fan separately. The parameters are typical values rather than measured ones. The next steps are adding the radiator and oil temperatures, validating the model against real engine data, and then trying a predictive controller, MPC, which uses the road ahead to plan cooling.</a:t>
+              <a:t>To conclude: the PID holds the engine at 90 °C with no steady-state offset. A P-only controller, which is how today's wax thermostat behaves, stays about 4 degrees too hot after a load step, and adding D cuts the temperature peak by about 7 %. The limitations: our model is linear and keeps only the coolant temperature, so it has no oil temperature and does not model the valve, pump and fan separately. Most inputs come from published data, but a few are assumptions, listed on the next slide. The next steps are adding the radiator and oil temperatures, validating the model against real engine data, and then trying a predictive controller, MPC, which uses the road ahead to plan cooling.</a:t>
             </a:r>
             <a:endParaRPr lang="en-US" dirty="0"/>
           </a:p>
@@ -1044,7 +1045,7 @@
           <a:p>
             <a:r>
               <a:rPr lang="en-US" dirty="0"/>
-              <a:t>Likely questions. How did you tune it? Trial and error in simulation: Kp first, then Ki, then Kd; Ziegler-Nichols is an alternative. Why is D so small? Thermal systems are slow and smooth, so D adds little, which is why many temperature loops use PI. Why only one temperature? A simple linear model is enough to show what P, I and D each do; the full model is our next step. Is the model validated? Not against real data yet; the parameters are typical values. Why e = T_c minus T_ref? Our actuators remove heat, so hotter must give a positive output. Why does a P controller leave an offset? It needs a non-zero error to produce a non-zero output; the integral removes it.</a:t>
+              <a:t>Likely questions. Where do the numbers come from? The engine data is from the Volvo D13 fact sheet, the heat rejection from a heavy-duty cooling paper, the material properties from standard tables, and the PID gains from the SIMC rule; the few assumptions are listed on slide 15. Why is D so small? Thermal systems are slow and smooth, so D adds little, which is why many temperature loops use PI. Why only one temperature? A simple linear model is enough to show what P, I and D each do; the full model is our next step. Is the model validated? Not against real engine data yet. Why e = T_c minus T_ref? Our actuators remove heat, so hotter must give a positive output. Why does a P controller leave an offset? It needs a non-zero error to produce a non-zero output; the integral removes it.</a:t>
             </a:r>
             <a:endParaRPr lang="en-US" dirty="0"/>
           </a:p>
@@ -1484,7 +1485,7 @@
           <a:p>
             <a:r>
               <a:rPr lang="en-US" dirty="0"/>
-              <a:t>A real cooling system has three temperatures: the engine coolant T_c, the radiator coolant T_r and the oil T_o. To keep the model simple we only keep T_c, the one we control. The radiator is not a separate temperature any more; it becomes a 10-second lag between the cooling command and the engine. The engine block itself adds a 60-second lag. The oil is left out because it changes slowly and does not change how we design the PID.</a:t>
+              <a:t>A real cooling system has three temperatures: the engine coolant T_c, the radiator coolant T_r and the oil T_o. To keep the model simple we only keep T_c, the one we control. The radiator becomes a short lag of 4.7 seconds: that is roughly the time the coolant spends inside the radiator. The engine block is a large mass of iron and coolant, so it gives a long lag of about 509 seconds, roughly 8.5 minutes. The oil is left out because it changes slowly and does not change how we design the PID.</a:t>
             </a:r>
             <a:endParaRPr lang="en-US" dirty="0"/>
           </a:p>
@@ -1572,7 +1573,7 @@
           <a:p>
             <a:r>
               <a:rPr lang="en-US" dirty="0"/>
-              <a:t>Starting from the energy balance, heat in minus heat out, we linearise around the normal operating point: 90 °C at 30 % engine load. That gives two transfer functions. G(s) is the cooling path: if the cooling command goes up by one unit, the coolant ends up 20 K colder, but it gets there through two lags, 10 seconds for the radiator and 60 seconds for the engine. Gd(s) is the load path: 1 % more engine load makes the coolant 0.57 K hotter, through the engine lag only. The coolant temperature is 90 °C minus the cooling effect plus the load effect. In MATLAB these are written with num, den, conv and tf, exactly like in our lab sheets.</a:t>
+              <a:t>Starting from the energy balance, heat in minus heat out, we linearise around the normal operating point: 90 °C, 30 % engine load and 25 °C outside air. Every number comes from published data. The engine and its coolant have a heat capacity of about 352 kJ per kelvin, from the Volvo D13 mass and coolant volume and textbook specific heats. At 30 % load the engine puts 45 kW into the coolant, so to hold 90 °C with 25 °C air the cooling must remove 45 kW over 65 K, which is 0.69 kW per kelvin. The time constant is heat capacity divided by that, 352 / 0.69 = 509 seconds. The radiator lag is its heat capacity divided by the coolant flow, about 4.7 seconds. The gains come the same way: 1 % load is 1.5 kW, divided by 0.69 gives 2.17 K. G(s) is the cooling path and Gd(s) the load path, written in MATLAB with num, den, conv and tf.</a:t>
             </a:r>
             <a:endParaRPr lang="en-US" dirty="0"/>
           </a:p>
@@ -1748,7 +1749,7 @@
           <a:p>
             <a:r>
               <a:rPr lang="en-US" dirty="0"/>
-              <a:t>A textbook PID needs three additions on a real system. First, split range: one PID output from 0 to 3 is shared across three actuators in order of energy cost: valve, then pump, then fan. In our simple model we do not model each actuator; we only keep the total command inside 0 to 3. In the load-step test the command goes from 0.8 to about 2.2, so the pump is fully on and the fan just starts. Second, anti-windup: when the output is at its limit, the integral stops adding up. In Simulink this is the clamping option of the PID block. Third, a 10-second low-pass filter on the derivative so sensor noise does not make the actuators jitter; in Simulink that is the filter coefficient N = 1/10 = 0.1. The gains were tuned by trial and error: Kp first, then Ki to remove the offset, then a small Kd to reduce the peak.</a:t>
+              <a:t>A textbook PID needs three additions on a real system. First, split range: one PID output from 0 to 3 is shared across three actuators in order of energy cost: valve, then pump, then fan. In our simple model we only keep the total command inside 0 to 3. In the load-step test the command goes from 0.83 to about 2.2, so the pump is fully on and the fan just starts. Second, anti-windup: when the output is at its limit, the integral stops adding up; in Simulink this is the clamping option of the PID block. Third, a 1-second low-pass filter on the derivative so sensor noise does not make the actuators jitter; in Simulink that is the filter coefficient N = 1. The gains were not guessed: they come from the SIMC tuning rule by Skogestad, 2003. For our plant it gives Kp = engine time constant divided by plant gain times the chosen closed-loop time of 20 seconds, the integral time is 4 times 20 = 80 seconds, and the derivative time equals the radiator lag. Converted to parallel form that is Kp 0.34, Ki 0.0041 and Kd 1.52.</a:t>
             </a:r>
             <a:endParaRPr lang="en-US" dirty="0"/>
           </a:p>
@@ -3036,7 +3037,7 @@
                           <a:ea typeface="Arial" pitchFamily="34" charset="-122"/>
                           <a:cs typeface="Arial" pitchFamily="34" charset="-120"/>
                         </a:rPr>
-                        <a:t>Plant parameters</a:t>
+                        <a:t>Physical data</a:t>
                       </a:r>
                       <a:endParaRPr lang="en-US" sz="1300" dirty="0">
                         <a:latin typeface="Arial" charset="0"/>
@@ -3104,7 +3105,7 @@
                           <a:ea typeface="Arial" pitchFamily="34" charset="-122"/>
                           <a:cs typeface="Arial" pitchFamily="34" charset="-120"/>
                         </a:rPr>
-                        <a:t>Set-point, time constants, gains and y0 in one place</a:t>
+                        <a:t>Engine, coolant and material data, plus stated assumptions</a:t>
                       </a:r>
                       <a:endParaRPr lang="en-US" sz="1300" dirty="0">
                         <a:latin typeface="Arial" charset="0"/>
@@ -3174,7 +3175,7 @@
                           <a:ea typeface="Arial" pitchFamily="34" charset="-122"/>
                           <a:cs typeface="Arial" pitchFamily="34" charset="-120"/>
                         </a:rPr>
-                        <a:t>PID gains</a:t>
+                        <a:t>Derived constants</a:t>
                       </a:r>
                       <a:endParaRPr lang="en-US" sz="1300" dirty="0">
                         <a:latin typeface="Arial" charset="0"/>
@@ -3242,7 +3243,7 @@
                           <a:ea typeface="Arial" pitchFamily="34" charset="-122"/>
                           <a:cs typeface="Arial" pitchFamily="34" charset="-120"/>
                         </a:rPr>
-                        <a:t>Kp, Ki, Kd and the 10 s derivative filter</a:t>
+                        <a:t>τ = C / H and gains K; PID gains from the SIMC rule</a:t>
                       </a:r>
                       <a:endParaRPr lang="en-US" sz="1300" dirty="0">
                         <a:latin typeface="Arial" charset="0"/>
@@ -4686,7 +4687,7 @@
                           <a:ea typeface="Arial" pitchFamily="34" charset="-122"/>
                           <a:cs typeface="Arial" pitchFamily="34" charset="-120"/>
                         </a:rPr>
-                        <a:t>P 0.3, I 0.006, D 2, N 0.1; limits −0.8 to 2.2; clamping</a:t>
+                        <a:t>P 0.344, I 0.0041, D 1.52, N 1; limits −0.83 to 2.17; clamping</a:t>
                       </a:r>
                       <a:endParaRPr lang="en-US" sz="1300" dirty="0">
                         <a:latin typeface="Arial" charset="0"/>
@@ -4824,7 +4825,7 @@
                           <a:ea typeface="Arial" pitchFamily="34" charset="-122"/>
                           <a:cs typeface="Arial" pitchFamily="34" charset="-120"/>
                         </a:rPr>
-                        <a:t>Cooling path: −20 / (600s² + 70s + 1)</a:t>
+                        <a:t>Cooling path: −78.2 / (2383s² + 513.8s + 1)</a:t>
                       </a:r>
                       <a:endParaRPr lang="en-US" sz="1300" dirty="0">
                         <a:latin typeface="Arial" charset="0"/>
@@ -4962,7 +4963,7 @@
                           <a:ea typeface="Arial" pitchFamily="34" charset="-122"/>
                           <a:cs typeface="Arial" pitchFamily="34" charset="-120"/>
                         </a:rPr>
-                        <a:t>Load +50 % at 600 s through 0.57 / (60s + 1)</a:t>
+                        <a:t>Load +50 % at 600 s through 2.17 / (509s + 1)</a:t>
                       </a:r>
                       <a:endParaRPr lang="en-US" sz="1300" dirty="0">
                         <a:latin typeface="Arial" charset="0"/>
@@ -5238,7 +5239,7 @@
                           <a:ea typeface="Arial" pitchFamily="34" charset="-122"/>
                           <a:cs typeface="Arial" pitchFamily="34" charset="-120"/>
                         </a:rPr>
-                        <a:t>Cooling command y = 0.8 + PID output</a:t>
+                        <a:t>Cooling command y = 0.83 + PID output</a:t>
                       </a:r>
                       <a:endParaRPr lang="en-US" sz="1300" dirty="0">
                         <a:latin typeface="Arial" charset="0"/>
@@ -5467,7 +5468,7 @@
                 <a:ea typeface="Arial" pitchFamily="34" charset="-122"/>
                 <a:cs typeface="Arial" pitchFamily="34" charset="-120"/>
               </a:rPr>
-              <a:t>Solver ode4, fixed step 1 s, 30-minute run · built by hand</a:t>
+              <a:t>Solver ode4, fixed step 0.1 s, 30-minute run · built by hand</a:t>
             </a:r>
             <a:endParaRPr lang="en-US" sz="1200" dirty="0"/>
           </a:p>
@@ -6114,7 +6115,7 @@
                           <a:ea typeface="Arial" pitchFamily="34" charset="-122"/>
                           <a:cs typeface="Arial" pitchFamily="34" charset="-120"/>
                         </a:rPr>
-                        <a:t>5.2 K</a:t>
+                        <a:t>3.9 K</a:t>
                       </a:r>
                       <a:endParaRPr lang="en-US" sz="1300" dirty="0">
                         <a:latin typeface="Arial" charset="0"/>
@@ -6182,7 +6183,7 @@
                           <a:ea typeface="Arial" pitchFamily="34" charset="-122"/>
                           <a:cs typeface="Arial" pitchFamily="34" charset="-120"/>
                         </a:rPr>
-                        <a:t>35 s</a:t>
+                        <a:t>27 s</a:t>
                       </a:r>
                       <a:endParaRPr lang="en-US" sz="1300" dirty="0">
                         <a:latin typeface="Arial" charset="0"/>
@@ -6250,7 +6251,7 @@
                           <a:ea typeface="Arial" pitchFamily="34" charset="-122"/>
                           <a:cs typeface="Arial" pitchFamily="34" charset="-120"/>
                         </a:rPr>
-                        <a:t>4.1 K</a:t>
+                        <a:t>3.9 K</a:t>
                       </a:r>
                       <a:endParaRPr lang="en-US" sz="1300" dirty="0">
                         <a:latin typeface="Arial" charset="0"/>
@@ -6388,7 +6389,7 @@
                           <a:ea typeface="Arial" pitchFamily="34" charset="-122"/>
                           <a:cs typeface="Arial" pitchFamily="34" charset="-120"/>
                         </a:rPr>
-                        <a:t>4.9 K</a:t>
+                        <a:t>3.3 K</a:t>
                       </a:r>
                       <a:endParaRPr lang="en-US" sz="1300" dirty="0">
                         <a:latin typeface="Arial" charset="0"/>
@@ -6456,7 +6457,7 @@
                           <a:ea typeface="Arial" pitchFamily="34" charset="-122"/>
                           <a:cs typeface="Arial" pitchFamily="34" charset="-120"/>
                         </a:rPr>
-                        <a:t>110 s</a:t>
+                        <a:t>173 s</a:t>
                       </a:r>
                       <a:endParaRPr lang="en-US" sz="1300" dirty="0">
                         <a:latin typeface="Arial" charset="0"/>
@@ -6662,7 +6663,7 @@
                           <a:ea typeface="Arial" pitchFamily="34" charset="-122"/>
                           <a:cs typeface="Arial" pitchFamily="34" charset="-120"/>
                         </a:rPr>
-                        <a:t>4.1 K</a:t>
+                        <a:t>3.0 K</a:t>
                       </a:r>
                       <a:endParaRPr lang="en-US" sz="1300" dirty="0">
                         <a:latin typeface="Arial" charset="0"/>
@@ -6730,7 +6731,7 @@
                           <a:ea typeface="Arial" pitchFamily="34" charset="-122"/>
                           <a:cs typeface="Arial" pitchFamily="34" charset="-120"/>
                         </a:rPr>
-                        <a:t>111 s</a:t>
+                        <a:t>175 s</a:t>
                       </a:r>
                       <a:endParaRPr lang="en-US" sz="1300" dirty="0">
                         <a:latin typeface="Arial" charset="0"/>
@@ -6911,7 +6912,7 @@
                 <a:ea typeface="Arial" pitchFamily="34" charset="-122"/>
                 <a:cs typeface="Arial" pitchFamily="34" charset="-120"/>
               </a:rPr>
-              <a:t>. Adding I brings it back to exactly 90 °C. Adding D cuts the peak by about 15 %.</a:t>
+              <a:t>. Adding I brings it back to exactly 90 °C. Adding D cuts the peak by about 7 %.</a:t>
             </a:r>
             <a:endParaRPr lang="en-US" sz="1400" dirty="0"/>
           </a:p>
@@ -7237,7 +7238,7 @@
                 <a:ea typeface="Arial" pitchFamily="34" charset="-122"/>
                 <a:cs typeface="Arial" pitchFamily="34" charset="-120"/>
               </a:rPr>
-              <a:t>PID reaches 95 °C with 7.5 % overshoot and settles in about 43 s.</a:t>
+              <a:t>PID reaches 95 °C with 10.7 % overshoot and settles in about 212 s.</a:t>
             </a:r>
             <a:endParaRPr lang="en-US" sz="1300" dirty="0"/>
           </a:p>
@@ -7325,7 +7326,7 @@
                 <a:ea typeface="Arial" pitchFamily="34" charset="-122"/>
                 <a:cs typeface="Arial" pitchFamily="34" charset="-120"/>
               </a:rPr>
-              <a:t>Stops at 94.3 °C, a 0.7 K offset. PI and PID remove it.</a:t>
+              <a:t>Stops at 94.8 °C, a 0.2 K offset. PI and PID remove it.</a:t>
             </a:r>
             <a:endParaRPr lang="en-US" sz="1300" dirty="0"/>
           </a:p>
@@ -7629,7 +7630,7 @@
                 <a:ea typeface="Arial" pitchFamily="34" charset="-122"/>
                 <a:cs typeface="Arial" pitchFamily="34" charset="-120"/>
               </a:rPr>
-              <a:t>PID holds 90 °C with zero offset. P only, like today's wax thermostat, stays 4 K too hot. D cuts the peak by about 15 %.</a:t>
+              <a:t>PID holds 90 °C with zero offset. P only, like today's wax thermostat, stays 4 K too hot. D cuts the peak by about 7 %.</a:t>
             </a:r>
             <a:endParaRPr lang="en-US" sz="1300" dirty="0"/>
           </a:p>
@@ -7767,7 +7768,7 @@
                 <a:ea typeface="Arial" pitchFamily="34" charset="-122"/>
                 <a:cs typeface="Arial" pitchFamily="34" charset="-120"/>
               </a:rPr>
-              <a:t>Linear model with one temperature: no oil, no separate valve, pump and fan. Parameters are typical values, not measured.</a:t>
+              <a:t>Linear model with one temperature: no oil, no separate valve, pump and fan. Some inputs are assumed (slide 15).</a:t>
             </a:r>
             <a:endParaRPr lang="en-US" sz="1300" dirty="0"/>
           </a:p>
@@ -8836,6 +8837,1312 @@
 </p:sld>
 </file>
 
+<file path=ppt/slides/slide20.xml><?xml version="1.0" encoding="utf-8"?>
+<p:sld xmlns:a="http://schemas.openxmlformats.org/drawingml/2006/main" xmlns:r="http://schemas.openxmlformats.org/officeDocument/2006/relationships" xmlns:p="http://schemas.openxmlformats.org/presentationml/2006/main">
+  <p:cSld name="Slide 10">
+    <p:bg>
+      <p:bgPr>
+        <a:solidFill>
+          <a:srgbClr val="F6F5F1"/>
+        </a:solidFill>
+      </p:bgPr>
+    </p:bg>
+    <p:spTree>
+      <p:nvGrpSpPr>
+        <p:cNvPr id="1" name=""/>
+        <p:cNvGrpSpPr/>
+        <p:nvPr/>
+      </p:nvGrpSpPr>
+      <p:grpSpPr>
+        <a:xfrm>
+          <a:off x="0" y="0"/>
+          <a:ext cx="0" cy="0"/>
+          <a:chOff x="0" y="0"/>
+          <a:chExt cx="0" cy="0"/>
+        </a:xfrm>
+      </p:grpSpPr>
+      <p:sp>
+        <p:nvSpPr>
+          <p:cNvPr id="2" name="Text 0"/>
+          <p:cNvSpPr/>
+          <p:nvPr/>
+        </p:nvSpPr>
+        <p:spPr>
+          <a:xfrm>
+            <a:off x="812800" y="812800"/>
+            <a:ext cx="10883392" cy="238753"/>
+          </a:xfrm>
+          <a:prstGeom prst="rect">
+            <a:avLst/>
+          </a:prstGeom>
+          <a:noFill/>
+          <a:ln/>
+        </p:spPr>
+        <p:txBody>
+          <a:bodyPr wrap="square" lIns="0" tIns="0" rIns="0" bIns="0" rtlCol="0" anchor="t">
+            <a:normAutofit/>
+          </a:bodyPr>
+          <a:lstStyle/>
+          <a:p>
+            <a:pPr algn="l" indent="0" marL="0">
+              <a:lnSpc>
+                <a:spcPts val="1680"/>
+              </a:lnSpc>
+              <a:buNone/>
+            </a:pPr>
+            <a:r>
+              <a:rPr lang="en-US" sz="1200" b="1" spc="150" kern="0" dirty="0">
+                <a:solidFill>
+                  <a:srgbClr val="B4501F"/>
+                </a:solidFill>
+                <a:latin typeface="Arial" pitchFamily="34" charset="0"/>
+                <a:ea typeface="Arial" pitchFamily="34" charset="-122"/>
+                <a:cs typeface="Arial" pitchFamily="34" charset="-120"/>
+              </a:rPr>
+              <a:t>DATA SOURCES</a:t>
+            </a:r>
+            <a:endParaRPr lang="en-US" sz="1200" dirty="0"/>
+          </a:p>
+        </p:txBody>
+      </p:sp>
+      <p:sp>
+        <p:nvSpPr>
+          <p:cNvPr id="3" name="Text 1"/>
+          <p:cNvSpPr/>
+          <p:nvPr>
+            <p:ph type="title"/>
+          </p:nvPr>
+        </p:nvSpPr>
+        <p:spPr>
+          <a:xfrm>
+            <a:off x="812800" y="1102358"/>
+            <a:ext cx="10883392" cy="472414"/>
+          </a:xfrm>
+          <a:prstGeom prst="rect">
+            <a:avLst/>
+          </a:prstGeom>
+          <a:noFill/>
+          <a:ln/>
+        </p:spPr>
+        <p:txBody>
+          <a:bodyPr wrap="square" lIns="0" tIns="0" rIns="0" bIns="0" rtlCol="0" anchor="t">
+            <a:normAutofit/>
+          </a:bodyPr>
+          <a:lstStyle/>
+          <a:p>
+            <a:pPr algn="l" indent="0" marL="0">
+              <a:lnSpc>
+                <a:spcPts val="3520"/>
+              </a:lnSpc>
+              <a:buNone/>
+            </a:pPr>
+            <a:r>
+              <a:rPr lang="en-US" sz="3200" b="1" i="0" dirty="0">
+                <a:solidFill>
+                  <a:srgbClr val="15233B"/>
+                </a:solidFill>
+                <a:latin typeface="Arial" pitchFamily="34" charset="0"/>
+                <a:ea typeface="Arial" pitchFamily="34" charset="-122"/>
+                <a:cs typeface="Arial" pitchFamily="34" charset="-120"/>
+              </a:rPr>
+              <a:t>Where the numbers come from</a:t>
+            </a:r>
+            <a:endParaRPr lang="en-US" sz="3200" dirty="0"/>
+          </a:p>
+        </p:txBody>
+      </p:sp>
+      <p:graphicFrame>
+        <p:nvGraphicFramePr>
+          <p:cNvPr id="4" name="Table 0"/>
+          <p:cNvGraphicFramePr>
+            <a:graphicFrameLocks noGrp="1"/>
+          </p:cNvGraphicFramePr>
+          <p:nvPr>
+            <p:extLst>
+              <p:ext uri="{D42A27DB-BD31-4B8C-83A1-F6EECF244321}">
+                <p14:modId xmlns:p14="http://schemas.microsoft.com/office/powerpoint/2010/main" val="1579011935"/>
+              </p:ext>
+            </p:extLst>
+          </p:nvPr>
+        </p:nvGraphicFramePr>
+        <p:xfrm>
+          <a:off x="825500" y="1816069"/>
+          <a:ext cx="10553700" cy="2874962"/>
+        </p:xfrm>
+        <a:graphic>
+          <a:graphicData uri="http://schemas.openxmlformats.org/drawingml/2006/table">
+            <a:tbl>
+              <a:tblPr/>
+              <a:tblGrid>
+                <a:gridCol w="3799332"/>
+                <a:gridCol w="6754368"/>
+              </a:tblGrid>
+              <a:tr h="359370">
+                <a:tc>
+                  <a:txBody>
+                    <a:bodyPr/>
+                    <a:lstStyle/>
+                    <a:p>
+                      <a:pPr indent="0" marL="0">
+                        <a:lnSpc>
+                          <a:spcPts val="1820"/>
+                        </a:lnSpc>
+                        <a:buNone/>
+                      </a:pPr>
+                      <a:r>
+                        <a:rPr lang="en-US" sz="1300" b="1" dirty="0">
+                          <a:solidFill>
+                            <a:srgbClr val="15233B"/>
+                          </a:solidFill>
+                          <a:latin typeface="Arial" pitchFamily="34" charset="0"/>
+                          <a:ea typeface="Arial" pitchFamily="34" charset="-122"/>
+                          <a:cs typeface="Arial" pitchFamily="34" charset="-120"/>
+                        </a:rPr>
+                        <a:t>Value</a:t>
+                      </a:r>
+                      <a:endParaRPr lang="en-US" sz="1300" dirty="0">
+                        <a:latin typeface="Arial" charset="0"/>
+                        <a:ea typeface="Arial" charset="0"/>
+                        <a:cs typeface="Arial" charset="0"/>
+                      </a:endParaRPr>
+                    </a:p>
+                  </a:txBody>
+                  <a:tcPr marL="57785" marR="57785" marT="57785" marB="57785" anchor="t">
+                    <a:lnL w="12700" cap="flat" cmpd="sng" algn="ctr">
+                      <a:solidFill>
+                        <a:srgbClr val="C4C4C0"/>
+                      </a:solidFill>
+                      <a:prstDash val="solid"/>
+                      <a:round/>
+                      <a:headEnd type="none" w="med" len="med"/>
+                      <a:tailEnd type="none" w="med" len="med"/>
+                    </a:lnL>
+                    <a:lnR w="12700" cap="flat" cmpd="sng" algn="ctr">
+                      <a:solidFill>
+                        <a:srgbClr val="B6B5B2"/>
+                      </a:solidFill>
+                      <a:prstDash val="solid"/>
+                      <a:round/>
+                      <a:headEnd type="none" w="med" len="med"/>
+                      <a:tailEnd type="none" w="med" len="med"/>
+                    </a:lnR>
+                    <a:lnT w="12700" cap="flat" cmpd="sng" algn="ctr">
+                      <a:solidFill>
+                        <a:srgbClr val="C4C4C0"/>
+                      </a:solidFill>
+                      <a:prstDash val="solid"/>
+                      <a:round/>
+                      <a:headEnd type="none" w="med" len="med"/>
+                      <a:tailEnd type="none" w="med" len="med"/>
+                    </a:lnT>
+                    <a:lnB w="12700" cap="flat" cmpd="sng" algn="ctr">
+                      <a:solidFill>
+                        <a:srgbClr val="B6B5B2"/>
+                      </a:solidFill>
+                      <a:prstDash val="solid"/>
+                      <a:round/>
+                      <a:headEnd type="none" w="med" len="med"/>
+                      <a:tailEnd type="none" w="med" len="med"/>
+                    </a:lnB>
+                    <a:solidFill>
+                      <a:srgbClr val="E4E3DF"/>
+                    </a:solidFill>
+                  </a:tcPr>
+                </a:tc>
+                <a:tc>
+                  <a:txBody>
+                    <a:bodyPr/>
+                    <a:lstStyle/>
+                    <a:p>
+                      <a:pPr indent="0" marL="0">
+                        <a:lnSpc>
+                          <a:spcPts val="1820"/>
+                        </a:lnSpc>
+                        <a:buNone/>
+                      </a:pPr>
+                      <a:r>
+                        <a:rPr lang="en-US" sz="1300" b="1" dirty="0">
+                          <a:solidFill>
+                            <a:srgbClr val="15233B"/>
+                          </a:solidFill>
+                          <a:latin typeface="Arial" pitchFamily="34" charset="0"/>
+                          <a:ea typeface="Arial" pitchFamily="34" charset="-122"/>
+                          <a:cs typeface="Arial" pitchFamily="34" charset="-120"/>
+                        </a:rPr>
+                        <a:t>Source</a:t>
+                      </a:r>
+                      <a:endParaRPr lang="en-US" sz="1300" dirty="0">
+                        <a:latin typeface="Arial" charset="0"/>
+                        <a:ea typeface="Arial" charset="0"/>
+                        <a:cs typeface="Arial" charset="0"/>
+                      </a:endParaRPr>
+                    </a:p>
+                  </a:txBody>
+                  <a:tcPr marL="57785" marR="57785" marT="57785" marB="57785" anchor="t">
+                    <a:lnL w="12700" cap="flat" cmpd="sng" algn="ctr">
+                      <a:solidFill>
+                        <a:srgbClr val="B6B5B2"/>
+                      </a:solidFill>
+                      <a:prstDash val="solid"/>
+                      <a:round/>
+                      <a:headEnd type="none" w="med" len="med"/>
+                      <a:tailEnd type="none" w="med" len="med"/>
+                    </a:lnL>
+                    <a:lnR w="12700" cap="flat" cmpd="sng" algn="ctr">
+                      <a:solidFill>
+                        <a:srgbClr val="B6B5B2"/>
+                      </a:solidFill>
+                      <a:prstDash val="solid"/>
+                      <a:round/>
+                      <a:headEnd type="none" w="med" len="med"/>
+                      <a:tailEnd type="none" w="med" len="med"/>
+                    </a:lnR>
+                    <a:lnT w="12700" cap="flat" cmpd="sng" algn="ctr">
+                      <a:solidFill>
+                        <a:srgbClr val="C4C4C0"/>
+                      </a:solidFill>
+                      <a:prstDash val="solid"/>
+                      <a:round/>
+                      <a:headEnd type="none" w="med" len="med"/>
+                      <a:tailEnd type="none" w="med" len="med"/>
+                    </a:lnT>
+                    <a:lnB w="12700" cap="flat" cmpd="sng" algn="ctr">
+                      <a:solidFill>
+                        <a:srgbClr val="B6B5B2"/>
+                      </a:solidFill>
+                      <a:prstDash val="solid"/>
+                      <a:round/>
+                      <a:headEnd type="none" w="med" len="med"/>
+                      <a:tailEnd type="none" w="med" len="med"/>
+                    </a:lnB>
+                    <a:solidFill>
+                      <a:srgbClr val="E4E3DF"/>
+                    </a:solidFill>
+                  </a:tcPr>
+                </a:tc>
+              </a:tr>
+              <a:tr h="359370">
+                <a:tc>
+                  <a:txBody>
+                    <a:bodyPr/>
+                    <a:lstStyle/>
+                    <a:p>
+                      <a:pPr indent="0" marL="0">
+                        <a:lnSpc>
+                          <a:spcPts val="1820"/>
+                        </a:lnSpc>
+                        <a:buNone/>
+                      </a:pPr>
+                      <a:r>
+                        <a:rPr lang="en-US" sz="1300" dirty="0">
+                          <a:solidFill>
+                            <a:srgbClr val="15233B"/>
+                          </a:solidFill>
+                          <a:latin typeface="Arial" pitchFamily="34" charset="0"/>
+                          <a:ea typeface="Arial" pitchFamily="34" charset="-122"/>
+                          <a:cs typeface="Arial" pitchFamily="34" charset="-120"/>
+                        </a:rPr>
+                        <a:t>338 kW, 1121 kg, 38 L coolant</a:t>
+                      </a:r>
+                      <a:endParaRPr lang="en-US" sz="1300" dirty="0">
+                        <a:latin typeface="Arial" charset="0"/>
+                        <a:ea typeface="Arial" charset="0"/>
+                        <a:cs typeface="Arial" charset="0"/>
+                      </a:endParaRPr>
+                    </a:p>
+                  </a:txBody>
+                  <a:tcPr marL="57785" marR="57785" marT="57785" marB="57785" anchor="t">
+                    <a:lnL w="12700" cap="flat" cmpd="sng" algn="ctr">
+                      <a:solidFill>
+                        <a:srgbClr val="C4C4C0"/>
+                      </a:solidFill>
+                      <a:prstDash val="solid"/>
+                      <a:round/>
+                      <a:headEnd type="none" w="med" len="med"/>
+                      <a:tailEnd type="none" w="med" len="med"/>
+                    </a:lnL>
+                    <a:lnR w="12700" cap="flat" cmpd="sng" algn="ctr">
+                      <a:solidFill>
+                        <a:srgbClr val="C4C4C0"/>
+                      </a:solidFill>
+                      <a:prstDash val="solid"/>
+                      <a:round/>
+                      <a:headEnd type="none" w="med" len="med"/>
+                      <a:tailEnd type="none" w="med" len="med"/>
+                    </a:lnR>
+                    <a:lnT w="12700" cap="flat" cmpd="sng" algn="ctr">
+                      <a:solidFill>
+                        <a:srgbClr val="B6B5B2"/>
+                      </a:solidFill>
+                      <a:prstDash val="solid"/>
+                      <a:round/>
+                      <a:headEnd type="none" w="med" len="med"/>
+                      <a:tailEnd type="none" w="med" len="med"/>
+                    </a:lnT>
+                    <a:lnB w="12700" cap="flat" cmpd="sng" algn="ctr">
+                      <a:solidFill>
+                        <a:srgbClr val="C4C4C0"/>
+                      </a:solidFill>
+                      <a:prstDash val="solid"/>
+                      <a:round/>
+                      <a:headEnd type="none" w="med" len="med"/>
+                      <a:tailEnd type="none" w="med" len="med"/>
+                    </a:lnB>
+                  </a:tcPr>
+                </a:tc>
+                <a:tc>
+                  <a:txBody>
+                    <a:bodyPr/>
+                    <a:lstStyle/>
+                    <a:p>
+                      <a:pPr indent="0" marL="0">
+                        <a:lnSpc>
+                          <a:spcPts val="1820"/>
+                        </a:lnSpc>
+                        <a:buNone/>
+                      </a:pPr>
+                      <a:r>
+                        <a:rPr lang="en-US" sz="1300" dirty="0">
+                          <a:solidFill>
+                            <a:srgbClr val="15233B"/>
+                          </a:solidFill>
+                          <a:latin typeface="Arial" pitchFamily="34" charset="0"/>
+                          <a:ea typeface="Arial" pitchFamily="34" charset="-122"/>
+                          <a:cs typeface="Arial" pitchFamily="34" charset="-120"/>
+                        </a:rPr>
+                        <a:t>Volvo D13C460 engine fact sheet</a:t>
+                      </a:r>
+                      <a:endParaRPr lang="en-US" sz="1300" dirty="0">
+                        <a:latin typeface="Arial" charset="0"/>
+                        <a:ea typeface="Arial" charset="0"/>
+                        <a:cs typeface="Arial" charset="0"/>
+                      </a:endParaRPr>
+                    </a:p>
+                  </a:txBody>
+                  <a:tcPr marL="57785" marR="57785" marT="57785" marB="57785" anchor="t">
+                    <a:lnL w="12700" cap="flat" cmpd="sng" algn="ctr">
+                      <a:solidFill>
+                        <a:srgbClr val="C4C4C0"/>
+                      </a:solidFill>
+                      <a:prstDash val="solid"/>
+                      <a:round/>
+                      <a:headEnd type="none" w="med" len="med"/>
+                      <a:tailEnd type="none" w="med" len="med"/>
+                    </a:lnL>
+                    <a:lnR w="12700" cap="flat" cmpd="sng" algn="ctr">
+                      <a:solidFill>
+                        <a:srgbClr val="C4C4C0"/>
+                      </a:solidFill>
+                      <a:prstDash val="solid"/>
+                      <a:round/>
+                      <a:headEnd type="none" w="med" len="med"/>
+                      <a:tailEnd type="none" w="med" len="med"/>
+                    </a:lnR>
+                    <a:lnT w="12700" cap="flat" cmpd="sng" algn="ctr">
+                      <a:solidFill>
+                        <a:srgbClr val="B6B5B2"/>
+                      </a:solidFill>
+                      <a:prstDash val="solid"/>
+                      <a:round/>
+                      <a:headEnd type="none" w="med" len="med"/>
+                      <a:tailEnd type="none" w="med" len="med"/>
+                    </a:lnT>
+                    <a:lnB w="12700" cap="flat" cmpd="sng" algn="ctr">
+                      <a:solidFill>
+                        <a:srgbClr val="C4C4C0"/>
+                      </a:solidFill>
+                      <a:prstDash val="solid"/>
+                      <a:round/>
+                      <a:headEnd type="none" w="med" len="med"/>
+                      <a:tailEnd type="none" w="med" len="med"/>
+                    </a:lnB>
+                  </a:tcPr>
+                </a:tc>
+              </a:tr>
+              <a:tr h="359370">
+                <a:tc>
+                  <a:txBody>
+                    <a:bodyPr/>
+                    <a:lstStyle/>
+                    <a:p>
+                      <a:pPr indent="0" marL="0">
+                        <a:lnSpc>
+                          <a:spcPts val="1820"/>
+                        </a:lnSpc>
+                        <a:buNone/>
+                      </a:pPr>
+                      <a:r>
+                        <a:rPr lang="en-US" sz="1300" dirty="0">
+                          <a:solidFill>
+                            <a:srgbClr val="15233B"/>
+                          </a:solidFill>
+                          <a:latin typeface="Arial" pitchFamily="34" charset="0"/>
+                          <a:ea typeface="Arial" pitchFamily="34" charset="-122"/>
+                          <a:cs typeface="Arial" pitchFamily="34" charset="-120"/>
+                        </a:rPr>
+                        <a:t>150 kW to coolant (105 °C, 45 °C air)</a:t>
+                      </a:r>
+                      <a:endParaRPr lang="en-US" sz="1300" dirty="0">
+                        <a:latin typeface="Arial" charset="0"/>
+                        <a:ea typeface="Arial" charset="0"/>
+                        <a:cs typeface="Arial" charset="0"/>
+                      </a:endParaRPr>
+                    </a:p>
+                  </a:txBody>
+                  <a:tcPr marL="57785" marR="57785" marT="57785" marB="57785" anchor="t">
+                    <a:lnL w="12700" cap="flat" cmpd="sng" algn="ctr">
+                      <a:solidFill>
+                        <a:srgbClr val="C4C4C0"/>
+                      </a:solidFill>
+                      <a:prstDash val="solid"/>
+                      <a:round/>
+                      <a:headEnd type="none" w="med" len="med"/>
+                      <a:tailEnd type="none" w="med" len="med"/>
+                    </a:lnL>
+                    <a:lnR w="12700" cap="flat" cmpd="sng" algn="ctr">
+                      <a:solidFill>
+                        <a:srgbClr val="C4C4C0"/>
+                      </a:solidFill>
+                      <a:prstDash val="solid"/>
+                      <a:round/>
+                      <a:headEnd type="none" w="med" len="med"/>
+                      <a:tailEnd type="none" w="med" len="med"/>
+                    </a:lnR>
+                    <a:lnT w="12700" cap="flat" cmpd="sng" algn="ctr">
+                      <a:solidFill>
+                        <a:srgbClr val="C4C4C0"/>
+                      </a:solidFill>
+                      <a:prstDash val="solid"/>
+                      <a:round/>
+                      <a:headEnd type="none" w="med" len="med"/>
+                      <a:tailEnd type="none" w="med" len="med"/>
+                    </a:lnT>
+                    <a:lnB w="12700" cap="flat" cmpd="sng" algn="ctr">
+                      <a:solidFill>
+                        <a:srgbClr val="C4C4C0"/>
+                      </a:solidFill>
+                      <a:prstDash val="solid"/>
+                      <a:round/>
+                      <a:headEnd type="none" w="med" len="med"/>
+                      <a:tailEnd type="none" w="med" len="med"/>
+                    </a:lnB>
+                  </a:tcPr>
+                </a:tc>
+                <a:tc>
+                  <a:txBody>
+                    <a:bodyPr/>
+                    <a:lstStyle/>
+                    <a:p>
+                      <a:pPr indent="0" marL="0">
+                        <a:lnSpc>
+                          <a:spcPts val="1820"/>
+                        </a:lnSpc>
+                        <a:buNone/>
+                      </a:pPr>
+                      <a:r>
+                        <a:rPr lang="en-US" sz="1300" dirty="0">
+                          <a:solidFill>
+                            <a:srgbClr val="15233B"/>
+                          </a:solidFill>
+                          <a:latin typeface="Arial" pitchFamily="34" charset="0"/>
+                          <a:ea typeface="Arial" pitchFamily="34" charset="-122"/>
+                          <a:cs typeface="Arial" pitchFamily="34" charset="-120"/>
+                        </a:rPr>
+                        <a:t>Worsztynowicz (2017), heavy-duty cooling modules</a:t>
+                      </a:r>
+                      <a:endParaRPr lang="en-US" sz="1300" dirty="0">
+                        <a:latin typeface="Arial" charset="0"/>
+                        <a:ea typeface="Arial" charset="0"/>
+                        <a:cs typeface="Arial" charset="0"/>
+                      </a:endParaRPr>
+                    </a:p>
+                  </a:txBody>
+                  <a:tcPr marL="57785" marR="57785" marT="57785" marB="57785" anchor="t">
+                    <a:lnL w="12700" cap="flat" cmpd="sng" algn="ctr">
+                      <a:solidFill>
+                        <a:srgbClr val="C4C4C0"/>
+                      </a:solidFill>
+                      <a:prstDash val="solid"/>
+                      <a:round/>
+                      <a:headEnd type="none" w="med" len="med"/>
+                      <a:tailEnd type="none" w="med" len="med"/>
+                    </a:lnL>
+                    <a:lnR w="12700" cap="flat" cmpd="sng" algn="ctr">
+                      <a:solidFill>
+                        <a:srgbClr val="C4C4C0"/>
+                      </a:solidFill>
+                      <a:prstDash val="solid"/>
+                      <a:round/>
+                      <a:headEnd type="none" w="med" len="med"/>
+                      <a:tailEnd type="none" w="med" len="med"/>
+                    </a:lnR>
+                    <a:lnT w="12700" cap="flat" cmpd="sng" algn="ctr">
+                      <a:solidFill>
+                        <a:srgbClr val="C4C4C0"/>
+                      </a:solidFill>
+                      <a:prstDash val="solid"/>
+                      <a:round/>
+                      <a:headEnd type="none" w="med" len="med"/>
+                      <a:tailEnd type="none" w="med" len="med"/>
+                    </a:lnT>
+                    <a:lnB w="12700" cap="flat" cmpd="sng" algn="ctr">
+                      <a:solidFill>
+                        <a:srgbClr val="C4C4C0"/>
+                      </a:solidFill>
+                      <a:prstDash val="solid"/>
+                      <a:round/>
+                      <a:headEnd type="none" w="med" len="med"/>
+                      <a:tailEnd type="none" w="med" len="med"/>
+                    </a:lnB>
+                  </a:tcPr>
+                </a:tc>
+              </a:tr>
+              <a:tr h="359370">
+                <a:tc>
+                  <a:txBody>
+                    <a:bodyPr/>
+                    <a:lstStyle/>
+                    <a:p>
+                      <a:pPr indent="0" marL="0">
+                        <a:lnSpc>
+                          <a:spcPts val="1820"/>
+                        </a:lnSpc>
+                        <a:buNone/>
+                      </a:pPr>
+                      <a:r>
+                        <a:rPr lang="en-US" sz="1300" dirty="0">
+                          <a:solidFill>
+                            <a:srgbClr val="15233B"/>
+                          </a:solidFill>
+                          <a:latin typeface="Arial" pitchFamily="34" charset="0"/>
+                          <a:ea typeface="Arial" pitchFamily="34" charset="-122"/>
+                          <a:cs typeface="Arial" pitchFamily="34" charset="-120"/>
+                        </a:rPr>
+                        <a:t>c_p: coolant 3.5, iron 0.46, Al 0.91 kJ/kg·K</a:t>
+                      </a:r>
+                      <a:endParaRPr lang="en-US" sz="1300" dirty="0">
+                        <a:latin typeface="Arial" charset="0"/>
+                        <a:ea typeface="Arial" charset="0"/>
+                        <a:cs typeface="Arial" charset="0"/>
+                      </a:endParaRPr>
+                    </a:p>
+                  </a:txBody>
+                  <a:tcPr marL="57785" marR="57785" marT="57785" marB="57785" anchor="t">
+                    <a:lnL w="12700" cap="flat" cmpd="sng" algn="ctr">
+                      <a:solidFill>
+                        <a:srgbClr val="C4C4C0"/>
+                      </a:solidFill>
+                      <a:prstDash val="solid"/>
+                      <a:round/>
+                      <a:headEnd type="none" w="med" len="med"/>
+                      <a:tailEnd type="none" w="med" len="med"/>
+                    </a:lnL>
+                    <a:lnR w="12700" cap="flat" cmpd="sng" algn="ctr">
+                      <a:solidFill>
+                        <a:srgbClr val="C4C4C0"/>
+                      </a:solidFill>
+                      <a:prstDash val="solid"/>
+                      <a:round/>
+                      <a:headEnd type="none" w="med" len="med"/>
+                      <a:tailEnd type="none" w="med" len="med"/>
+                    </a:lnR>
+                    <a:lnT w="12700" cap="flat" cmpd="sng" algn="ctr">
+                      <a:solidFill>
+                        <a:srgbClr val="C4C4C0"/>
+                      </a:solidFill>
+                      <a:prstDash val="solid"/>
+                      <a:round/>
+                      <a:headEnd type="none" w="med" len="med"/>
+                      <a:tailEnd type="none" w="med" len="med"/>
+                    </a:lnT>
+                    <a:lnB w="12700" cap="flat" cmpd="sng" algn="ctr">
+                      <a:solidFill>
+                        <a:srgbClr val="C4C4C0"/>
+                      </a:solidFill>
+                      <a:prstDash val="solid"/>
+                      <a:round/>
+                      <a:headEnd type="none" w="med" len="med"/>
+                      <a:tailEnd type="none" w="med" len="med"/>
+                    </a:lnB>
+                  </a:tcPr>
+                </a:tc>
+                <a:tc>
+                  <a:txBody>
+                    <a:bodyPr/>
+                    <a:lstStyle/>
+                    <a:p>
+                      <a:pPr indent="0" marL="0">
+                        <a:lnSpc>
+                          <a:spcPts val="1820"/>
+                        </a:lnSpc>
+                        <a:buNone/>
+                      </a:pPr>
+                      <a:r>
+                        <a:rPr lang="en-US" sz="1300" dirty="0">
+                          <a:solidFill>
+                            <a:srgbClr val="15233B"/>
+                          </a:solidFill>
+                          <a:latin typeface="Arial" pitchFamily="34" charset="0"/>
+                          <a:ea typeface="Arial" pitchFamily="34" charset="-122"/>
+                          <a:cs typeface="Arial" pitchFamily="34" charset="-120"/>
+                        </a:rPr>
+                        <a:t>Engineering ToolBox property tables</a:t>
+                      </a:r>
+                      <a:endParaRPr lang="en-US" sz="1300" dirty="0">
+                        <a:latin typeface="Arial" charset="0"/>
+                        <a:ea typeface="Arial" charset="0"/>
+                        <a:cs typeface="Arial" charset="0"/>
+                      </a:endParaRPr>
+                    </a:p>
+                  </a:txBody>
+                  <a:tcPr marL="57785" marR="57785" marT="57785" marB="57785" anchor="t">
+                    <a:lnL w="12700" cap="flat" cmpd="sng" algn="ctr">
+                      <a:solidFill>
+                        <a:srgbClr val="C4C4C0"/>
+                      </a:solidFill>
+                      <a:prstDash val="solid"/>
+                      <a:round/>
+                      <a:headEnd type="none" w="med" len="med"/>
+                      <a:tailEnd type="none" w="med" len="med"/>
+                    </a:lnL>
+                    <a:lnR w="12700" cap="flat" cmpd="sng" algn="ctr">
+                      <a:solidFill>
+                        <a:srgbClr val="C4C4C0"/>
+                      </a:solidFill>
+                      <a:prstDash val="solid"/>
+                      <a:round/>
+                      <a:headEnd type="none" w="med" len="med"/>
+                      <a:tailEnd type="none" w="med" len="med"/>
+                    </a:lnR>
+                    <a:lnT w="12700" cap="flat" cmpd="sng" algn="ctr">
+                      <a:solidFill>
+                        <a:srgbClr val="C4C4C0"/>
+                      </a:solidFill>
+                      <a:prstDash val="solid"/>
+                      <a:round/>
+                      <a:headEnd type="none" w="med" len="med"/>
+                      <a:tailEnd type="none" w="med" len="med"/>
+                    </a:lnT>
+                    <a:lnB w="12700" cap="flat" cmpd="sng" algn="ctr">
+                      <a:solidFill>
+                        <a:srgbClr val="C4C4C0"/>
+                      </a:solidFill>
+                      <a:prstDash val="solid"/>
+                      <a:round/>
+                      <a:headEnd type="none" w="med" len="med"/>
+                      <a:tailEnd type="none" w="med" len="med"/>
+                    </a:lnB>
+                  </a:tcPr>
+                </a:tc>
+              </a:tr>
+              <a:tr h="359370">
+                <a:tc>
+                  <a:txBody>
+                    <a:bodyPr/>
+                    <a:lstStyle/>
+                    <a:p>
+                      <a:pPr indent="0" marL="0">
+                        <a:lnSpc>
+                          <a:spcPts val="1820"/>
+                        </a:lnSpc>
+                        <a:buNone/>
+                      </a:pPr>
+                      <a:r>
+                        <a:rPr lang="en-US" sz="1300" dirty="0">
+                          <a:solidFill>
+                            <a:srgbClr val="15233B"/>
+                          </a:solidFill>
+                          <a:latin typeface="Arial" pitchFamily="34" charset="0"/>
+                          <a:ea typeface="Arial" pitchFamily="34" charset="-122"/>
+                          <a:cs typeface="Arial" pitchFamily="34" charset="-120"/>
+                        </a:rPr>
+                        <a:t>150 kW ≈ 18 % of fuel energy</a:t>
+                      </a:r>
+                      <a:endParaRPr lang="en-US" sz="1300" dirty="0">
+                        <a:latin typeface="Arial" charset="0"/>
+                        <a:ea typeface="Arial" charset="0"/>
+                        <a:cs typeface="Arial" charset="0"/>
+                      </a:endParaRPr>
+                    </a:p>
+                  </a:txBody>
+                  <a:tcPr marL="57785" marR="57785" marT="57785" marB="57785" anchor="t">
+                    <a:lnL w="12700" cap="flat" cmpd="sng" algn="ctr">
+                      <a:solidFill>
+                        <a:srgbClr val="C4C4C0"/>
+                      </a:solidFill>
+                      <a:prstDash val="solid"/>
+                      <a:round/>
+                      <a:headEnd type="none" w="med" len="med"/>
+                      <a:tailEnd type="none" w="med" len="med"/>
+                    </a:lnL>
+                    <a:lnR w="12700" cap="flat" cmpd="sng" algn="ctr">
+                      <a:solidFill>
+                        <a:srgbClr val="C4C4C0"/>
+                      </a:solidFill>
+                      <a:prstDash val="solid"/>
+                      <a:round/>
+                      <a:headEnd type="none" w="med" len="med"/>
+                      <a:tailEnd type="none" w="med" len="med"/>
+                    </a:lnR>
+                    <a:lnT w="12700" cap="flat" cmpd="sng" algn="ctr">
+                      <a:solidFill>
+                        <a:srgbClr val="C4C4C0"/>
+                      </a:solidFill>
+                      <a:prstDash val="solid"/>
+                      <a:round/>
+                      <a:headEnd type="none" w="med" len="med"/>
+                      <a:tailEnd type="none" w="med" len="med"/>
+                    </a:lnT>
+                    <a:lnB w="12700" cap="flat" cmpd="sng" algn="ctr">
+                      <a:solidFill>
+                        <a:srgbClr val="C4C4C0"/>
+                      </a:solidFill>
+                      <a:prstDash val="solid"/>
+                      <a:round/>
+                      <a:headEnd type="none" w="med" len="med"/>
+                      <a:tailEnd type="none" w="med" len="med"/>
+                    </a:lnB>
+                  </a:tcPr>
+                </a:tc>
+                <a:tc>
+                  <a:txBody>
+                    <a:bodyPr/>
+                    <a:lstStyle/>
+                    <a:p>
+                      <a:pPr indent="0" marL="0">
+                        <a:lnSpc>
+                          <a:spcPts val="1820"/>
+                        </a:lnSpc>
+                        <a:buNone/>
+                      </a:pPr>
+                      <a:r>
+                        <a:rPr lang="en-US" sz="1300" dirty="0">
+                          <a:solidFill>
+                            <a:srgbClr val="15233B"/>
+                          </a:solidFill>
+                          <a:latin typeface="Arial" pitchFamily="34" charset="0"/>
+                          <a:ea typeface="Arial" pitchFamily="34" charset="-122"/>
+                          <a:cs typeface="Arial" pitchFamily="34" charset="-120"/>
+                        </a:rPr>
+                        <a:t>Heywood, ICE Fundamentals: 17–26 % (cross-check)</a:t>
+                      </a:r>
+                      <a:endParaRPr lang="en-US" sz="1300" dirty="0">
+                        <a:latin typeface="Arial" charset="0"/>
+                        <a:ea typeface="Arial" charset="0"/>
+                        <a:cs typeface="Arial" charset="0"/>
+                      </a:endParaRPr>
+                    </a:p>
+                  </a:txBody>
+                  <a:tcPr marL="57785" marR="57785" marT="57785" marB="57785" anchor="t">
+                    <a:lnL w="12700" cap="flat" cmpd="sng" algn="ctr">
+                      <a:solidFill>
+                        <a:srgbClr val="C4C4C0"/>
+                      </a:solidFill>
+                      <a:prstDash val="solid"/>
+                      <a:round/>
+                      <a:headEnd type="none" w="med" len="med"/>
+                      <a:tailEnd type="none" w="med" len="med"/>
+                    </a:lnL>
+                    <a:lnR w="12700" cap="flat" cmpd="sng" algn="ctr">
+                      <a:solidFill>
+                        <a:srgbClr val="C4C4C0"/>
+                      </a:solidFill>
+                      <a:prstDash val="solid"/>
+                      <a:round/>
+                      <a:headEnd type="none" w="med" len="med"/>
+                      <a:tailEnd type="none" w="med" len="med"/>
+                    </a:lnR>
+                    <a:lnT w="12700" cap="flat" cmpd="sng" algn="ctr">
+                      <a:solidFill>
+                        <a:srgbClr val="C4C4C0"/>
+                      </a:solidFill>
+                      <a:prstDash val="solid"/>
+                      <a:round/>
+                      <a:headEnd type="none" w="med" len="med"/>
+                      <a:tailEnd type="none" w="med" len="med"/>
+                    </a:lnT>
+                    <a:lnB w="12700" cap="flat" cmpd="sng" algn="ctr">
+                      <a:solidFill>
+                        <a:srgbClr val="C4C4C0"/>
+                      </a:solidFill>
+                      <a:prstDash val="solid"/>
+                      <a:round/>
+                      <a:headEnd type="none" w="med" len="med"/>
+                      <a:tailEnd type="none" w="med" len="med"/>
+                    </a:lnB>
+                  </a:tcPr>
+                </a:tc>
+              </a:tr>
+              <a:tr h="359370">
+                <a:tc>
+                  <a:txBody>
+                    <a:bodyPr/>
+                    <a:lstStyle/>
+                    <a:p>
+                      <a:pPr indent="0" marL="0">
+                        <a:lnSpc>
+                          <a:spcPts val="1820"/>
+                        </a:lnSpc>
+                        <a:buNone/>
+                      </a:pPr>
+                      <a:r>
+                        <a:rPr lang="en-US" sz="1300" dirty="0">
+                          <a:solidFill>
+                            <a:srgbClr val="15233B"/>
+                          </a:solidFill>
+                          <a:latin typeface="Arial" pitchFamily="34" charset="0"/>
+                          <a:ea typeface="Arial" pitchFamily="34" charset="-122"/>
+                          <a:cs typeface="Arial" pitchFamily="34" charset="-120"/>
+                        </a:rPr>
+                        <a:t>Kp, Ki, Kd</a:t>
+                      </a:r>
+                      <a:endParaRPr lang="en-US" sz="1300" dirty="0">
+                        <a:latin typeface="Arial" charset="0"/>
+                        <a:ea typeface="Arial" charset="0"/>
+                        <a:cs typeface="Arial" charset="0"/>
+                      </a:endParaRPr>
+                    </a:p>
+                  </a:txBody>
+                  <a:tcPr marL="57785" marR="57785" marT="57785" marB="57785" anchor="t">
+                    <a:lnL w="12700" cap="flat" cmpd="sng" algn="ctr">
+                      <a:solidFill>
+                        <a:srgbClr val="C4C4C0"/>
+                      </a:solidFill>
+                      <a:prstDash val="solid"/>
+                      <a:round/>
+                      <a:headEnd type="none" w="med" len="med"/>
+                      <a:tailEnd type="none" w="med" len="med"/>
+                    </a:lnL>
+                    <a:lnR w="12700" cap="flat" cmpd="sng" algn="ctr">
+                      <a:solidFill>
+                        <a:srgbClr val="C4C4C0"/>
+                      </a:solidFill>
+                      <a:prstDash val="solid"/>
+                      <a:round/>
+                      <a:headEnd type="none" w="med" len="med"/>
+                      <a:tailEnd type="none" w="med" len="med"/>
+                    </a:lnR>
+                    <a:lnT w="12700" cap="flat" cmpd="sng" algn="ctr">
+                      <a:solidFill>
+                        <a:srgbClr val="C4C4C0"/>
+                      </a:solidFill>
+                      <a:prstDash val="solid"/>
+                      <a:round/>
+                      <a:headEnd type="none" w="med" len="med"/>
+                      <a:tailEnd type="none" w="med" len="med"/>
+                    </a:lnT>
+                    <a:lnB w="12700" cap="flat" cmpd="sng" algn="ctr">
+                      <a:solidFill>
+                        <a:srgbClr val="C4C4C0"/>
+                      </a:solidFill>
+                      <a:prstDash val="solid"/>
+                      <a:round/>
+                      <a:headEnd type="none" w="med" len="med"/>
+                      <a:tailEnd type="none" w="med" len="med"/>
+                    </a:lnB>
+                  </a:tcPr>
+                </a:tc>
+                <a:tc>
+                  <a:txBody>
+                    <a:bodyPr/>
+                    <a:lstStyle/>
+                    <a:p>
+                      <a:pPr indent="0" marL="0">
+                        <a:lnSpc>
+                          <a:spcPts val="1820"/>
+                        </a:lnSpc>
+                        <a:buNone/>
+                      </a:pPr>
+                      <a:r>
+                        <a:rPr lang="en-US" sz="1300" dirty="0">
+                          <a:solidFill>
+                            <a:srgbClr val="15233B"/>
+                          </a:solidFill>
+                          <a:latin typeface="Arial" pitchFamily="34" charset="0"/>
+                          <a:ea typeface="Arial" pitchFamily="34" charset="-122"/>
+                          <a:cs typeface="Arial" pitchFamily="34" charset="-120"/>
+                        </a:rPr>
+                        <a:t>SIMC tuning rule, Skogestad (2003)</a:t>
+                      </a:r>
+                      <a:endParaRPr lang="en-US" sz="1300" dirty="0">
+                        <a:latin typeface="Arial" charset="0"/>
+                        <a:ea typeface="Arial" charset="0"/>
+                        <a:cs typeface="Arial" charset="0"/>
+                      </a:endParaRPr>
+                    </a:p>
+                  </a:txBody>
+                  <a:tcPr marL="57785" marR="57785" marT="57785" marB="57785" anchor="t">
+                    <a:lnL w="12700" cap="flat" cmpd="sng" algn="ctr">
+                      <a:solidFill>
+                        <a:srgbClr val="C4C4C0"/>
+                      </a:solidFill>
+                      <a:prstDash val="solid"/>
+                      <a:round/>
+                      <a:headEnd type="none" w="med" len="med"/>
+                      <a:tailEnd type="none" w="med" len="med"/>
+                    </a:lnL>
+                    <a:lnR w="12700" cap="flat" cmpd="sng" algn="ctr">
+                      <a:solidFill>
+                        <a:srgbClr val="C4C4C0"/>
+                      </a:solidFill>
+                      <a:prstDash val="solid"/>
+                      <a:round/>
+                      <a:headEnd type="none" w="med" len="med"/>
+                      <a:tailEnd type="none" w="med" len="med"/>
+                    </a:lnR>
+                    <a:lnT w="12700" cap="flat" cmpd="sng" algn="ctr">
+                      <a:solidFill>
+                        <a:srgbClr val="C4C4C0"/>
+                      </a:solidFill>
+                      <a:prstDash val="solid"/>
+                      <a:round/>
+                      <a:headEnd type="none" w="med" len="med"/>
+                      <a:tailEnd type="none" w="med" len="med"/>
+                    </a:lnT>
+                    <a:lnB w="12700" cap="flat" cmpd="sng" algn="ctr">
+                      <a:solidFill>
+                        <a:srgbClr val="C4C4C0"/>
+                      </a:solidFill>
+                      <a:prstDash val="solid"/>
+                      <a:round/>
+                      <a:headEnd type="none" w="med" len="med"/>
+                      <a:tailEnd type="none" w="med" len="med"/>
+                    </a:lnB>
+                  </a:tcPr>
+                </a:tc>
+              </a:tr>
+              <a:tr h="359370">
+                <a:tc>
+                  <a:txBody>
+                    <a:bodyPr/>
+                    <a:lstStyle/>
+                    <a:p>
+                      <a:pPr indent="0" marL="0">
+                        <a:lnSpc>
+                          <a:spcPts val="1820"/>
+                        </a:lnSpc>
+                        <a:buNone/>
+                      </a:pPr>
+                      <a:r>
+                        <a:rPr lang="en-US" sz="1300" dirty="0">
+                          <a:solidFill>
+                            <a:srgbClr val="15233B"/>
+                          </a:solidFill>
+                          <a:latin typeface="Arial" pitchFamily="34" charset="0"/>
+                          <a:ea typeface="Arial" pitchFamily="34" charset="-122"/>
+                          <a:cs typeface="Arial" pitchFamily="34" charset="-120"/>
+                        </a:rPr>
+                        <a:t>50 % mass, 26 L, 30 kg, 250 L/min, 25 °C</a:t>
+                      </a:r>
+                      <a:endParaRPr lang="en-US" sz="1300" dirty="0">
+                        <a:latin typeface="Arial" charset="0"/>
+                        <a:ea typeface="Arial" charset="0"/>
+                        <a:cs typeface="Arial" charset="0"/>
+                      </a:endParaRPr>
+                    </a:p>
+                  </a:txBody>
+                  <a:tcPr marL="57785" marR="57785" marT="57785" marB="57785" anchor="t">
+                    <a:lnL w="12700" cap="flat" cmpd="sng" algn="ctr">
+                      <a:solidFill>
+                        <a:srgbClr val="C4C4C0"/>
+                      </a:solidFill>
+                      <a:prstDash val="solid"/>
+                      <a:round/>
+                      <a:headEnd type="none" w="med" len="med"/>
+                      <a:tailEnd type="none" w="med" len="med"/>
+                    </a:lnL>
+                    <a:lnR w="12700" cap="flat" cmpd="sng" algn="ctr">
+                      <a:solidFill>
+                        <a:srgbClr val="C4C4C0"/>
+                      </a:solidFill>
+                      <a:prstDash val="solid"/>
+                      <a:round/>
+                      <a:headEnd type="none" w="med" len="med"/>
+                      <a:tailEnd type="none" w="med" len="med"/>
+                    </a:lnR>
+                    <a:lnT w="12700" cap="flat" cmpd="sng" algn="ctr">
+                      <a:solidFill>
+                        <a:srgbClr val="C4C4C0"/>
+                      </a:solidFill>
+                      <a:prstDash val="solid"/>
+                      <a:round/>
+                      <a:headEnd type="none" w="med" len="med"/>
+                      <a:tailEnd type="none" w="med" len="med"/>
+                    </a:lnT>
+                    <a:lnB w="12700" cap="flat" cmpd="sng" algn="ctr">
+                      <a:solidFill>
+                        <a:srgbClr val="C4C4C0"/>
+                      </a:solidFill>
+                      <a:prstDash val="solid"/>
+                      <a:round/>
+                      <a:headEnd type="none" w="med" len="med"/>
+                      <a:tailEnd type="none" w="med" len="med"/>
+                    </a:lnB>
+                  </a:tcPr>
+                </a:tc>
+                <a:tc>
+                  <a:txBody>
+                    <a:bodyPr/>
+                    <a:lstStyle/>
+                    <a:p>
+                      <a:pPr indent="0" marL="0">
+                        <a:lnSpc>
+                          <a:spcPts val="1820"/>
+                        </a:lnSpc>
+                        <a:buNone/>
+                      </a:pPr>
+                      <a:r>
+                        <a:rPr lang="en-US" sz="1300" dirty="0">
+                          <a:solidFill>
+                            <a:srgbClr val="15233B"/>
+                          </a:solidFill>
+                          <a:latin typeface="Arial" pitchFamily="34" charset="0"/>
+                          <a:ea typeface="Arial" pitchFamily="34" charset="-122"/>
+                          <a:cs typeface="Arial" pitchFamily="34" charset="-120"/>
+                        </a:rPr>
+                        <a:t>Our assumptions</a:t>
+                      </a:r>
+                      <a:endParaRPr lang="en-US" sz="1300" dirty="0">
+                        <a:latin typeface="Arial" charset="0"/>
+                        <a:ea typeface="Arial" charset="0"/>
+                        <a:cs typeface="Arial" charset="0"/>
+                      </a:endParaRPr>
+                    </a:p>
+                  </a:txBody>
+                  <a:tcPr marL="57785" marR="57785" marT="57785" marB="57785" anchor="t">
+                    <a:lnL w="12700" cap="flat" cmpd="sng" algn="ctr">
+                      <a:solidFill>
+                        <a:srgbClr val="C4C4C0"/>
+                      </a:solidFill>
+                      <a:prstDash val="solid"/>
+                      <a:round/>
+                      <a:headEnd type="none" w="med" len="med"/>
+                      <a:tailEnd type="none" w="med" len="med"/>
+                    </a:lnL>
+                    <a:lnR w="12700" cap="flat" cmpd="sng" algn="ctr">
+                      <a:solidFill>
+                        <a:srgbClr val="C4C4C0"/>
+                      </a:solidFill>
+                      <a:prstDash val="solid"/>
+                      <a:round/>
+                      <a:headEnd type="none" w="med" len="med"/>
+                      <a:tailEnd type="none" w="med" len="med"/>
+                    </a:lnR>
+                    <a:lnT w="12700" cap="flat" cmpd="sng" algn="ctr">
+                      <a:solidFill>
+                        <a:srgbClr val="C4C4C0"/>
+                      </a:solidFill>
+                      <a:prstDash val="solid"/>
+                      <a:round/>
+                      <a:headEnd type="none" w="med" len="med"/>
+                      <a:tailEnd type="none" w="med" len="med"/>
+                    </a:lnT>
+                    <a:lnB w="12700" cap="flat" cmpd="sng" algn="ctr">
+                      <a:solidFill>
+                        <a:srgbClr val="C4C4C0"/>
+                      </a:solidFill>
+                      <a:prstDash val="solid"/>
+                      <a:round/>
+                      <a:headEnd type="none" w="med" len="med"/>
+                      <a:tailEnd type="none" w="med" len="med"/>
+                    </a:lnB>
+                  </a:tcPr>
+                </a:tc>
+              </a:tr>
+              <a:tr h="359370">
+                <a:tc>
+                  <a:txBody>
+                    <a:bodyPr/>
+                    <a:lstStyle/>
+                    <a:p>
+                      <a:pPr indent="0" marL="0">
+                        <a:lnSpc>
+                          <a:spcPts val="1820"/>
+                        </a:lnSpc>
+                        <a:buNone/>
+                      </a:pPr>
+                      <a:r>
+                        <a:rPr lang="en-US" sz="1300" dirty="0">
+                          <a:solidFill>
+                            <a:srgbClr val="15233B"/>
+                          </a:solidFill>
+                          <a:latin typeface="Arial" pitchFamily="34" charset="0"/>
+                          <a:ea typeface="Arial" pitchFamily="34" charset="-122"/>
+                          <a:cs typeface="Arial" pitchFamily="34" charset="-120"/>
+                        </a:rPr>
+                        <a:t>τc 509 s, τr 4.7 s, K 78.2 and 2.17</a:t>
+                      </a:r>
+                      <a:endParaRPr lang="en-US" sz="1300" dirty="0">
+                        <a:latin typeface="Arial" charset="0"/>
+                        <a:ea typeface="Arial" charset="0"/>
+                        <a:cs typeface="Arial" charset="0"/>
+                      </a:endParaRPr>
+                    </a:p>
+                  </a:txBody>
+                  <a:tcPr marL="57785" marR="57785" marT="57785" marB="57785" anchor="t">
+                    <a:lnL w="12700" cap="flat" cmpd="sng" algn="ctr">
+                      <a:solidFill>
+                        <a:srgbClr val="C4C4C0"/>
+                      </a:solidFill>
+                      <a:prstDash val="solid"/>
+                      <a:round/>
+                      <a:headEnd type="none" w="med" len="med"/>
+                      <a:tailEnd type="none" w="med" len="med"/>
+                    </a:lnL>
+                    <a:lnR w="12700" cap="flat" cmpd="sng" algn="ctr">
+                      <a:solidFill>
+                        <a:srgbClr val="C4C4C0"/>
+                      </a:solidFill>
+                      <a:prstDash val="solid"/>
+                      <a:round/>
+                      <a:headEnd type="none" w="med" len="med"/>
+                      <a:tailEnd type="none" w="med" len="med"/>
+                    </a:lnR>
+                    <a:lnT w="12700" cap="flat" cmpd="sng" algn="ctr">
+                      <a:solidFill>
+                        <a:srgbClr val="C4C4C0"/>
+                      </a:solidFill>
+                      <a:prstDash val="solid"/>
+                      <a:round/>
+                      <a:headEnd type="none" w="med" len="med"/>
+                      <a:tailEnd type="none" w="med" len="med"/>
+                    </a:lnT>
+                    <a:lnB w="12700" cap="flat" cmpd="sng" algn="ctr">
+                      <a:solidFill>
+                        <a:srgbClr val="C4C4C0"/>
+                      </a:solidFill>
+                      <a:prstDash val="solid"/>
+                      <a:round/>
+                      <a:headEnd type="none" w="med" len="med"/>
+                      <a:tailEnd type="none" w="med" len="med"/>
+                    </a:lnB>
+                  </a:tcPr>
+                </a:tc>
+                <a:tc>
+                  <a:txBody>
+                    <a:bodyPr/>
+                    <a:lstStyle/>
+                    <a:p>
+                      <a:pPr indent="0" marL="0">
+                        <a:lnSpc>
+                          <a:spcPts val="1820"/>
+                        </a:lnSpc>
+                        <a:buNone/>
+                      </a:pPr>
+                      <a:r>
+                        <a:rPr lang="en-US" sz="1300" dirty="0">
+                          <a:solidFill>
+                            <a:srgbClr val="15233B"/>
+                          </a:solidFill>
+                          <a:latin typeface="Arial" pitchFamily="34" charset="0"/>
+                          <a:ea typeface="Arial" pitchFamily="34" charset="-122"/>
+                          <a:cs typeface="Arial" pitchFamily="34" charset="-120"/>
+                        </a:rPr>
+                        <a:t>Calculated in pid_truck_cooling.m</a:t>
+                      </a:r>
+                      <a:endParaRPr lang="en-US" sz="1300" dirty="0">
+                        <a:latin typeface="Arial" charset="0"/>
+                        <a:ea typeface="Arial" charset="0"/>
+                        <a:cs typeface="Arial" charset="0"/>
+                      </a:endParaRPr>
+                    </a:p>
+                  </a:txBody>
+                  <a:tcPr marL="57785" marR="57785" marT="57785" marB="57785" anchor="t">
+                    <a:lnL w="12700" cap="flat" cmpd="sng" algn="ctr">
+                      <a:solidFill>
+                        <a:srgbClr val="C4C4C0"/>
+                      </a:solidFill>
+                      <a:prstDash val="solid"/>
+                      <a:round/>
+                      <a:headEnd type="none" w="med" len="med"/>
+                      <a:tailEnd type="none" w="med" len="med"/>
+                    </a:lnL>
+                    <a:lnR w="12700" cap="flat" cmpd="sng" algn="ctr">
+                      <a:solidFill>
+                        <a:srgbClr val="C4C4C0"/>
+                      </a:solidFill>
+                      <a:prstDash val="solid"/>
+                      <a:round/>
+                      <a:headEnd type="none" w="med" len="med"/>
+                      <a:tailEnd type="none" w="med" len="med"/>
+                    </a:lnR>
+                    <a:lnT w="12700" cap="flat" cmpd="sng" algn="ctr">
+                      <a:solidFill>
+                        <a:srgbClr val="C4C4C0"/>
+                      </a:solidFill>
+                      <a:prstDash val="solid"/>
+                      <a:round/>
+                      <a:headEnd type="none" w="med" len="med"/>
+                      <a:tailEnd type="none" w="med" len="med"/>
+                    </a:lnT>
+                    <a:lnB w="12700" cap="flat" cmpd="sng" algn="ctr">
+                      <a:solidFill>
+                        <a:srgbClr val="C4C4C0"/>
+                      </a:solidFill>
+                      <a:prstDash val="solid"/>
+                      <a:round/>
+                      <a:headEnd type="none" w="med" len="med"/>
+                      <a:tailEnd type="none" w="med" len="med"/>
+                    </a:lnB>
+                  </a:tcPr>
+                </a:tc>
+              </a:tr>
+            </a:tbl>
+          </a:graphicData>
+        </a:graphic>
+      </p:graphicFrame>
+      <p:sp>
+        <p:nvSpPr>
+          <p:cNvPr id="5" name="Text 2"/>
+          <p:cNvSpPr/>
+          <p:nvPr/>
+        </p:nvSpPr>
+        <p:spPr>
+          <a:xfrm>
+            <a:off x="812800" y="6238249"/>
+            <a:ext cx="10883392" cy="238753"/>
+          </a:xfrm>
+          <a:prstGeom prst="rect">
+            <a:avLst/>
+          </a:prstGeom>
+          <a:noFill/>
+          <a:ln/>
+        </p:spPr>
+        <p:txBody>
+          <a:bodyPr wrap="square" lIns="0" tIns="0" rIns="0" bIns="0" rtlCol="0" anchor="t">
+            <a:normAutofit/>
+          </a:bodyPr>
+          <a:lstStyle/>
+          <a:p>
+            <a:pPr algn="l" indent="0" marL="0">
+              <a:lnSpc>
+                <a:spcPts val="1680"/>
+              </a:lnSpc>
+              <a:buNone/>
+            </a:pPr>
+            <a:r>
+              <a:rPr lang="en-US" sz="1200" dirty="0">
+                <a:solidFill>
+                  <a:srgbClr val="6B7486"/>
+                </a:solidFill>
+                <a:latin typeface="Arial" pitchFamily="34" charset="0"/>
+                <a:ea typeface="Arial" pitchFamily="34" charset="-122"/>
+                <a:cs typeface="Arial" pitchFamily="34" charset="-120"/>
+              </a:rPr>
+              <a:t>PID Thermal Control for Heavy-Duty Trucks · 15</a:t>
+            </a:r>
+            <a:endParaRPr lang="en-US" sz="1200" dirty="0"/>
+          </a:p>
+        </p:txBody>
+      </p:sp>
+    </p:spTree>
+  </p:cSld>
+  <p:clrMapOvr>
+    <a:masterClrMapping/>
+  </p:clrMapOvr>
+</p:sld>
+</file>
+
 <file path=ppt/slides/slide3.xml><?xml version="1.0" encoding="utf-8"?>
 <p:sld xmlns:a="http://schemas.openxmlformats.org/drawingml/2006/main" xmlns:r="http://schemas.openxmlformats.org/officeDocument/2006/relationships" xmlns:p="http://schemas.openxmlformats.org/presentationml/2006/main">
   <p:cSld name="Slide 3">
@@ -12037,7 +13344,7 @@
                 <a:ea typeface="Arial" pitchFamily="34" charset="-122"/>
                 <a:cs typeface="Arial" pitchFamily="34" charset="-120"/>
               </a:rPr>
-              <a:t>Not a separate state. Modelled as a 10 s lag between the cooling command and the engine.</a:t>
+              <a:t>Not a separate state. Modelled as a 4.7 s lag between the cooling command and the engine.</a:t>
             </a:r>
             <a:endParaRPr lang="en-US" sz="1300" dirty="0"/>
           </a:p>
@@ -12262,7 +13569,7 @@
                 <a:ea typeface="Arial" pitchFamily="34" charset="-122"/>
                 <a:cs typeface="Arial" pitchFamily="34" charset="-120"/>
               </a:rPr>
-              <a:t>. The engine block adds a 60 s lag. In the code the only output is </a:t>
+              <a:t>. The engine block adds a 509 s lag. In the code the only output is </a:t>
             </a:r>
             <a:r>
               <a:rPr lang="en-US" sz="1400" dirty="0">
@@ -12521,7 +13828,7 @@
                 <a:ea typeface="Courier New" pitchFamily="49" charset="-122"/>
                 <a:cs typeface="Courier New" pitchFamily="49" charset="-120"/>
               </a:rPr>
-              <a:t>G(s)  = 20 / ((60s + 1)(10s + 1))</a:t>
+              <a:t>G(s)  = 78.2 / ((509s + 1)(4.7s + 1))</a:t>
             </a:r>
             <a:endParaRPr lang="en-US" sz="1500" dirty="0"/>
           </a:p>
@@ -12565,7 +13872,7 @@
                 <a:ea typeface="Arial" pitchFamily="34" charset="-122"/>
                 <a:cs typeface="Arial" pitchFamily="34" charset="-120"/>
               </a:rPr>
-              <a:t>Cooling path: one more unit of cooling command lowers T_c by 20 K, through the radiator and engine lags</a:t>
+              <a:t>Cooling path: one more unit of cooling command lowers T_c by 78 K, through the radiator and engine lags</a:t>
             </a:r>
             <a:endParaRPr lang="en-US" sz="1300" dirty="0"/>
           </a:p>
@@ -12636,7 +13943,7 @@
                 <a:ea typeface="Courier New" pitchFamily="49" charset="-122"/>
                 <a:cs typeface="Courier New" pitchFamily="49" charset="-120"/>
               </a:rPr>
-              <a:t>Gd(s) = 0.57 / (60s + 1)</a:t>
+              <a:t>Gd(s) = 2.17 / (509s + 1)</a:t>
             </a:r>
             <a:endParaRPr lang="en-US" sz="1500" dirty="0"/>
           </a:p>
@@ -12680,7 +13987,7 @@
                 <a:ea typeface="Arial" pitchFamily="34" charset="-122"/>
                 <a:cs typeface="Arial" pitchFamily="34" charset="-120"/>
               </a:rPr>
-              <a:t>Load path: 1 % more engine load raises T_c by 0.57 K, through the engine lag only</a:t>
+              <a:t>Load path: 1 % more engine load raises T_c by 2.17 K, through the engine lag only</a:t>
             </a:r>
             <a:endParaRPr lang="en-US" sz="1300" dirty="0"/>
           </a:p>
@@ -12795,7 +14102,7 @@
                 <a:ea typeface="Arial" pitchFamily="34" charset="-122"/>
                 <a:cs typeface="Arial" pitchFamily="34" charset="-120"/>
               </a:rPr>
-              <a:t>Linearised around 90 °C and 30 % load, where the cooling command is y0 = 0.8</a:t>
+              <a:t>Linearised around 90 °C, 30 % load and 25 °C air, where the cooling command is y0 = 0.83</a:t>
             </a:r>
             <a:endParaRPr lang="en-US" sz="1300" dirty="0"/>
           </a:p>
@@ -12839,7 +14146,7 @@
                 <a:ea typeface="Arial" pitchFamily="34" charset="-122"/>
                 <a:cs typeface="Arial" pitchFamily="34" charset="-120"/>
               </a:rPr>
-              <a:t>Δy = change in cooling command (scale 0–3) · ΔL = change in engine load [%] · gains and time constants are typical values</a:t>
+              <a:t>τ = heat capacity ÷ heat removal rate · K = heat input ÷ heat removal rate · all inputs on slide 15</a:t>
             </a:r>
             <a:endParaRPr lang="en-US" sz="1300" dirty="0"/>
           </a:p>
@@ -14625,7 +15932,7 @@
                 <a:ea typeface="Arial" pitchFamily="34" charset="-122"/>
                 <a:cs typeface="Arial" pitchFamily="34" charset="-120"/>
               </a:rPr>
-              <a:t>A 10 s low-pass filter on the D term, so sensor noise is not amplified.</a:t>
+              <a:t>A 1 s low-pass filter on the D term, so sensor noise is not amplified.</a:t>
             </a:r>
             <a:endParaRPr lang="en-US" sz="1300" dirty="0"/>
           </a:p>
@@ -14669,7 +15976,7 @@
                 <a:ea typeface="Arial" pitchFamily="34" charset="-122"/>
                 <a:cs typeface="Arial" pitchFamily="34" charset="-120"/>
               </a:rPr>
-              <a:t>Tuned gains</a:t>
+              <a:t>SIMC gains</a:t>
             </a:r>
             <a:endParaRPr lang="en-US" sz="1400" dirty="0"/>
           </a:p>
@@ -14717,7 +16024,7 @@
                 <a:ea typeface="Arial" pitchFamily="34" charset="-122"/>
                 <a:cs typeface="Arial" pitchFamily="34" charset="-120"/>
               </a:rPr>
-              <a:t>Kp = 0.3</a:t>
+              <a:t>Kp = 0.34</a:t>
             </a:r>
             <a:endParaRPr lang="en-US" sz="1400" dirty="0"/>
           </a:p>
@@ -14765,7 +16072,7 @@
                 <a:ea typeface="Arial" pitchFamily="34" charset="-122"/>
                 <a:cs typeface="Arial" pitchFamily="34" charset="-120"/>
               </a:rPr>
-              <a:t>Ki = 0.006</a:t>
+              <a:t>Ki = 0.0041</a:t>
             </a:r>
             <a:endParaRPr lang="en-US" sz="1400" dirty="0"/>
           </a:p>
@@ -14813,7 +16120,7 @@
                 <a:ea typeface="Arial" pitchFamily="34" charset="-122"/>
                 <a:cs typeface="Arial" pitchFamily="34" charset="-120"/>
               </a:rPr>
-              <a:t>Kd = 2.0</a:t>
+              <a:t>Kd = 1.52</a:t>
             </a:r>
             <a:endParaRPr lang="en-US" sz="1400" dirty="0"/>
           </a:p>
@@ -14861,7 +16168,7 @@
                 <a:ea typeface="Arial" pitchFamily="34" charset="-122"/>
                 <a:cs typeface="Arial" pitchFamily="34" charset="-120"/>
               </a:rPr>
-              <a:t>N = 0.1</a:t>
+              <a:t>N = 1</a:t>
             </a:r>
             <a:endParaRPr lang="en-US" sz="1400" dirty="0"/>
           </a:p>

</xml_diff>

<commit_message>
Update deck for the simplified assumed plant and SIMC gains; references slide
Co-Authored-By: Claude Opus 5.5 <noreply@anthropic.com>
Claude-Session: https://claude.ai/code/session_01KYcVruEhgF1vnL4e2wj7fD
</commit_message>
<xml_diff>
--- a/PID_Thermal_Control_for_Heavy-Duty_Trucks_v2.pptx
+++ b/PID_Thermal_Control_for_Heavy-Duty_Trucks_v2.pptx
@@ -605,7 +605,7 @@
           <a:p>
             <a:r>
               <a:rPr lang="en-US" dirty="0"/>
-              <a:t>All the MATLAB code is in one file, pid_truck_cooling.m, split into sections. The first section lists the physical data with its source, and the assumptions we had to make. The next section calculates the time constants and gains from that data, and then the PID gains with the SIMC rule, so no number is typed in by hand. Then the plant transfer functions are defined with num, den and tf, and the three controllers P, PI and PID. feedback() closes the loop, and pole() prints the closed-loop poles: all of them are in the left half of the s-plane, so all three loops are stable. Experiment 1 is a set-point step analysed with step() and stepinfo(). Experiment 2 is a load step, where we find the settling time by walking backwards from the end of the response, the same method as in the time-domain lab.</a:t>
+              <a:t>All the MATLAB code is in one file, pid_truck_cooling.m, split into sections. The parameters and gains are at the top, so every number is in one place. Then the plant transfer functions are defined with num, den and tf, and the three controllers P, PI and PID. feedback() closes the loop, and pole() prints the closed-loop poles: all of them are in the left half of the s-plane, so all three loops are stable. Experiment 1 is a set-point step analysed with step() and stepinfo(). Experiment 2 is a load step, where we find the settling time by walking backwards from the end of the response, the same method as in the time-domain lab.</a:t>
             </a:r>
             <a:endParaRPr lang="en-US" dirty="0"/>
           </a:p>
@@ -693,7 +693,7 @@
           <a:p>
             <a:r>
               <a:rPr lang="en-US" dirty="0"/>
-              <a:t>We built the same loop by hand in Simulink. The Step block gives the set-point, 90 °C, stepping to 95 °C at 1200 seconds. The Sum block subtracts the set-point from the coolant temperature to get the error. The PID Controller block has the same gains as the MATLAB code, a filter coefficient of 1, output limits and clamping anti-windup. The limits are minus 0.83 and 2.17 because the block outputs the change from the normal command of 0.83, so the real command stays between 0 and 3. The cooling transfer function has a minus sign because more cooling lowers the temperature. A second Step adds 50 % engine load at 600 seconds through Gd(s). The plant output is 90 plus the two effects, and it is fed back to the error block. The Scope shows the temperature and the cooling command. [Add a screenshot of the model and the Scope here.]</a:t>
+              <a:t>We built the same loop by hand in Simulink. The Step block gives the set-point, 90 °C, stepping to 95 °C at 1200 seconds. The Sum block subtracts the set-point from the coolant temperature to get the error. The PID Controller block has the same SIMC gains as the MATLAB code, Simulink's default filter coefficient of 100, output limits and clamping anti-windup. The limits are minus 0.8 and 2.2 because the block outputs the change from the normal command of 0.8, so the real command stays between 0 and 3. The cooling transfer function has a minus sign because more cooling lowers the temperature. A second Step adds 50 % engine load at 600 seconds through Gd(s). The plant output is 90 plus the two effects, and it is fed back to the error block. The Scope shows the temperature and the cooling command. [Add a screenshot of the model and the Scope here.]</a:t>
             </a:r>
             <a:endParaRPr lang="en-US" dirty="0"/>
           </a:p>
@@ -781,7 +781,7 @@
           <a:p>
             <a:r>
               <a:rPr lang="en-US" dirty="0"/>
-              <a:t>Second test, the one that matters most for a truck. At time zero the engine load jumps from 30 to 80 percent, as if the truck hits a hill. That adds 75 kW of heat to the coolant. P only settles about 3.9 degrees too hot and stays there: that is the steady-state offset, exactly as theory predicts, and it is also why today's wax thermostat, which is a mechanical P controller, never reaches its target. Adding the integral term brings the temperature back to exactly 90 °C in about three minutes. Adding the derivative term lowers the peak from 3.3 to 3.0 K. Settling time here is the time to stay within ±0.5 K. The benefit of D is small because thermal systems are slow and smooth, which is why many industrial temperature loops use PI only. During this test the PID raises the cooling command from 0.83 to about 2.2, still below the limit of 3.</a:t>
+              <a:t>Second test, the one that matters most for a truck. At time zero the engine load jumps from 30 to 80 percent, as if the truck hits a hill. P only settles about 3.5 degrees too hot and stays there: that is the steady-state offset, exactly as the final value theorem predicts, 50 × 0.6 / (1 + 0.375 × 20) = 3.5 K. It is also why today's wax thermostat, which is a mechanical P controller, never reaches its target. Adding the integral term brings the temperature back to exactly 90 °C in about 100 seconds. Adding the derivative term cuts the peak from 4.6 to 3.3 K, about 28 % lower. Settling time here is the time to stay within ±0.5 K. During this test the PID raises the cooling command from 0.8 to about 2.3, still below the limit of 3.</a:t>
             </a:r>
             <a:endParaRPr lang="en-US" dirty="0"/>
           </a:p>
@@ -869,7 +869,7 @@
           <a:p>
             <a:r>
               <a:rPr lang="en-US" dirty="0"/>
-              <a:t>First test: we change the target from 90 to 95 °C and compare P only, PI and PID, using step() and stepinfo() in MATLAB. P only never quite reaches 95: it stops at about 94.8 °C, a small steady-state offset of 0.2 K, because it needs an error to produce any output. The offset is small here because the plant gain is large. PI removes the offset with 12.6 % overshoot. The full PID removes the offset and lowers the overshoot to 10.7 %, settling within 2 % in about 212 seconds. The closed-loop poles printed by pole() all have negative real parts, so all three loops are stable.</a:t>
+              <a:t>First test: we change the target from 90 to 95 °C and compare P only, PI and PID, using step() and stepinfo() in MATLAB. P only never reaches 95: it stops at about 94.4 °C, a steady-state offset of 0.6 K, because it needs an error to produce any output. PI removes the offset but overshoots by 24 %. The full PID removes the offset and cuts the overshoot to only 3.3 %, settling within 2 % in about 78 seconds. The closed-loop poles printed by pole() all have negative real parts, so all three loops are stable.</a:t>
             </a:r>
             <a:endParaRPr lang="en-US" dirty="0"/>
           </a:p>
@@ -957,7 +957,7 @@
           <a:p>
             <a:r>
               <a:rPr lang="en-US" dirty="0"/>
-              <a:t>To conclude: the PID holds the engine at 90 °C with no steady-state offset. A P-only controller, which is how today's wax thermostat behaves, stays about 4 degrees too hot after a load step, and adding D cuts the temperature peak by about 7 %. The limitations: our model is linear and keeps only the coolant temperature, so it has no oil temperature and does not model the valve, pump and fan separately. Most inputs come from published data, but a few are assumptions, listed on the next slide. The next steps are adding the radiator and oil temperatures, validating the model against real engine data, and then trying a predictive controller, MPC, which uses the road ahead to plan cooling.</a:t>
+              <a:t>To conclude: the PID holds the engine at 90 °C with no steady-state offset. A P-only controller, which is how today's wax thermostat behaves, stays about 3.5 degrees too hot after a load step, and adding D cuts the temperature peak by about 28 %. The limitations: our model is linear and keeps only the coolant temperature, so it has no oil temperature and does not model the valve, pump and fan separately. The plant values are assumed example values, not measured; the PID gains come from a published tuning rule. The next steps are measuring the plant on a real engine, adding the radiator and oil temperatures, and then trying a predictive controller, MPC, which uses the road ahead to plan cooling.</a:t>
             </a:r>
             <a:endParaRPr lang="en-US" dirty="0"/>
           </a:p>
@@ -1045,7 +1045,7 @@
           <a:p>
             <a:r>
               <a:rPr lang="en-US" dirty="0"/>
-              <a:t>Likely questions. Where do the numbers come from? The engine data is from the Volvo D13 fact sheet, the heat rejection from a heavy-duty cooling paper, the material properties from standard tables, and the PID gains from the SIMC rule; the few assumptions are listed on slide 15. Why is D so small? Thermal systems are slow and smooth, so D adds little, which is why many temperature loops use PI. Why only one temperature? A simple linear model is enough to show what P, I and D each do; the full model is our next step. Is the model validated? Not against real engine data yet. Why e = T_c minus T_ref? Our actuators remove heat, so hotter must give a positive output. Why does a P controller leave an offset? It needs a non-zero error to produce a non-zero output; the integral removes it.</a:t>
+              <a:t>Likely questions. Where do the numbers come from? The plant values are assumed example values for a first-order thermal model; the PID gains are calculated from them with Skogestad's SIMC rule, so they are not guessed. Why is D useful here? It acts on how fast the temperature is rising, so it reacts early and cuts the peak by 28 %. Why only one temperature? A simple linear model is enough to show what P, I and D each do. Is the model validated? No, the next step is to measure it on a real engine. Why e = T_c minus T_ref? Our actuators remove heat, so hotter must give a positive output. Why does a P controller leave an offset? It needs a non-zero error to produce a non-zero output; the integral removes it.</a:t>
             </a:r>
             <a:endParaRPr lang="en-US" dirty="0"/>
           </a:p>
@@ -1485,7 +1485,7 @@
           <a:p>
             <a:r>
               <a:rPr lang="en-US" dirty="0"/>
-              <a:t>A real cooling system has three temperatures: the engine coolant T_c, the radiator coolant T_r and the oil T_o. To keep the model simple we only keep T_c, the one we control. The radiator becomes a short lag of 4.7 seconds: that is roughly the time the coolant spends inside the radiator. The engine block is a large mass of iron and coolant, so it gives a long lag of about 509 seconds, roughly 8.5 minutes. The oil is left out because it changes slowly and does not change how we design the PID.</a:t>
+              <a:t>A real cooling system has three temperatures: the engine coolant T_c, the radiator coolant T_r and the oil T_o. To keep the model simple we only keep T_c, the one we control. The radiator is not a separate temperature any more; it becomes a 10-second lag between the cooling command and the engine. The engine block itself adds a 60-second lag. The oil is left out because it changes slowly and does not change how we design the PID.</a:t>
             </a:r>
             <a:endParaRPr lang="en-US" dirty="0"/>
           </a:p>
@@ -1573,7 +1573,7 @@
           <a:p>
             <a:r>
               <a:rPr lang="en-US" dirty="0"/>
-              <a:t>Starting from the energy balance, heat in minus heat out, we linearise around the normal operating point: 90 °C, 30 % engine load and 25 °C outside air. Every number comes from published data. The engine and its coolant have a heat capacity of about 352 kJ per kelvin, from the Volvo D13 mass and coolant volume and textbook specific heats. At 30 % load the engine puts 45 kW into the coolant, so to hold 90 °C with 25 °C air the cooling must remove 45 kW over 65 K, which is 0.69 kW per kelvin. The time constant is heat capacity divided by that, 352 / 0.69 = 509 seconds. The radiator lag is its heat capacity divided by the coolant flow, about 4.7 seconds. The gains come the same way: 1 % load is 1.5 kW, divided by 0.69 gives 2.17 K. G(s) is the cooling path and Gd(s) the load path, written in MATLAB with num, den, conv and tf.</a:t>
+              <a:t>Each part of the cooling system is modelled as a first-order thermal lag, K over tau s plus 1, which is the standard textbook model of a thermal system (Ogata). We linearise around the normal operating point: 90 °C at 30 % engine load. G(s) is the cooling path: if the cooling command goes up by one unit, the coolant ends up 20 K colder, through two lags, 10 seconds for the radiator and 60 seconds for the engine. Gd(s) is the load path: 1 % more engine load makes the coolant 0.6 K hotter, through the engine lag only. These numbers are assumed example values, chosen to be realistic in size; they are not measured on a real truck. In MATLAB they are written with num, den, conv and tf, exactly like in our lab sheets.</a:t>
             </a:r>
             <a:endParaRPr lang="en-US" dirty="0"/>
           </a:p>
@@ -1749,7 +1749,7 @@
           <a:p>
             <a:r>
               <a:rPr lang="en-US" dirty="0"/>
-              <a:t>A textbook PID needs three additions on a real system. First, split range: one PID output from 0 to 3 is shared across three actuators in order of energy cost: valve, then pump, then fan. In our simple model we only keep the total command inside 0 to 3. In the load-step test the command goes from 0.83 to about 2.2, so the pump is fully on and the fan just starts. Second, anti-windup: when the output is at its limit, the integral stops adding up; in Simulink this is the clamping option of the PID block. Third, a 1-second low-pass filter on the derivative so sensor noise does not make the actuators jitter; in Simulink that is the filter coefficient N = 1. The gains were not guessed: they come from the SIMC tuning rule by Skogestad, 2003. For our plant it gives Kp = engine time constant divided by plant gain times the chosen closed-loop time of 20 seconds, the integral time is 4 times 20 = 80 seconds, and the derivative time equals the radiator lag. Converted to parallel form that is Kp 0.34, Ki 0.0041 and Kd 1.52.</a:t>
+              <a:t>A textbook PID needs three additions on a real system. First, split range: one PID output from 0 to 3 is shared across three actuators in order of energy cost: valve, then pump, then fan. In our simple model we only keep the total command inside 0 to 3; in the load-step test it goes from 0.8 to about 2.3. Second, anti-windup: when the output is at its limit, the integral stops adding up; in Simulink this is the clamping option of the PID block. Third, a filter on the derivative so sensor noise does not make the actuators jitter; we use Simulink's default filter coefficient N = 100. The gains are not guessed: they come from the SIMC tuning rule by Skogestad, 2003. For our plant 20 over (60 s + 1)(10 s + 1), with a closed-loop time constant of 10 seconds, the rule gives Kc = 60 / (20 × 10) = 0.3, integral time = 4 × 10 = 40 seconds and derivative time = 10 seconds. Converted to the parallel form used in MATLAB and Simulink that is Kp 0.375, Ki 0.0075 and Kd 3.</a:t>
             </a:r>
             <a:endParaRPr lang="en-US" dirty="0"/>
           </a:p>
@@ -3037,7 +3037,7 @@
                           <a:ea typeface="Arial" pitchFamily="34" charset="-122"/>
                           <a:cs typeface="Arial" pitchFamily="34" charset="-120"/>
                         </a:rPr>
-                        <a:t>Physical data</a:t>
+                        <a:t>Plant parameters</a:t>
                       </a:r>
                       <a:endParaRPr lang="en-US" sz="1300" dirty="0">
                         <a:latin typeface="Arial" charset="0"/>
@@ -3105,7 +3105,7 @@
                           <a:ea typeface="Arial" pitchFamily="34" charset="-122"/>
                           <a:cs typeface="Arial" pitchFamily="34" charset="-120"/>
                         </a:rPr>
-                        <a:t>Engine, coolant and material data, plus stated assumptions</a:t>
+                        <a:t>Assumed example values: time constants, gains, y0</a:t>
                       </a:r>
                       <a:endParaRPr lang="en-US" sz="1300" dirty="0">
                         <a:latin typeface="Arial" charset="0"/>
@@ -3175,7 +3175,7 @@
                           <a:ea typeface="Arial" pitchFamily="34" charset="-122"/>
                           <a:cs typeface="Arial" pitchFamily="34" charset="-120"/>
                         </a:rPr>
-                        <a:t>Derived constants</a:t>
+                        <a:t>PID gains</a:t>
                       </a:r>
                       <a:endParaRPr lang="en-US" sz="1300" dirty="0">
                         <a:latin typeface="Arial" charset="0"/>
@@ -3243,7 +3243,7 @@
                           <a:ea typeface="Arial" pitchFamily="34" charset="-122"/>
                           <a:cs typeface="Arial" pitchFamily="34" charset="-120"/>
                         </a:rPr>
-                        <a:t>τ = C / H and gains K; PID gains from the SIMC rule</a:t>
+                        <a:t>Kp, Ki, Kd calculated with the SIMC tuning rule</a:t>
                       </a:r>
                       <a:endParaRPr lang="en-US" sz="1300" dirty="0">
                         <a:latin typeface="Arial" charset="0"/>
@@ -4687,7 +4687,7 @@
                           <a:ea typeface="Arial" pitchFamily="34" charset="-122"/>
                           <a:cs typeface="Arial" pitchFamily="34" charset="-120"/>
                         </a:rPr>
-                        <a:t>P 0.344, I 0.0041, D 1.52, N 1; limits −0.83 to 2.17; clamping</a:t>
+                        <a:t>P 0.375, I 0.0075, D 3, N 100; limits −0.8 to 2.2; clamping</a:t>
                       </a:r>
                       <a:endParaRPr lang="en-US" sz="1300" dirty="0">
                         <a:latin typeface="Arial" charset="0"/>
@@ -4825,7 +4825,7 @@
                           <a:ea typeface="Arial" pitchFamily="34" charset="-122"/>
                           <a:cs typeface="Arial" pitchFamily="34" charset="-120"/>
                         </a:rPr>
-                        <a:t>Cooling path: −78.2 / (2383s² + 513.8s + 1)</a:t>
+                        <a:t>Cooling path: −20 / (600s² + 70s + 1)</a:t>
                       </a:r>
                       <a:endParaRPr lang="en-US" sz="1300" dirty="0">
                         <a:latin typeface="Arial" charset="0"/>
@@ -4963,7 +4963,7 @@
                           <a:ea typeface="Arial" pitchFamily="34" charset="-122"/>
                           <a:cs typeface="Arial" pitchFamily="34" charset="-120"/>
                         </a:rPr>
-                        <a:t>Load +50 % at 600 s through 2.17 / (509s + 1)</a:t>
+                        <a:t>Load +50 % at 600 s through 0.6 / (60s + 1)</a:t>
                       </a:r>
                       <a:endParaRPr lang="en-US" sz="1300" dirty="0">
                         <a:latin typeface="Arial" charset="0"/>
@@ -5239,7 +5239,7 @@
                           <a:ea typeface="Arial" pitchFamily="34" charset="-122"/>
                           <a:cs typeface="Arial" pitchFamily="34" charset="-120"/>
                         </a:rPr>
-                        <a:t>Cooling command y = 0.83 + PID output</a:t>
+                        <a:t>Cooling command y = 0.8 + PID output</a:t>
                       </a:r>
                       <a:endParaRPr lang="en-US" sz="1300" dirty="0">
                         <a:latin typeface="Arial" charset="0"/>
@@ -5468,7 +5468,7 @@
                 <a:ea typeface="Arial" pitchFamily="34" charset="-122"/>
                 <a:cs typeface="Arial" pitchFamily="34" charset="-120"/>
               </a:rPr>
-              <a:t>Solver ode4, fixed step 0.1 s, 30-minute run · built by hand</a:t>
+              <a:t>Default solver, 30-minute run · built by hand</a:t>
             </a:r>
             <a:endParaRPr lang="en-US" sz="1200" dirty="0"/>
           </a:p>
@@ -6115,7 +6115,7 @@
                           <a:ea typeface="Arial" pitchFamily="34" charset="-122"/>
                           <a:cs typeface="Arial" pitchFamily="34" charset="-120"/>
                         </a:rPr>
-                        <a:t>3.9 K</a:t>
+                        <a:t>4.9 K</a:t>
                       </a:r>
                       <a:endParaRPr lang="en-US" sz="1300" dirty="0">
                         <a:latin typeface="Arial" charset="0"/>
@@ -6183,7 +6183,7 @@
                           <a:ea typeface="Arial" pitchFamily="34" charset="-122"/>
                           <a:cs typeface="Arial" pitchFamily="34" charset="-120"/>
                         </a:rPr>
-                        <a:t>27 s</a:t>
+                        <a:t>31 s</a:t>
                       </a:r>
                       <a:endParaRPr lang="en-US" sz="1300" dirty="0">
                         <a:latin typeface="Arial" charset="0"/>
@@ -6251,7 +6251,7 @@
                           <a:ea typeface="Arial" pitchFamily="34" charset="-122"/>
                           <a:cs typeface="Arial" pitchFamily="34" charset="-120"/>
                         </a:rPr>
-                        <a:t>3.9 K</a:t>
+                        <a:t>3.5 K</a:t>
                       </a:r>
                       <a:endParaRPr lang="en-US" sz="1300" dirty="0">
                         <a:latin typeface="Arial" charset="0"/>
@@ -6389,7 +6389,7 @@
                           <a:ea typeface="Arial" pitchFamily="34" charset="-122"/>
                           <a:cs typeface="Arial" pitchFamily="34" charset="-120"/>
                         </a:rPr>
-                        <a:t>3.3 K</a:t>
+                        <a:t>4.6 K</a:t>
                       </a:r>
                       <a:endParaRPr lang="en-US" sz="1300" dirty="0">
                         <a:latin typeface="Arial" charset="0"/>
@@ -6457,7 +6457,7 @@
                           <a:ea typeface="Arial" pitchFamily="34" charset="-122"/>
                           <a:cs typeface="Arial" pitchFamily="34" charset="-120"/>
                         </a:rPr>
-                        <a:t>173 s</a:t>
+                        <a:t>99 s</a:t>
                       </a:r>
                       <a:endParaRPr lang="en-US" sz="1300" dirty="0">
                         <a:latin typeface="Arial" charset="0"/>
@@ -6663,7 +6663,7 @@
                           <a:ea typeface="Arial" pitchFamily="34" charset="-122"/>
                           <a:cs typeface="Arial" pitchFamily="34" charset="-120"/>
                         </a:rPr>
-                        <a:t>3.0 K</a:t>
+                        <a:t>3.3 K</a:t>
                       </a:r>
                       <a:endParaRPr lang="en-US" sz="1300" dirty="0">
                         <a:latin typeface="Arial" charset="0"/>
@@ -6731,7 +6731,7 @@
                           <a:ea typeface="Arial" pitchFamily="34" charset="-122"/>
                           <a:cs typeface="Arial" pitchFamily="34" charset="-120"/>
                         </a:rPr>
-                        <a:t>175 s</a:t>
+                        <a:t>99 s</a:t>
                       </a:r>
                       <a:endParaRPr lang="en-US" sz="1300" dirty="0">
                         <a:latin typeface="Arial" charset="0"/>
@@ -6901,7 +6901,7 @@
                 <a:ea typeface="Arial" pitchFamily="34" charset="-122"/>
                 <a:cs typeface="Arial" pitchFamily="34" charset="-120"/>
               </a:rPr>
-              <a:t>4 K too hot</a:t>
+              <a:t>3.5 K too hot</a:t>
             </a:r>
             <a:r>
               <a:rPr lang="en-US" sz="1400" dirty="0">
@@ -6912,7 +6912,7 @@
                 <a:ea typeface="Arial" pitchFamily="34" charset="-122"/>
                 <a:cs typeface="Arial" pitchFamily="34" charset="-120"/>
               </a:rPr>
-              <a:t>. Adding I brings it back to exactly 90 °C. Adding D cuts the peak by about 7 %.</a:t>
+              <a:t>. Adding I brings it back to exactly 90 °C. Adding D cuts the peak by about 28 %.</a:t>
             </a:r>
             <a:endParaRPr lang="en-US" sz="1400" dirty="0"/>
           </a:p>
@@ -7238,7 +7238,7 @@
                 <a:ea typeface="Arial" pitchFamily="34" charset="-122"/>
                 <a:cs typeface="Arial" pitchFamily="34" charset="-120"/>
               </a:rPr>
-              <a:t>PID reaches 95 °C with 10.7 % overshoot and settles in about 212 s.</a:t>
+              <a:t>PID reaches 95 °C with 3.3 % overshoot and settles in about 78 s.</a:t>
             </a:r>
             <a:endParaRPr lang="en-US" sz="1300" dirty="0"/>
           </a:p>
@@ -7326,7 +7326,7 @@
                 <a:ea typeface="Arial" pitchFamily="34" charset="-122"/>
                 <a:cs typeface="Arial" pitchFamily="34" charset="-120"/>
               </a:rPr>
-              <a:t>Stops at 94.8 °C, a 0.2 K offset. PI and PID remove it.</a:t>
+              <a:t>Stops at 94.4 °C, a 0.6 K offset. PI and PID remove it.</a:t>
             </a:r>
             <a:endParaRPr lang="en-US" sz="1300" dirty="0"/>
           </a:p>
@@ -7630,7 +7630,7 @@
                 <a:ea typeface="Arial" pitchFamily="34" charset="-122"/>
                 <a:cs typeface="Arial" pitchFamily="34" charset="-120"/>
               </a:rPr>
-              <a:t>PID holds 90 °C with zero offset. P only, like today's wax thermostat, stays 4 K too hot. D cuts the peak by about 7 %.</a:t>
+              <a:t>PID holds 90 °C with zero offset. P only, like today's wax thermostat, stays 3.5 K too hot. D cuts the peak by about 28 %.</a:t>
             </a:r>
             <a:endParaRPr lang="en-US" sz="1300" dirty="0"/>
           </a:p>
@@ -7768,7 +7768,7 @@
                 <a:ea typeface="Arial" pitchFamily="34" charset="-122"/>
                 <a:cs typeface="Arial" pitchFamily="34" charset="-120"/>
               </a:rPr>
-              <a:t>Linear model with one temperature: no oil, no separate valve, pump and fan. Some inputs are assumed (slide 15).</a:t>
+              <a:t>Linear model with one temperature: no oil, no separate valve, pump and fan. Plant values are assumed (slide 15).</a:t>
             </a:r>
             <a:endParaRPr lang="en-US" sz="1300" dirty="0"/>
           </a:p>
@@ -8899,7 +8899,7 @@
                 <a:ea typeface="Arial" pitchFamily="34" charset="-122"/>
                 <a:cs typeface="Arial" pitchFamily="34" charset="-120"/>
               </a:rPr>
-              <a:t>DATA SOURCES</a:t>
+              <a:t>REFERENCES</a:t>
             </a:r>
             <a:endParaRPr lang="en-US" sz="1200" dirty="0"/>
           </a:p>
@@ -8945,7 +8945,7 @@
                 <a:ea typeface="Arial" pitchFamily="34" charset="-122"/>
                 <a:cs typeface="Arial" pitchFamily="34" charset="-120"/>
               </a:rPr>
-              <a:t>Where the numbers come from</a:t>
+              <a:t>Model, assumptions and references</a:t>
             </a:r>
             <a:endParaRPr lang="en-US" sz="3200" dirty="0"/>
           </a:p>
@@ -8998,7 +8998,7 @@
                           <a:ea typeface="Arial" pitchFamily="34" charset="-122"/>
                           <a:cs typeface="Arial" pitchFamily="34" charset="-120"/>
                         </a:rPr>
-                        <a:t>Value</a:t>
+                        <a:t>Item</a:t>
                       </a:r>
                       <a:endParaRPr lang="en-US" sz="1300" dirty="0">
                         <a:latin typeface="Arial" charset="0"/>
@@ -9142,7 +9142,7 @@
                           <a:ea typeface="Arial" pitchFamily="34" charset="-122"/>
                           <a:cs typeface="Arial" pitchFamily="34" charset="-120"/>
                         </a:rPr>
-                        <a:t>338 kW, 1121 kg, 38 L coolant</a:t>
+                        <a:t>First-order thermal model K/(τs + 1)</a:t>
                       </a:r>
                       <a:endParaRPr lang="en-US" sz="1300" dirty="0">
                         <a:latin typeface="Arial" charset="0"/>
@@ -9210,7 +9210,7 @@
                           <a:ea typeface="Arial" pitchFamily="34" charset="-122"/>
                           <a:cs typeface="Arial" pitchFamily="34" charset="-120"/>
                         </a:rPr>
-                        <a:t>Volvo D13C460 engine fact sheet</a:t>
+                        <a:t>Ogata, Modern Control Engineering (thermal systems)</a:t>
                       </a:r>
                       <a:endParaRPr lang="en-US" sz="1300" dirty="0">
                         <a:latin typeface="Arial" charset="0"/>
@@ -9280,7 +9280,7 @@
                           <a:ea typeface="Arial" pitchFamily="34" charset="-122"/>
                           <a:cs typeface="Arial" pitchFamily="34" charset="-120"/>
                         </a:rPr>
-                        <a:t>150 kW to coolant (105 °C, 45 °C air)</a:t>
+                        <a:t>τc 60 s, τr 10 s, K 20 and 0.6, y0 0.8</a:t>
                       </a:r>
                       <a:endParaRPr lang="en-US" sz="1300" dirty="0">
                         <a:latin typeface="Arial" charset="0"/>
@@ -9348,7 +9348,7 @@
                           <a:ea typeface="Arial" pitchFamily="34" charset="-122"/>
                           <a:cs typeface="Arial" pitchFamily="34" charset="-120"/>
                         </a:rPr>
-                        <a:t>Worsztynowicz (2017), heavy-duty cooling modules</a:t>
+                        <a:t>Assumed example values, not measured</a:t>
                       </a:r>
                       <a:endParaRPr lang="en-US" sz="1300" dirty="0">
                         <a:latin typeface="Arial" charset="0"/>
@@ -9418,7 +9418,7 @@
                           <a:ea typeface="Arial" pitchFamily="34" charset="-122"/>
                           <a:cs typeface="Arial" pitchFamily="34" charset="-120"/>
                         </a:rPr>
-                        <a:t>c_p: coolant 3.5, iron 0.46, Al 0.91 kJ/kg·K</a:t>
+                        <a:t>Kp 0.375, Ki 0.0075, Kd 3.0</a:t>
                       </a:r>
                       <a:endParaRPr lang="en-US" sz="1300" dirty="0">
                         <a:latin typeface="Arial" charset="0"/>
@@ -9486,7 +9486,7 @@
                           <a:ea typeface="Arial" pitchFamily="34" charset="-122"/>
                           <a:cs typeface="Arial" pitchFamily="34" charset="-120"/>
                         </a:rPr>
-                        <a:t>Engineering ToolBox property tables</a:t>
+                        <a:t>SIMC rule: Skogestad, J. Process Control 13 (2003)</a:t>
                       </a:r>
                       <a:endParaRPr lang="en-US" sz="1300" dirty="0">
                         <a:latin typeface="Arial" charset="0"/>
@@ -9556,7 +9556,7 @@
                           <a:ea typeface="Arial" pitchFamily="34" charset="-122"/>
                           <a:cs typeface="Arial" pitchFamily="34" charset="-120"/>
                         </a:rPr>
-                        <a:t>150 kW ≈ 18 % of fuel energy</a:t>
+                        <a:t>Closed-loop time τcl = 10 s</a:t>
                       </a:r>
                       <a:endParaRPr lang="en-US" sz="1300" dirty="0">
                         <a:latin typeface="Arial" charset="0"/>
@@ -9624,7 +9624,7 @@
                           <a:ea typeface="Arial" pitchFamily="34" charset="-122"/>
                           <a:cs typeface="Arial" pitchFamily="34" charset="-120"/>
                         </a:rPr>
-                        <a:t>Heywood, ICE Fundamentals: 17–26 % (cross-check)</a:t>
+                        <a:t>Our choice, equal to the radiator lag</a:t>
                       </a:r>
                       <a:endParaRPr lang="en-US" sz="1300" dirty="0">
                         <a:latin typeface="Arial" charset="0"/>
@@ -9694,7 +9694,7 @@
                           <a:ea typeface="Arial" pitchFamily="34" charset="-122"/>
                           <a:cs typeface="Arial" pitchFamily="34" charset="-120"/>
                         </a:rPr>
-                        <a:t>Kp, Ki, Kd</a:t>
+                        <a:t>Derivative filter N = 100</a:t>
                       </a:r>
                       <a:endParaRPr lang="en-US" sz="1300" dirty="0">
                         <a:latin typeface="Arial" charset="0"/>
@@ -9762,7 +9762,7 @@
                           <a:ea typeface="Arial" pitchFamily="34" charset="-122"/>
                           <a:cs typeface="Arial" pitchFamily="34" charset="-120"/>
                         </a:rPr>
-                        <a:t>SIMC tuning rule, Skogestad (2003)</a:t>
+                        <a:t>Simulink PID Controller default value</a:t>
                       </a:r>
                       <a:endParaRPr lang="en-US" sz="1300" dirty="0">
                         <a:latin typeface="Arial" charset="0"/>
@@ -9832,7 +9832,7 @@
                           <a:ea typeface="Arial" pitchFamily="34" charset="-122"/>
                           <a:cs typeface="Arial" pitchFamily="34" charset="-120"/>
                         </a:rPr>
-                        <a:t>50 % mass, 26 L, 30 kg, 250 L/min, 25 °C</a:t>
+                        <a:t>Rise, peak, overshoot, settling time</a:t>
                       </a:r>
                       <a:endParaRPr lang="en-US" sz="1300" dirty="0">
                         <a:latin typeface="Arial" charset="0"/>
@@ -9900,7 +9900,7 @@
                           <a:ea typeface="Arial" pitchFamily="34" charset="-122"/>
                           <a:cs typeface="Arial" pitchFamily="34" charset="-120"/>
                         </a:rPr>
-                        <a:t>Our assumptions</a:t>
+                        <a:t>stepinfo() and our time-domain lab notes</a:t>
                       </a:r>
                       <a:endParaRPr lang="en-US" sz="1300" dirty="0">
                         <a:latin typeface="Arial" charset="0"/>
@@ -9970,7 +9970,7 @@
                           <a:ea typeface="Arial" pitchFamily="34" charset="-122"/>
                           <a:cs typeface="Arial" pitchFamily="34" charset="-120"/>
                         </a:rPr>
-                        <a:t>τc 509 s, τr 4.7 s, K 78.2 and 2.17</a:t>
+                        <a:t>P offset, I removes it</a:t>
                       </a:r>
                       <a:endParaRPr lang="en-US" sz="1300" dirty="0">
                         <a:latin typeface="Arial" charset="0"/>
@@ -10038,7 +10038,7 @@
                           <a:ea typeface="Arial" pitchFamily="34" charset="-122"/>
                           <a:cs typeface="Arial" pitchFamily="34" charset="-120"/>
                         </a:rPr>
-                        <a:t>Calculated in pid_truck_cooling.m</a:t>
+                        <a:t>Final value theorem: Nise, Control Systems Engineering</a:t>
                       </a:r>
                       <a:endParaRPr lang="en-US" sz="1300" dirty="0">
                         <a:latin typeface="Arial" charset="0"/>
@@ -13344,7 +13344,7 @@
                 <a:ea typeface="Arial" pitchFamily="34" charset="-122"/>
                 <a:cs typeface="Arial" pitchFamily="34" charset="-120"/>
               </a:rPr>
-              <a:t>Not a separate state. Modelled as a 4.7 s lag between the cooling command and the engine.</a:t>
+              <a:t>Not a separate state. Modelled as a 10 s lag between the cooling command and the engine.</a:t>
             </a:r>
             <a:endParaRPr lang="en-US" sz="1300" dirty="0"/>
           </a:p>
@@ -13569,7 +13569,7 @@
                 <a:ea typeface="Arial" pitchFamily="34" charset="-122"/>
                 <a:cs typeface="Arial" pitchFamily="34" charset="-120"/>
               </a:rPr>
-              <a:t>. The engine block adds a 509 s lag. In the code the only output is </a:t>
+              <a:t>. The engine block adds a 60 s lag. In the code the only output is </a:t>
             </a:r>
             <a:r>
               <a:rPr lang="en-US" sz="1400" dirty="0">
@@ -13828,7 +13828,7 @@
                 <a:ea typeface="Courier New" pitchFamily="49" charset="-122"/>
                 <a:cs typeface="Courier New" pitchFamily="49" charset="-120"/>
               </a:rPr>
-              <a:t>G(s)  = 78.2 / ((509s + 1)(4.7s + 1))</a:t>
+              <a:t>G(s)  = 20 / ((60s + 1)(10s + 1))</a:t>
             </a:r>
             <a:endParaRPr lang="en-US" sz="1500" dirty="0"/>
           </a:p>
@@ -13872,7 +13872,7 @@
                 <a:ea typeface="Arial" pitchFamily="34" charset="-122"/>
                 <a:cs typeface="Arial" pitchFamily="34" charset="-120"/>
               </a:rPr>
-              <a:t>Cooling path: one more unit of cooling command lowers T_c by 78 K, through the radiator and engine lags</a:t>
+              <a:t>Cooling path: one more unit of cooling command lowers T_c by 20 K, through the radiator and engine lags</a:t>
             </a:r>
             <a:endParaRPr lang="en-US" sz="1300" dirty="0"/>
           </a:p>
@@ -13943,7 +13943,7 @@
                 <a:ea typeface="Courier New" pitchFamily="49" charset="-122"/>
                 <a:cs typeface="Courier New" pitchFamily="49" charset="-120"/>
               </a:rPr>
-              <a:t>Gd(s) = 2.17 / (509s + 1)</a:t>
+              <a:t>Gd(s) = 0.6 / (60s + 1)</a:t>
             </a:r>
             <a:endParaRPr lang="en-US" sz="1500" dirty="0"/>
           </a:p>
@@ -13987,7 +13987,7 @@
                 <a:ea typeface="Arial" pitchFamily="34" charset="-122"/>
                 <a:cs typeface="Arial" pitchFamily="34" charset="-120"/>
               </a:rPr>
-              <a:t>Load path: 1 % more engine load raises T_c by 2.17 K, through the engine lag only</a:t>
+              <a:t>Load path: 1 % more engine load raises T_c by 0.6 K, through the engine lag only</a:t>
             </a:r>
             <a:endParaRPr lang="en-US" sz="1300" dirty="0"/>
           </a:p>
@@ -14102,7 +14102,7 @@
                 <a:ea typeface="Arial" pitchFamily="34" charset="-122"/>
                 <a:cs typeface="Arial" pitchFamily="34" charset="-120"/>
               </a:rPr>
-              <a:t>Linearised around 90 °C, 30 % load and 25 °C air, where the cooling command is y0 = 0.83</a:t>
+              <a:t>Linearised around 90 °C and 30 % load, where the cooling command is y0 = 0.8</a:t>
             </a:r>
             <a:endParaRPr lang="en-US" sz="1300" dirty="0"/>
           </a:p>
@@ -14146,7 +14146,7 @@
                 <a:ea typeface="Arial" pitchFamily="34" charset="-122"/>
                 <a:cs typeface="Arial" pitchFamily="34" charset="-120"/>
               </a:rPr>
-              <a:t>τ = heat capacity ÷ heat removal rate · K = heat input ÷ heat removal rate · all inputs on slide 15</a:t>
+              <a:t>Δy = change in cooling command (scale 0–3) · ΔL = change in engine load [%] · assumed example values (slide 15)</a:t>
             </a:r>
             <a:endParaRPr lang="en-US" sz="1300" dirty="0"/>
           </a:p>
@@ -15932,7 +15932,7 @@
                 <a:ea typeface="Arial" pitchFamily="34" charset="-122"/>
                 <a:cs typeface="Arial" pitchFamily="34" charset="-120"/>
               </a:rPr>
-              <a:t>A 1 s low-pass filter on the D term, so sensor noise is not amplified.</a:t>
+              <a:t>Simulink's default filter (N = 100) on the D term, so sensor noise is not amplified.</a:t>
             </a:r>
             <a:endParaRPr lang="en-US" sz="1300" dirty="0"/>
           </a:p>
@@ -16024,7 +16024,7 @@
                 <a:ea typeface="Arial" pitchFamily="34" charset="-122"/>
                 <a:cs typeface="Arial" pitchFamily="34" charset="-120"/>
               </a:rPr>
-              <a:t>Kp = 0.34</a:t>
+              <a:t>Kp = 0.375</a:t>
             </a:r>
             <a:endParaRPr lang="en-US" sz="1400" dirty="0"/>
           </a:p>
@@ -16072,7 +16072,7 @@
                 <a:ea typeface="Arial" pitchFamily="34" charset="-122"/>
                 <a:cs typeface="Arial" pitchFamily="34" charset="-120"/>
               </a:rPr>
-              <a:t>Ki = 0.0041</a:t>
+              <a:t>Ki = 0.0075</a:t>
             </a:r>
             <a:endParaRPr lang="en-US" sz="1400" dirty="0"/>
           </a:p>
@@ -16120,7 +16120,7 @@
                 <a:ea typeface="Arial" pitchFamily="34" charset="-122"/>
                 <a:cs typeface="Arial" pitchFamily="34" charset="-120"/>
               </a:rPr>
-              <a:t>Kd = 1.52</a:t>
+              <a:t>Kd = 3.0</a:t>
             </a:r>
             <a:endParaRPr lang="en-US" sz="1400" dirty="0"/>
           </a:p>
@@ -16168,7 +16168,7 @@
                 <a:ea typeface="Arial" pitchFamily="34" charset="-122"/>
                 <a:cs typeface="Arial" pitchFamily="34" charset="-120"/>
               </a:rPr>
-              <a:t>N = 1</a:t>
+              <a:t>N = 100</a:t>
             </a:r>
             <a:endParaRPr lang="en-US" sz="1400" dirty="0"/>
           </a:p>

</xml_diff>

<commit_message>
Update deck to the fully referenced plant, SIMC gains and data sources slide
Co-Authored-By: Claude Opus 5.5 <noreply@anthropic.com>
Claude-Session: https://claude.ai/code/session_01KYcVruEhgF1vnL4e2wj7fD
</commit_message>
<xml_diff>
--- a/PID_Thermal_Control_for_Heavy-Duty_Trucks_v2.pptx
+++ b/PID_Thermal_Control_for_Heavy-Duty_Trucks_v2.pptx
@@ -605,7 +605,7 @@
           <a:p>
             <a:r>
               <a:rPr lang="en-US" dirty="0"/>
-              <a:t>All the MATLAB code is in one file, pid_truck_cooling.m, split into sections. The parameters and gains are at the top, so every number is in one place. Then the plant transfer functions are defined with num, den and tf, and the three controllers P, PI and PID. feedback() closes the loop, and pole() prints the closed-loop poles: all of them are in the left half of the s-plane, so all three loops are stable. Experiment 1 is a set-point step analysed with step() and stepinfo(). Experiment 2 is a load step, where we find the settling time by walking backwards from the end of the response, the same method as in the time-domain lab.</a:t>
+              <a:t>All the MATLAB code is in one file, pid_truck_cooling.m, split into sections. The first section lists every published number with a reference tag in square brackets. The next section calculates the heat capacity, time constants and gains from those numbers with the energy balance, and the PID gains with the SIMC rule, so no number is typed in without a source. Then the plant transfer functions are defined with num, den and tf, and the three controllers P, PI and PID. feedback() closes the loop, and pole() prints the closed-loop poles: all of them are in the left half of the s-plane, so all three loops are stable. Experiment 1 is a set-point step analysed with step() and stepinfo(). Experiment 2 is a load step, where we find the settling time by walking backwards from the end of the response, the same method as in the time-domain lab.</a:t>
             </a:r>
             <a:endParaRPr lang="en-US" dirty="0"/>
           </a:p>
@@ -693,7 +693,7 @@
           <a:p>
             <a:r>
               <a:rPr lang="en-US" dirty="0"/>
-              <a:t>We built the same loop by hand in Simulink. The Step block gives the set-point, 90 °C, stepping to 95 °C at 1200 seconds. The Sum block subtracts the set-point from the coolant temperature to get the error. The PID Controller block has the same SIMC gains as the MATLAB code, Simulink's default filter coefficient of 100, output limits and clamping anti-windup. The limits are minus 0.8 and 2.2 because the block outputs the change from the normal command of 0.8, so the real command stays between 0 and 3. The cooling transfer function has a minus sign because more cooling lowers the temperature. A second Step adds 50 % engine load at 600 seconds through Gd(s). The plant output is 90 plus the two effects, and it is fed back to the error block. The Scope shows the temperature and the cooling command. [Add a screenshot of the model and the Scope here.]</a:t>
+              <a:t>We built the same loop by hand in Simulink. The Step block gives the set-point, 90 °C, stepping to 95 °C at 1200 seconds. The Sum block subtracts the set-point from the coolant temperature to get the error. The PID Controller block has the same SIMC gains as the MATLAB code, Simulink's default filter coefficient of 100, output limits and clamping anti-windup. The limits are minus 1.58 and 2.92 because the block outputs the change from the normal fan flow of 1.58 kg per second, so the real fan flow stays between 0 and 4.5. The fan transfer function has a minus sign because more air lowers the temperature. A second Step adds 40 % engine load at 600 seconds through Gd(s). The plant output is 90 plus the two effects, and it is fed back to the error block. The Scope shows the temperature and the fan air flow. [Add a screenshot of the model and the Scope here.]</a:t>
             </a:r>
             <a:endParaRPr lang="en-US" dirty="0"/>
           </a:p>
@@ -781,7 +781,7 @@
           <a:p>
             <a:r>
               <a:rPr lang="en-US" dirty="0"/>
-              <a:t>Second test, the one that matters most for a truck. At time zero the engine load jumps from 30 to 80 percent, as if the truck hits a hill. P only settles about 3.5 degrees too hot and stays there: that is the steady-state offset, exactly as the final value theorem predicts, 50 × 0.6 / (1 + 0.375 × 20) = 3.5 K. It is also why today's wax thermostat, which is a mechanical P controller, never reaches its target. Adding the integral term brings the temperature back to exactly 90 °C in about 100 seconds. Adding the derivative term cuts the peak from 4.6 to 3.3 K, about 28 % lower. Settling time here is the time to stay within ±0.5 K. During this test the PID raises the cooling command from 0.8 to about 2.3, still below the limit of 3.</a:t>
+              <a:t>Second test, the one that matters most for a truck. At time zero the engine load jumps from 30 to 70 percent, as if the truck hits a hill, which adds 68 kW of heat to the coolant. P only settles about 0.8 degrees too hot and stays there: that is the steady-state offset the final value theorem predicts, 40 × 2.0 / (1 + 2.48 × 38.1). It is also why today's wax thermostat, which is a mechanical P controller, never reaches its target. Adding the integral term brings the temperature back to exactly 90 °C in under two minutes. Adding the derivative term cuts the peak from 1.10 to 0.77 K, about 30 % lower. Settling time here is the time to stay within ±0.1 K. During this test the PID raises the fan air flow from 1.58 to about 3.7 kg per second, peaking at 4.0, still below the fan's limit of 4.5.</a:t>
             </a:r>
             <a:endParaRPr lang="en-US" dirty="0"/>
           </a:p>
@@ -869,7 +869,7 @@
           <a:p>
             <a:r>
               <a:rPr lang="en-US" dirty="0"/>
-              <a:t>First test: we change the target from 90 to 95 °C and compare P only, PI and PID, using step() and stepinfo() in MATLAB. P only never reaches 95: it stops at about 94.4 °C, a steady-state offset of 0.6 K, because it needs an error to produce any output. PI removes the offset but overshoots by 24 %. The full PID removes the offset and cuts the overshoot to only 3.3 %, settling within 2 % in about 78 seconds. The closed-loop poles printed by pole() all have negative real parts, so all three loops are stable.</a:t>
+              <a:t>First test: we change the target from 90 to 95 °C and compare P only, PI and PID, using step() and stepinfo() in MATLAB. P only stops 0.05 K short of 95 °C: a small steady-state offset, small because the plant gain is large. PI removes the offset but overshoots by 41 %. The full PID removes the offset and cuts the overshoot to 12.6 %, settling within 2 % in about 121 seconds. The closed-loop poles printed by pole() all have negative real parts, so all three loops are stable.</a:t>
             </a:r>
             <a:endParaRPr lang="en-US" dirty="0"/>
           </a:p>
@@ -957,7 +957,7 @@
           <a:p>
             <a:r>
               <a:rPr lang="en-US" dirty="0"/>
-              <a:t>To conclude: the PID holds the engine at 90 °C with no steady-state offset. A P-only controller, which is how today's wax thermostat behaves, stays about 3.5 degrees too hot after a load step, and adding D cuts the temperature peak by about 28 %. The limitations: our model is linear and keeps only the coolant temperature, so it has no oil temperature and does not model the valve, pump and fan separately. The plant values are assumed example values, not measured; the PID gains come from a published tuning rule. The next steps are measuring the plant on a real engine, adding the radiator and oil temperatures, and then trying a predictive controller, MPC, which uses the road ahead to plan cooling.</a:t>
+              <a:t>To conclude: the PID holds the engine at 90 °C with no steady-state offset. A P-only controller, which is how today's wax thermostat behaves, stays about 0.8 degrees too hot after a load step, and adding D cuts the temperature peak by about 30 %. The limitations: our model is linear, treats the engine as one lumped mass and only controls the fan. All numbers come from published sources, but from different engines and studies, not from our own tests. The next steps are measuring a real engine, adding the radiator and oil temperatures and the full split range, and then trying a predictive controller, MPC, which uses the road ahead to plan cooling.</a:t>
             </a:r>
             <a:endParaRPr lang="en-US" dirty="0"/>
           </a:p>
@@ -1045,7 +1045,7 @@
           <a:p>
             <a:r>
               <a:rPr lang="en-US" dirty="0"/>
-              <a:t>Likely questions. Where do the numbers come from? The plant values are assumed example values for a first-order thermal model; the PID gains are calculated from them with Skogestad's SIMC rule, so they are not guessed. Why is D useful here? It acts on how fast the temperature is rising, so it reacts early and cuts the peak by 28 %. Why only one temperature? A simple linear model is enough to show what P, I and D each do. Is the model validated? No, the next step is to measure it on a real engine. Why e = T_c minus T_ref? Our actuators remove heat, so hotter must give a positive output. Why does a P controller leave an offset? It needs a non-zero error to produce a non-zero output; the integral removes it.</a:t>
+              <a:t>Likely questions. Where do the numbers come from? Every number in the code has a reference tag: the engine data from the Volvo D13 fact sheet, the heat rejection, radiator and fan data from the COBEM 2009 truck and bus paper, the model equations from Mohamed et al. 2018, the lumped-mass idea from a Chalmers thesis, material properties from Engineering ToolBox, and the PID gains from Skogestad's SIMC rule. Why is D useful here? It reacts to how fast the temperature is rising, so it acts early and cuts the peak by 30 %. Is the model validated? Not against our own engine tests; the data comes from different published sources. Why e = T_c minus T_ref? The fan removes heat, so hotter must give more air. Why does a P controller leave an offset? It needs a non-zero error to produce a non-zero output; the integral removes it.</a:t>
             </a:r>
             <a:endParaRPr lang="en-US" dirty="0"/>
           </a:p>
@@ -1485,7 +1485,7 @@
           <a:p>
             <a:r>
               <a:rPr lang="en-US" dirty="0"/>
-              <a:t>A real cooling system has three temperatures: the engine coolant T_c, the radiator coolant T_r and the oil T_o. To keep the model simple we only keep T_c, the one we control. The radiator is not a separate temperature any more; it becomes a 10-second lag between the cooling command and the engine. The engine block itself adds a 60-second lag. The oil is left out because it changes slowly and does not change how we design the PID.</a:t>
+              <a:t>A real cooling system has three temperatures: the engine coolant T_c, the radiator coolant T_r and the oil T_o. Following the Chalmers thesis by Haury and Volkering, we lump the engine block, the coolant and the oil into one mass with one temperature, T_c, the one we control. Using the Volvo D13 data, that mass has a heat capacity of 720 kJ per kelvin, which gives a long lag of about 851 seconds. The radiator is not a separate temperature: the coolant takes 38 litres divided by 3.25 kg per second, about 11.3 seconds, to go round the loop, and we model that as a short lag.</a:t>
             </a:r>
             <a:endParaRPr lang="en-US" dirty="0"/>
           </a:p>
@@ -1573,7 +1573,7 @@
           <a:p>
             <a:r>
               <a:rPr lang="en-US" dirty="0"/>
-              <a:t>Each part of the cooling system is modelled as a first-order thermal lag, K over tau s plus 1, which is the standard textbook model of a thermal system (Ogata). We linearise around the normal operating point: 90 °C at 30 % engine load. G(s) is the cooling path: if the cooling command goes up by one unit, the coolant ends up 20 K colder, through two lags, 10 seconds for the radiator and 60 seconds for the engine. Gd(s) is the load path: 1 % more engine load makes the coolant 0.6 K hotter, through the engine lag only. These numbers are assumed example values, chosen to be realistic in size; they are not measured on a real truck. In MATLAB they are written with num, den, conv and tf, exactly like in our lab sheets.</a:t>
+              <a:t>We use the energy balance from Mohamed et al., IOSR 2018: heat capacity times the rate of temperature change equals the heat from the engine minus the heat the fan removes, where the fan heat is effectiveness times air flow times air specific heat times the temperature difference. Every number comes from a source. The engine is the Volvo D13: 338 kW, 1121 kg, 38 litres of coolant and 33 litres of oil. With textbook specific heats, block plus coolant plus oil gives 720 kJ per kelvin. From the COBEM 2009 truck and bus paper, half of the engine power goes into the coolant, so 1 % load is 1.69 kW; the radiator is rated at 100 °C water and 30 °C air; the coolant flow is 3.25 kg per second; and the fan can move 4.5 kg per second of air. At 90 °C and 30 % load the fan needs 1.58 kg per second, which removes 0.845 kW per kelvin. The time constant is 720 divided by 0.845, which is 851 seconds. The gains come out as 38 K per kg per second of fan air and 2.0 K per percent of load.</a:t>
             </a:r>
             <a:endParaRPr lang="en-US" dirty="0"/>
           </a:p>
@@ -1749,7 +1749,7 @@
           <a:p>
             <a:r>
               <a:rPr lang="en-US" dirty="0"/>
-              <a:t>A textbook PID needs three additions on a real system. First, split range: one PID output from 0 to 3 is shared across three actuators in order of energy cost: valve, then pump, then fan. In our simple model we only keep the total command inside 0 to 3; in the load-step test it goes from 0.8 to about 2.3. Second, anti-windup: when the output is at its limit, the integral stops adding up; in Simulink this is the clamping option of the PID block. Third, a filter on the derivative so sensor noise does not make the actuators jitter; we use Simulink's default filter coefficient N = 100. The gains are not guessed: they come from the SIMC tuning rule by Skogestad, 2003. For our plant 20 over (60 s + 1)(10 s + 1), with a closed-loop time constant of 10 seconds, the rule gives Kc = 60 / (20 × 10) = 0.3, integral time = 4 × 10 = 40 seconds and derivative time = 10 seconds. Converted to the parallel form used in MATLAB and Simulink that is Kp 0.375, Ki 0.0075 and Kd 3.</a:t>
+              <a:t>A textbook PID needs three additions on a real system. First, split range: in a full system one PID output is shared across valve, pump and fan in order of energy cost. In our model the pump runs at the fixed 3.25 kg per second from the COBEM paper and the PID drives the fan only, between 0 and 4.5 kg per second of air. Second, anti-windup: when the fan is at its limit, the integral stops adding up; in Simulink this is the clamping option of the PID block. Third, a filter on the derivative so sensor noise does not make the fan jitter; we use Simulink's default filter coefficient N = 100. The gains come from the SIMC tuning rule by Skogestad, 2003. Skogestad recommends a closed-loop time constant equal to the delay for tight control, so we use the 11.3-second loop time. The rule gives Kc = 851 / (38.1 × 11.3) = 1.98, integral time 4 × 11.3 = 45 seconds and derivative time 11.3 seconds. In parallel form that is Kp 2.48, Ki 0.044 and Kd 22.4, in kg/s of fan air per kelvin.</a:t>
             </a:r>
             <a:endParaRPr lang="en-US" dirty="0"/>
           </a:p>
@@ -3105,7 +3105,7 @@
                           <a:ea typeface="Arial" pitchFamily="34" charset="-122"/>
                           <a:cs typeface="Arial" pitchFamily="34" charset="-120"/>
                         </a:rPr>
-                        <a:t>Assumed example values: time constants, gains, y0</a:t>
+                        <a:t>Published data → C, τ and K by energy balance</a:t>
                       </a:r>
                       <a:endParaRPr lang="en-US" sz="1300" dirty="0">
                         <a:latin typeface="Arial" charset="0"/>
@@ -3243,7 +3243,7 @@
                           <a:ea typeface="Arial" pitchFamily="34" charset="-122"/>
                           <a:cs typeface="Arial" pitchFamily="34" charset="-120"/>
                         </a:rPr>
-                        <a:t>Kp, Ki, Kd calculated with the SIMC tuning rule</a:t>
+                        <a:t>Kp, Ki, Kd from the SIMC tuning rule</a:t>
                       </a:r>
                       <a:endParaRPr lang="en-US" sz="1300" dirty="0">
                         <a:latin typeface="Arial" charset="0"/>
@@ -3933,7 +3933,7 @@
                           <a:ea typeface="Arial" pitchFamily="34" charset="-122"/>
                           <a:cs typeface="Arial" pitchFamily="34" charset="-120"/>
                         </a:rPr>
-                        <a:t>Load step 30 → 80 %: peak, offset and settling time</a:t>
+                        <a:t>Load step 30 → 70 %: peak, offset and settling time</a:t>
                       </a:r>
                       <a:endParaRPr lang="en-US" sz="1300" dirty="0">
                         <a:latin typeface="Arial" charset="0"/>
@@ -4687,7 +4687,7 @@
                           <a:ea typeface="Arial" pitchFamily="34" charset="-122"/>
                           <a:cs typeface="Arial" pitchFamily="34" charset="-120"/>
                         </a:rPr>
-                        <a:t>P 0.375, I 0.0075, D 3, N 100; limits −0.8 to 2.2; clamping</a:t>
+                        <a:t>P 2.476, I 0.0439, D 22.35, N 100; limits −1.58 to 2.92</a:t>
                       </a:r>
                       <a:endParaRPr lang="en-US" sz="1300" dirty="0">
                         <a:latin typeface="Arial" charset="0"/>
@@ -4825,7 +4825,7 @@
                           <a:ea typeface="Arial" pitchFamily="34" charset="-122"/>
                           <a:cs typeface="Arial" pitchFamily="34" charset="-120"/>
                         </a:rPr>
-                        <a:t>Cooling path: −20 / (600s² + 70s + 1)</a:t>
+                        <a:t>Fan path: −38.09 / (9611s² + 862.8s + 1)</a:t>
                       </a:r>
                       <a:endParaRPr lang="en-US" sz="1300" dirty="0">
                         <a:latin typeface="Arial" charset="0"/>
@@ -4963,7 +4963,7 @@
                           <a:ea typeface="Arial" pitchFamily="34" charset="-122"/>
                           <a:cs typeface="Arial" pitchFamily="34" charset="-120"/>
                         </a:rPr>
-                        <a:t>Load +50 % at 600 s through 0.6 / (60s + 1)</a:t>
+                        <a:t>Load +40 % at 600 s through 2.0 / (851.5s + 1)</a:t>
                       </a:r>
                       <a:endParaRPr lang="en-US" sz="1300" dirty="0">
                         <a:latin typeface="Arial" charset="0"/>
@@ -5239,7 +5239,7 @@
                           <a:ea typeface="Arial" pitchFamily="34" charset="-122"/>
                           <a:cs typeface="Arial" pitchFamily="34" charset="-120"/>
                         </a:rPr>
-                        <a:t>Cooling command y = 0.8 + PID output</a:t>
+                        <a:t>Fan air flow y = 1.58 + PID output [kg/s]</a:t>
                       </a:r>
                       <a:endParaRPr lang="en-US" sz="1300" dirty="0">
                         <a:latin typeface="Arial" charset="0"/>
@@ -5377,7 +5377,7 @@
                           <a:ea typeface="Arial" pitchFamily="34" charset="-122"/>
                           <a:cs typeface="Arial" pitchFamily="34" charset="-120"/>
                         </a:rPr>
-                        <a:t>T_c with the set-point, and the cooling command</a:t>
+                        <a:t>T_c with the set-point, and the fan air flow</a:t>
                       </a:r>
                       <a:endParaRPr lang="en-US" sz="1300" dirty="0">
                         <a:latin typeface="Arial" charset="0"/>
@@ -5588,7 +5588,7 @@
                 <a:ea typeface="Arial" pitchFamily="34" charset="-122"/>
                 <a:cs typeface="Arial" pitchFamily="34" charset="-120"/>
               </a:rPr>
-              <a:t>EXPERIMENT 2 · LOAD STEP 30 % → 80 %</a:t>
+              <a:t>EXPERIMENT 2 · LOAD STEP 30 % → 70 %</a:t>
             </a:r>
             <a:endParaRPr lang="en-US" sz="1200" dirty="0"/>
           </a:p>
@@ -6115,7 +6115,7 @@
                           <a:ea typeface="Arial" pitchFamily="34" charset="-122"/>
                           <a:cs typeface="Arial" pitchFamily="34" charset="-120"/>
                         </a:rPr>
-                        <a:t>4.9 K</a:t>
+                        <a:t>1.18 K</a:t>
                       </a:r>
                       <a:endParaRPr lang="en-US" sz="1300" dirty="0">
                         <a:latin typeface="Arial" charset="0"/>
@@ -6183,7 +6183,7 @@
                           <a:ea typeface="Arial" pitchFamily="34" charset="-122"/>
                           <a:cs typeface="Arial" pitchFamily="34" charset="-120"/>
                         </a:rPr>
-                        <a:t>31 s</a:t>
+                        <a:t>39 s</a:t>
                       </a:r>
                       <a:endParaRPr lang="en-US" sz="1300" dirty="0">
                         <a:latin typeface="Arial" charset="0"/>
@@ -6251,7 +6251,7 @@
                           <a:ea typeface="Arial" pitchFamily="34" charset="-122"/>
                           <a:cs typeface="Arial" pitchFamily="34" charset="-120"/>
                         </a:rPr>
-                        <a:t>3.5 K</a:t>
+                        <a:t>0.84 K</a:t>
                       </a:r>
                       <a:endParaRPr lang="en-US" sz="1300" dirty="0">
                         <a:latin typeface="Arial" charset="0"/>
@@ -6389,7 +6389,7 @@
                           <a:ea typeface="Arial" pitchFamily="34" charset="-122"/>
                           <a:cs typeface="Arial" pitchFamily="34" charset="-120"/>
                         </a:rPr>
-                        <a:t>4.6 K</a:t>
+                        <a:t>1.10 K</a:t>
                       </a:r>
                       <a:endParaRPr lang="en-US" sz="1300" dirty="0">
                         <a:latin typeface="Arial" charset="0"/>
@@ -6457,7 +6457,7 @@
                           <a:ea typeface="Arial" pitchFamily="34" charset="-122"/>
                           <a:cs typeface="Arial" pitchFamily="34" charset="-120"/>
                         </a:rPr>
-                        <a:t>99 s</a:t>
+                        <a:t>112 s</a:t>
                       </a:r>
                       <a:endParaRPr lang="en-US" sz="1300" dirty="0">
                         <a:latin typeface="Arial" charset="0"/>
@@ -6663,7 +6663,7 @@
                           <a:ea typeface="Arial" pitchFamily="34" charset="-122"/>
                           <a:cs typeface="Arial" pitchFamily="34" charset="-120"/>
                         </a:rPr>
-                        <a:t>3.3 K</a:t>
+                        <a:t>0.77 K</a:t>
                       </a:r>
                       <a:endParaRPr lang="en-US" sz="1300" dirty="0">
                         <a:latin typeface="Arial" charset="0"/>
@@ -6731,7 +6731,7 @@
                           <a:ea typeface="Arial" pitchFamily="34" charset="-122"/>
                           <a:cs typeface="Arial" pitchFamily="34" charset="-120"/>
                         </a:rPr>
-                        <a:t>99 s</a:t>
+                        <a:t>104 s</a:t>
                       </a:r>
                       <a:endParaRPr lang="en-US" sz="1300" dirty="0">
                         <a:latin typeface="Arial" charset="0"/>
@@ -6901,7 +6901,7 @@
                 <a:ea typeface="Arial" pitchFamily="34" charset="-122"/>
                 <a:cs typeface="Arial" pitchFamily="34" charset="-120"/>
               </a:rPr>
-              <a:t>3.5 K too hot</a:t>
+              <a:t>0.8 K too hot</a:t>
             </a:r>
             <a:r>
               <a:rPr lang="en-US" sz="1400" dirty="0">
@@ -6912,7 +6912,7 @@
                 <a:ea typeface="Arial" pitchFamily="34" charset="-122"/>
                 <a:cs typeface="Arial" pitchFamily="34" charset="-120"/>
               </a:rPr>
-              <a:t>. Adding I brings it back to exactly 90 °C. Adding D cuts the peak by about 28 %.</a:t>
+              <a:t>. Adding I brings it back to exactly 90 °C. Adding D cuts the peak by about 30 %.</a:t>
             </a:r>
             <a:endParaRPr lang="en-US" sz="1400" dirty="0"/>
           </a:p>
@@ -7238,7 +7238,7 @@
                 <a:ea typeface="Arial" pitchFamily="34" charset="-122"/>
                 <a:cs typeface="Arial" pitchFamily="34" charset="-120"/>
               </a:rPr>
-              <a:t>PID reaches 95 °C with 3.3 % overshoot and settles in about 78 s.</a:t>
+              <a:t>PID reaches 95 °C with 12.6 % overshoot and settles in about 121 s.</a:t>
             </a:r>
             <a:endParaRPr lang="en-US" sz="1300" dirty="0"/>
           </a:p>
@@ -7326,7 +7326,7 @@
                 <a:ea typeface="Arial" pitchFamily="34" charset="-122"/>
                 <a:cs typeface="Arial" pitchFamily="34" charset="-120"/>
               </a:rPr>
-              <a:t>Stops at 94.4 °C, a 0.6 K offset. PI and PID remove it.</a:t>
+              <a:t>Stops 0.05 K short. PI removes that but overshoots 41 %.</a:t>
             </a:r>
             <a:endParaRPr lang="en-US" sz="1300" dirty="0"/>
           </a:p>
@@ -7630,7 +7630,7 @@
                 <a:ea typeface="Arial" pitchFamily="34" charset="-122"/>
                 <a:cs typeface="Arial" pitchFamily="34" charset="-120"/>
               </a:rPr>
-              <a:t>PID holds 90 °C with zero offset. P only, like today's wax thermostat, stays 3.5 K too hot. D cuts the peak by about 28 %.</a:t>
+              <a:t>PID holds 90 °C with zero offset. P only, like today's wax thermostat, stays 0.8 K too hot. D cuts the peak by about 30 %.</a:t>
             </a:r>
             <a:endParaRPr lang="en-US" sz="1300" dirty="0"/>
           </a:p>
@@ -7768,7 +7768,7 @@
                 <a:ea typeface="Arial" pitchFamily="34" charset="-122"/>
                 <a:cs typeface="Arial" pitchFamily="34" charset="-120"/>
               </a:rPr>
-              <a:t>Linear model with one temperature: no oil, no separate valve, pump and fan. Plant values are assumed (slide 15).</a:t>
+              <a:t>Linear, one lumped mass, fan only. Data from published sources (slide 15), not our own tests.</a:t>
             </a:r>
             <a:endParaRPr lang="en-US" sz="1300" dirty="0"/>
           </a:p>
@@ -8945,7 +8945,7 @@
                 <a:ea typeface="Arial" pitchFamily="34" charset="-122"/>
                 <a:cs typeface="Arial" pitchFamily="34" charset="-120"/>
               </a:rPr>
-              <a:t>Model, assumptions and references</a:t>
+              <a:t>Data sources and references</a:t>
             </a:r>
             <a:endParaRPr lang="en-US" sz="3200" dirty="0"/>
           </a:p>
@@ -8998,7 +8998,7 @@
                           <a:ea typeface="Arial" pitchFamily="34" charset="-122"/>
                           <a:cs typeface="Arial" pitchFamily="34" charset="-120"/>
                         </a:rPr>
-                        <a:t>Item</a:t>
+                        <a:t>Value</a:t>
                       </a:r>
                       <a:endParaRPr lang="en-US" sz="1300" dirty="0">
                         <a:latin typeface="Arial" charset="0"/>
@@ -9142,7 +9142,7 @@
                           <a:ea typeface="Arial" pitchFamily="34" charset="-122"/>
                           <a:cs typeface="Arial" pitchFamily="34" charset="-120"/>
                         </a:rPr>
-                        <a:t>First-order thermal model K/(τs + 1)</a:t>
+                        <a:t>338 kW, 1121 kg, 38 L coolant, 33 L oil</a:t>
                       </a:r>
                       <a:endParaRPr lang="en-US" sz="1300" dirty="0">
                         <a:latin typeface="Arial" charset="0"/>
@@ -9210,7 +9210,7 @@
                           <a:ea typeface="Arial" pitchFamily="34" charset="-122"/>
                           <a:cs typeface="Arial" pitchFamily="34" charset="-120"/>
                         </a:rPr>
-                        <a:t>Ogata, Modern Control Engineering (thermal systems)</a:t>
+                        <a:t>Volvo D13C460 engine fact sheet (2010)</a:t>
                       </a:r>
                       <a:endParaRPr lang="en-US" sz="1300" dirty="0">
                         <a:latin typeface="Arial" charset="0"/>
@@ -9280,7 +9280,7 @@
                           <a:ea typeface="Arial" pitchFamily="34" charset="-122"/>
                           <a:cs typeface="Arial" pitchFamily="34" charset="-120"/>
                         </a:rPr>
-                        <a:t>τc 60 s, τr 10 s, K 20 and 0.6, y0 0.8</a:t>
+                        <a:t>Q = 0.5·P, 3.25 kg/s, 100/30 °C, fan 4.5 kg/s</a:t>
                       </a:r>
                       <a:endParaRPr lang="en-US" sz="1300" dirty="0">
                         <a:latin typeface="Arial" charset="0"/>
@@ -9348,7 +9348,7 @@
                           <a:ea typeface="Arial" pitchFamily="34" charset="-122"/>
                           <a:cs typeface="Arial" pitchFamily="34" charset="-120"/>
                         </a:rPr>
-                        <a:t>Assumed example values, not measured</a:t>
+                        <a:t>Rosa et al., COBEM 2009 (trucks and buses)</a:t>
                       </a:r>
                       <a:endParaRPr lang="en-US" sz="1300" dirty="0">
                         <a:latin typeface="Arial" charset="0"/>
@@ -9418,7 +9418,7 @@
                           <a:ea typeface="Arial" pitchFamily="34" charset="-122"/>
                           <a:cs typeface="Arial" pitchFamily="34" charset="-120"/>
                         </a:rPr>
-                        <a:t>Kp 0.375, Ki 0.0075, Kd 3.0</a:t>
+                        <a:t>C·dT/dt = Q_in − ε·m_f·c_p·(T − T_air)</a:t>
                       </a:r>
                       <a:endParaRPr lang="en-US" sz="1300" dirty="0">
                         <a:latin typeface="Arial" charset="0"/>
@@ -9486,7 +9486,7 @@
                           <a:ea typeface="Arial" pitchFamily="34" charset="-122"/>
                           <a:cs typeface="Arial" pitchFamily="34" charset="-120"/>
                         </a:rPr>
-                        <a:t>SIMC rule: Skogestad, J. Process Control 13 (2003)</a:t>
+                        <a:t>Mohamed et al., IOSR J. Eng. 8(6), 2018</a:t>
                       </a:r>
                       <a:endParaRPr lang="en-US" sz="1300" dirty="0">
                         <a:latin typeface="Arial" charset="0"/>
@@ -9556,7 +9556,7 @@
                           <a:ea typeface="Arial" pitchFamily="34" charset="-122"/>
                           <a:cs typeface="Arial" pitchFamily="34" charset="-120"/>
                         </a:rPr>
-                        <a:t>Closed-loop time τcl = 10 s</a:t>
+                        <a:t>Block + coolant + oil as one mass</a:t>
                       </a:r>
                       <a:endParaRPr lang="en-US" sz="1300" dirty="0">
                         <a:latin typeface="Arial" charset="0"/>
@@ -9624,7 +9624,7 @@
                           <a:ea typeface="Arial" pitchFamily="34" charset="-122"/>
                           <a:cs typeface="Arial" pitchFamily="34" charset="-120"/>
                         </a:rPr>
-                        <a:t>Our choice, equal to the radiator lag</a:t>
+                        <a:t>Haury &amp; Volkering, Chalmers thesis, 2011</a:t>
                       </a:r>
                       <a:endParaRPr lang="en-US" sz="1300" dirty="0">
                         <a:latin typeface="Arial" charset="0"/>
@@ -9694,7 +9694,7 @@
                           <a:ea typeface="Arial" pitchFamily="34" charset="-122"/>
                           <a:cs typeface="Arial" pitchFamily="34" charset="-120"/>
                         </a:rPr>
-                        <a:t>Derivative filter N = 100</a:t>
+                        <a:t>c_p and density of iron, water, oil, air</a:t>
                       </a:r>
                       <a:endParaRPr lang="en-US" sz="1300" dirty="0">
                         <a:latin typeface="Arial" charset="0"/>
@@ -9762,7 +9762,7 @@
                           <a:ea typeface="Arial" pitchFamily="34" charset="-122"/>
                           <a:cs typeface="Arial" pitchFamily="34" charset="-120"/>
                         </a:rPr>
-                        <a:t>Simulink PID Controller default value</a:t>
+                        <a:t>Engineering ToolBox property tables</a:t>
                       </a:r>
                       <a:endParaRPr lang="en-US" sz="1300" dirty="0">
                         <a:latin typeface="Arial" charset="0"/>
@@ -9832,7 +9832,7 @@
                           <a:ea typeface="Arial" pitchFamily="34" charset="-122"/>
                           <a:cs typeface="Arial" pitchFamily="34" charset="-120"/>
                         </a:rPr>
-                        <a:t>Rise, peak, overshoot, settling time</a:t>
+                        <a:t>Kp, Ki, Kd (τ_cl = loop delay)</a:t>
                       </a:r>
                       <a:endParaRPr lang="en-US" sz="1300" dirty="0">
                         <a:latin typeface="Arial" charset="0"/>
@@ -9900,7 +9900,7 @@
                           <a:ea typeface="Arial" pitchFamily="34" charset="-122"/>
                           <a:cs typeface="Arial" pitchFamily="34" charset="-120"/>
                         </a:rPr>
-                        <a:t>stepinfo() and our time-domain lab notes</a:t>
+                        <a:t>SIMC: Skogestad, J. Process Control 13 (2003)</a:t>
                       </a:r>
                       <a:endParaRPr lang="en-US" sz="1300" dirty="0">
                         <a:latin typeface="Arial" charset="0"/>
@@ -9970,7 +9970,7 @@
                           <a:ea typeface="Arial" pitchFamily="34" charset="-122"/>
                           <a:cs typeface="Arial" pitchFamily="34" charset="-120"/>
                         </a:rPr>
-                        <a:t>P offset, I removes it</a:t>
+                        <a:t>N = 100; final value theorem</a:t>
                       </a:r>
                       <a:endParaRPr lang="en-US" sz="1300" dirty="0">
                         <a:latin typeface="Arial" charset="0"/>
@@ -10038,7 +10038,7 @@
                           <a:ea typeface="Arial" pitchFamily="34" charset="-122"/>
                           <a:cs typeface="Arial" pitchFamily="34" charset="-120"/>
                         </a:rPr>
-                        <a:t>Final value theorem: Nise, Control Systems Engineering</a:t>
+                        <a:t>Simulink PID default; Nise, Control Systems Eng.</a:t>
                       </a:r>
                       <a:endParaRPr lang="en-US" sz="1300" dirty="0">
                         <a:latin typeface="Arial" charset="0"/>
@@ -13344,7 +13344,7 @@
                 <a:ea typeface="Arial" pitchFamily="34" charset="-122"/>
                 <a:cs typeface="Arial" pitchFamily="34" charset="-120"/>
               </a:rPr>
-              <a:t>Not a separate state. Modelled as a 10 s lag between the cooling command and the engine.</a:t>
+              <a:t>Not a separate state. Coolant takes 11.3 s to go round the loop: a short lag.</a:t>
             </a:r>
             <a:endParaRPr lang="en-US" sz="1300" dirty="0"/>
           </a:p>
@@ -13503,7 +13503,7 @@
                 <a:ea typeface="Arial" pitchFamily="34" charset="-122"/>
                 <a:cs typeface="Arial" pitchFamily="34" charset="-120"/>
               </a:rPr>
-              <a:t>Left out of the simple model. It changes too slowly to matter for the PID.</a:t>
+              <a:t>Lumped with the block and coolant into one heat capacity (Chalmers, 2011).</a:t>
             </a:r>
             <a:endParaRPr lang="en-US" sz="1300" dirty="0"/>
           </a:p>
@@ -13569,7 +13569,7 @@
                 <a:ea typeface="Arial" pitchFamily="34" charset="-122"/>
                 <a:cs typeface="Arial" pitchFamily="34" charset="-120"/>
               </a:rPr>
-              <a:t>. The engine block adds a 60 s lag. In the code the only output is </a:t>
+              <a:t>. Block, coolant and oil act as one mass with an 851 s lag. The output is </a:t>
             </a:r>
             <a:r>
               <a:rPr lang="en-US" sz="1400" dirty="0">
@@ -13828,7 +13828,7 @@
                 <a:ea typeface="Courier New" pitchFamily="49" charset="-122"/>
                 <a:cs typeface="Courier New" pitchFamily="49" charset="-120"/>
               </a:rPr>
-              <a:t>G(s)  = 20 / ((60s + 1)(10s + 1))</a:t>
+              <a:t>G(s)  = 38.1 / ((851s + 1)(11.3s + 1))</a:t>
             </a:r>
             <a:endParaRPr lang="en-US" sz="1500" dirty="0"/>
           </a:p>
@@ -13872,7 +13872,7 @@
                 <a:ea typeface="Arial" pitchFamily="34" charset="-122"/>
                 <a:cs typeface="Arial" pitchFamily="34" charset="-120"/>
               </a:rPr>
-              <a:t>Cooling path: one more unit of cooling command lowers T_c by 20 K, through the radiator and engine lags</a:t>
+              <a:t>Fan path: 1 kg/s more fan air lowers T_c by 38 K, through the loop delay and the engine lag</a:t>
             </a:r>
             <a:endParaRPr lang="en-US" sz="1300" dirty="0"/>
           </a:p>
@@ -13943,7 +13943,7 @@
                 <a:ea typeface="Courier New" pitchFamily="49" charset="-122"/>
                 <a:cs typeface="Courier New" pitchFamily="49" charset="-120"/>
               </a:rPr>
-              <a:t>Gd(s) = 0.6 / (60s + 1)</a:t>
+              <a:t>Gd(s) = 2.0 / (851s + 1)</a:t>
             </a:r>
             <a:endParaRPr lang="en-US" sz="1500" dirty="0"/>
           </a:p>
@@ -13987,7 +13987,7 @@
                 <a:ea typeface="Arial" pitchFamily="34" charset="-122"/>
                 <a:cs typeface="Arial" pitchFamily="34" charset="-120"/>
               </a:rPr>
-              <a:t>Load path: 1 % more engine load raises T_c by 0.6 K, through the engine lag only</a:t>
+              <a:t>Load path: 1 % more engine load raises T_c by 2.0 K, through the engine lag only</a:t>
             </a:r>
             <a:endParaRPr lang="en-US" sz="1300" dirty="0"/>
           </a:p>
@@ -14102,7 +14102,7 @@
                 <a:ea typeface="Arial" pitchFamily="34" charset="-122"/>
                 <a:cs typeface="Arial" pitchFamily="34" charset="-120"/>
               </a:rPr>
-              <a:t>Linearised around 90 °C and 30 % load, where the cooling command is y0 = 0.8</a:t>
+              <a:t>Linearised at 90 °C, 30 % load and 30 °C air, where the fan air flow is y0 = 1.58 kg/s</a:t>
             </a:r>
             <a:endParaRPr lang="en-US" sz="1300" dirty="0"/>
           </a:p>
@@ -14146,7 +14146,7 @@
                 <a:ea typeface="Arial" pitchFamily="34" charset="-122"/>
                 <a:cs typeface="Arial" pitchFamily="34" charset="-120"/>
               </a:rPr>
-              <a:t>Δy = change in cooling command (scale 0–3) · ΔL = change in engine load [%] · assumed example values (slide 15)</a:t>
+              <a:t>Data: Volvo D13 fact sheet, COBEM 2009, IOSR 2018, Chalmers 2011, Engineering ToolBox (slide 15)</a:t>
             </a:r>
             <a:endParaRPr lang="en-US" sz="1300" dirty="0"/>
           </a:p>
@@ -15114,7 +15114,7 @@
                 <a:ea typeface="Arial" pitchFamily="34" charset="-122"/>
                 <a:cs typeface="Arial" pitchFamily="34" charset="-120"/>
               </a:rPr>
-              <a:t>One output y (0–3) for three actuators. The model only limits y to 0–3:</a:t>
+              <a:t>Our model drives the fan only (0–4.5 kg/s of air). Full split range:</a:t>
             </a:r>
             <a:endParaRPr lang="en-US" sz="1300" dirty="0"/>
           </a:p>
@@ -16024,7 +16024,7 @@
                 <a:ea typeface="Arial" pitchFamily="34" charset="-122"/>
                 <a:cs typeface="Arial" pitchFamily="34" charset="-120"/>
               </a:rPr>
-              <a:t>Kp = 0.375</a:t>
+              <a:t>Kp = 2.48</a:t>
             </a:r>
             <a:endParaRPr lang="en-US" sz="1400" dirty="0"/>
           </a:p>
@@ -16072,7 +16072,7 @@
                 <a:ea typeface="Arial" pitchFamily="34" charset="-122"/>
                 <a:cs typeface="Arial" pitchFamily="34" charset="-120"/>
               </a:rPr>
-              <a:t>Ki = 0.0075</a:t>
+              <a:t>Ki = 0.044</a:t>
             </a:r>
             <a:endParaRPr lang="en-US" sz="1400" dirty="0"/>
           </a:p>
@@ -16120,7 +16120,7 @@
                 <a:ea typeface="Arial" pitchFamily="34" charset="-122"/>
                 <a:cs typeface="Arial" pitchFamily="34" charset="-120"/>
               </a:rPr>
-              <a:t>Kd = 3.0</a:t>
+              <a:t>Kd = 22.4</a:t>
             </a:r>
             <a:endParaRPr lang="en-US" sz="1400" dirty="0"/>
           </a:p>

</xml_diff>

<commit_message>
Remove Simulink from the deck and match it to the simple load-step script
Co-Authored-By: Claude Opus 5.5 <noreply@anthropic.com>
Claude-Session: https://claude.ai/code/session_01KYcVruEhgF1vnL4e2wj7fD
</commit_message>
<xml_diff>
--- a/PID_Thermal_Control_for_Heavy-Duty_Trucks_v2.pptx
+++ b/PID_Thermal_Control_for_Heavy-Duty_Trucks_v2.pptx
@@ -15,7 +15,6 @@
     <p:sldId id="263" r:id="rId9"/>
     <p:sldId id="264" r:id="rId10"/>
     <p:sldId id="265" r:id="rId11"/>
-    <p:sldId id="266" r:id="rId12"/>
     <p:sldId id="269" r:id="rId15"/>
     <p:sldId id="267" r:id="rId13"/>
     <p:sldId id="273" r:id="rId19"/>
@@ -517,7 +516,7 @@
           <a:p>
             <a:r>
               <a:rPr lang="en-US" dirty="0"/>
-              <a:t>Introduce the team and the topic. One line: "Our project is about controlling the temperature of a heavy-duty truck engine. We modelled the engine's cooling system in MATLAB and Simulink and designed a PID controller that keeps the engine at 90 °C, then compared it with the cooling system trucks use today."</a:t>
+              <a:t>Introduce the team and the topic. One line: "Our project is about controlling the temperature of a heavy-duty truck engine. We modelled the engine's cooling system in MATLAB and showed how a PID controller keeps the engine at 90 °C when the load goes up."</a:t>
             </a:r>
             <a:endParaRPr lang="en-US" dirty="0"/>
           </a:p>
@@ -605,7 +604,7 @@
           <a:p>
             <a:r>
               <a:rPr lang="en-US" dirty="0"/>
-              <a:t>All the MATLAB code is in one file, pid_truck_cooling.m, split into sections. The first section lists every published number with a reference tag in square brackets. The next section calculates the heat capacity, time constants and gains from those numbers with the energy balance, and the PID gains with the SIMC rule, so no number is typed in without a source. Then the plant transfer functions are defined with num, den and tf, and the three controllers P, PI and PID. feedback() closes the loop, and pole() prints the closed-loop poles: all of them are in the left half of the s-plane, so all three loops are stable. Experiment 1 is a set-point step analysed with step() and stepinfo(). Experiment 2 is a load step, where we find the settling time by walking backwards from the end of the response, the same method as in the time-domain lab.</a:t>
+              <a:t>All the MATLAB code is one short file, pid_truck_cooling.m. It defines the two plant transfer functions with num, den and tf, and the PID by adding three transfer functions. Then it runs one test twice: the engine load steps from 30 to 70 percent, first with no controller using step on Gd, then with the PID using Gd times feedback of 1 and C times G. It plots the two responses, prints the temperatures, and uses pole() to check that all closed-loop poles are negative, so the loop is stable.</a:t>
             </a:r>
             <a:endParaRPr lang="en-US" dirty="0"/>
           </a:p>
@@ -629,94 +628,6 @@
             <a:fld id="{F7021451-1387-4CA6-816F-3879F97B5CBC}" type="slidenum">
               <a:rPr lang="en-US"/>
               <a:t>10</a:t>
-            </a:fld>
-            <a:endParaRPr lang="en-US"/>
-          </a:p>
-        </p:txBody>
-      </p:sp>
-    </p:spTree>
-    <p:extLst>
-      <p:ext uri="{BB962C8B-B14F-4D97-AF65-F5344CB8AC3E}">
-        <p14:creationId xmlns:p14="http://schemas.microsoft.com/office/powerpoint/2010/main" val="1024086991"/>
-      </p:ext>
-    </p:extLst>
-  </p:cSld>
-  <p:clrMapOvr>
-    <a:masterClrMapping/>
-  </p:clrMapOvr>
-</p:notes>
-</file>
-
-<file path=ppt/notesSlides/notesSlide11.xml><?xml version="1.0" encoding="utf-8"?>
-<p:notes xmlns:a="http://schemas.openxmlformats.org/drawingml/2006/main" xmlns:r="http://schemas.openxmlformats.org/officeDocument/2006/relationships" xmlns:p="http://schemas.openxmlformats.org/presentationml/2006/main">
-  <p:cSld>
-    <p:spTree>
-      <p:nvGrpSpPr>
-        <p:cNvPr id="1" name=""/>
-        <p:cNvGrpSpPr/>
-        <p:nvPr/>
-      </p:nvGrpSpPr>
-      <p:grpSpPr>
-        <a:xfrm>
-          <a:off x="0" y="0"/>
-          <a:ext cx="0" cy="0"/>
-          <a:chOff x="0" y="0"/>
-          <a:chExt cx="0" cy="0"/>
-        </a:xfrm>
-      </p:grpSpPr>
-      <p:sp>
-        <p:nvSpPr>
-          <p:cNvPr id="2" name="Slide Image Placeholder 1"/>
-          <p:cNvSpPr>
-            <a:spLocks noGrp="1" noRot="1" noChangeAspect="1"/>
-          </p:cNvSpPr>
-          <p:nvPr>
-            <p:ph type="sldImg"/>
-          </p:nvPr>
-        </p:nvSpPr>
-        <p:spPr/>
-      </p:sp>
-      <p:sp>
-        <p:nvSpPr>
-          <p:cNvPr id="3" name="Notes Placeholder 2"/>
-          <p:cNvSpPr>
-            <a:spLocks noGrp="1"/>
-          </p:cNvSpPr>
-          <p:nvPr>
-            <p:ph type="body" idx="1"/>
-          </p:nvPr>
-        </p:nvSpPr>
-        <p:spPr/>
-        <p:txBody>
-          <a:bodyPr/>
-          <a:lstStyle/>
-          <a:p>
-            <a:r>
-              <a:rPr lang="en-US" dirty="0"/>
-              <a:t>We built the same loop by hand in Simulink. The Step block gives the set-point, 90 °C, stepping to 95 °C at 1200 seconds. The Sum block subtracts the set-point from the coolant temperature to get the error. The PID Controller block has the same SIMC gains as the MATLAB code, Simulink's default filter coefficient of 100, output limits and clamping anti-windup. The limits are minus 1.58 and 2.92 because the block outputs the change from the normal fan flow of 1.58 kg per second, so the real fan flow stays between 0 and 4.5. The fan transfer function has a minus sign because more air lowers the temperature. A second Step adds 40 % engine load at 600 seconds through Gd(s). The plant output is 90 plus the two effects, and it is fed back to the error block. The Scope shows the temperature and the fan air flow. [Add a screenshot of the model and the Scope here.]</a:t>
-            </a:r>
-            <a:endParaRPr lang="en-US" dirty="0"/>
-          </a:p>
-        </p:txBody>
-      </p:sp>
-      <p:sp>
-        <p:nvSpPr>
-          <p:cNvPr id="4" name="Slide Number Placeholder 3"/>
-          <p:cNvSpPr>
-            <a:spLocks noGrp="1"/>
-          </p:cNvSpPr>
-          <p:nvPr>
-            <p:ph type="sldNum" sz="quarter" idx="10"/>
-          </p:nvPr>
-        </p:nvSpPr>
-        <p:spPr/>
-        <p:txBody>
-          <a:bodyPr/>
-          <a:lstStyle/>
-          <a:p>
-            <a:fld id="{F7021451-1387-4CA6-816F-3879F97B5CBC}" type="slidenum">
-              <a:rPr lang="en-US"/>
-              <a:t>11</a:t>
             </a:fld>
             <a:endParaRPr lang="en-US"/>
           </a:p>
@@ -781,7 +692,7 @@
           <a:p>
             <a:r>
               <a:rPr lang="en-US" dirty="0"/>
-              <a:t>Second test, the one that matters most for a truck. At time zero the engine load jumps from 30 to 70 percent, as if the truck hits a hill, which adds 68 kW of heat to the coolant. P only settles about 0.8 degrees too hot and stays there: that is the steady-state offset the final value theorem predicts, 40 × 2.0 / (1 + 2.48 × 38.1). It is also why today's wax thermostat, which is a mechanical P controller, never reaches its target. Adding the integral term brings the temperature back to exactly 90 °C in under two minutes. Adding the derivative term cuts the peak from 1.10 to 0.77 K, about 30 % lower. Settling time here is the time to stay within ±0.1 K. During this test the PID raises the fan air flow from 1.58 to about 3.7 kg per second, peaking at 4.0, still below the fan's limit of 4.5.</a:t>
+              <a:t>Now the same load step with the PID. As soon as the temperature starts to rise, the PID increases the fan air flow, from 1.58 to about 3.7 kg per second. The temperature peaks only 0.77 K above 90 °C, and the integral term brings it back to exactly 90 °C, staying within 0.1 K after about 104 seconds. Compared with no control, that is 0.77 K instead of 79 K. The poles printed by pole() all have negative real parts, so the loop is stable.</a:t>
             </a:r>
             <a:endParaRPr lang="en-US" dirty="0"/>
           </a:p>
@@ -869,7 +780,7 @@
           <a:p>
             <a:r>
               <a:rPr lang="en-US" dirty="0"/>
-              <a:t>First test: we change the target from 90 to 95 °C and compare P only, PI and PID, using step() and stepinfo() in MATLAB. P only stops 0.05 K short of 95 °C: a small steady-state offset, small because the plant gain is large. PI removes the offset but overshoots by 41 %. The full PID removes the offset and cuts the overshoot to 12.6 %, settling within 2 % in about 121 seconds. The closed-loop poles printed by pole() all have negative real parts, so all three loops are stable.</a:t>
+              <a:t>First, what happens with no controller. The engine load jumps from 30 to 70 percent, which adds 68 kW of heat to the coolant, and the fan stays where it was. The temperature keeps climbing with the engine's 851-second time constant: after one hour it is at 169 °C, far above the 105 °C limit, and it would only stop at 90 plus 40 times 2, which is 170 °C. In a real engine the coolant would boil long before that. This is why the engine needs a controller.</a:t>
             </a:r>
             <a:endParaRPr lang="en-US" dirty="0"/>
           </a:p>
@@ -957,7 +868,7 @@
           <a:p>
             <a:r>
               <a:rPr lang="en-US" dirty="0"/>
-              <a:t>To conclude: the PID holds the engine at 90 °C with no steady-state offset. A P-only controller, which is how today's wax thermostat behaves, stays about 0.8 degrees too hot after a load step, and adding D cuts the temperature peak by about 30 %. The limitations: our model is linear, treats the engine as one lumped mass and only controls the fan. All numbers come from published sources, but from different engines and studies, not from our own tests. The next steps are measuring a real engine, adding the radiator and oil temperatures and the full split range, and then trying a predictive controller, MPC, which uses the road ahead to plan cooling.</a:t>
+              <a:t>To conclude: with no controller, a load step from 30 to 70 percent would push the engine towards 170 °C. With the PID, the temperature rises by less than 1 K and returns to exactly 90 °C in under two minutes. The limitations: our model is linear, treats the engine as one lumped mass and only controls the fan, and its numbers come from published sources rather than our own tests. The next steps are measuring a real engine, adding the radiator and oil temperatures, and trying a predictive controller, MPC, which uses the road ahead to plan cooling.</a:t>
             </a:r>
             <a:endParaRPr lang="en-US" dirty="0"/>
           </a:p>
@@ -1045,7 +956,7 @@
           <a:p>
             <a:r>
               <a:rPr lang="en-US" dirty="0"/>
-              <a:t>Likely questions. Where do the numbers come from? Every number in the code has a reference tag: the engine data from the Volvo D13 fact sheet, the heat rejection, radiator and fan data from the COBEM 2009 truck and bus paper, the model equations from Mohamed et al. 2018, the lumped-mass idea from a Chalmers thesis, material properties from Engineering ToolBox, and the PID gains from Skogestad's SIMC rule. Why is D useful here? It reacts to how fast the temperature is rising, so it acts early and cuts the peak by 30 %. Is the model validated? Not against our own engine tests; the data comes from different published sources. Why e = T_c minus T_ref? The fan removes heat, so hotter must give more air. Why does a P controller leave an offset? It needs a non-zero error to produce a non-zero output; the integral removes it.</a:t>
+              <a:t>Likely questions. Where do the numbers come from? Every number comes from the sources on slide 14: the engine from the Volvo D13 fact sheet, the heat and radiator data from the COBEM 2009 truck and bus paper, the model equations from Mohamed et al. 2018, and the PID gains from Skogestad's SIMC rule. Why does the engine overheat without control? The extra heat from the higher load has nowhere to go. How does the PID fix it? It increases the fan air flow as soon as the temperature rises, and the integral term keeps pushing until the temperature is exactly 90 °C again. Is the loop stable? Yes, all closed-loop poles have negative real parts. Is the model validated? Not against our own engine tests.</a:t>
             </a:r>
             <a:endParaRPr lang="en-US" dirty="0"/>
           </a:p>
@@ -1309,7 +1220,7 @@
           <a:p>
             <a:r>
               <a:rPr lang="en-US" dirty="0"/>
-              <a:t>Our method has four steps. First, model the cooling system: we start from the energy balance and simplify it to two transfer functions, one for the cooling command and one for the engine load. Second, design a PID controller with a derivative filter, an output limit and anti-windup. Third, simulate two classic tests in MATLAB, a set-point step and a load step, and build the same loop in Simulink. Fourth, compare P only, PI and PID using offset, peak and settling time.</a:t>
+              <a:t>Our method has four steps. First, model the cooling system: we start from the energy balance in a published paper and get two transfer functions, one for the fan and one for the engine load. Second, design a PID controller, with the gains calculated by the SIMC tuning rule. Third, simulate one test in MATLAB: the engine load jumps from 30 to 70 percent. Fourth, compare what happens to the temperature without a controller and with the PID.</a:t>
             </a:r>
             <a:endParaRPr lang="en-US" dirty="0"/>
           </a:p>
@@ -1749,7 +1660,7 @@
           <a:p>
             <a:r>
               <a:rPr lang="en-US" dirty="0"/>
-              <a:t>A textbook PID needs three additions on a real system. First, split range: in a full system one PID output is shared across valve, pump and fan in order of energy cost. In our model the pump runs at the fixed 3.25 kg per second from the COBEM paper and the PID drives the fan only, between 0 and 4.5 kg per second of air. Second, anti-windup: when the fan is at its limit, the integral stops adding up; in Simulink this is the clamping option of the PID block. Third, a filter on the derivative so sensor noise does not make the fan jitter; we use Simulink's default filter coefficient N = 100. The gains come from the SIMC tuning rule by Skogestad, 2003. Skogestad recommends a closed-loop time constant equal to the delay for tight control, so we use the 11.3-second loop time. The rule gives Kc = 851 / (38.1 × 11.3) = 1.98, integral time 4 × 11.3 = 45 seconds and derivative time 11.3 seconds. In parallel form that is Kp 2.48, Ki 0.044 and Kd 22.4, in kg/s of fan air per kelvin.</a:t>
+              <a:t>Three points about our PID. First, in a full system one PID output would be shared across valve, pump and fan; in our model the pump runs at a fixed 3.25 kg per second and the PID drives the fan only, between 0 and 4.5 kg per second of air. Second, the gains come from the SIMC tuning rule by Skogestad, 2003, which calculates them from the plant's time constants and gain: Kp 2.48, Ki 0.044 and Kd 22.4, in kg/s of fan air per kelvin. Third, the derivative term has a small 0.01-second filter so it does not amplify sensor noise.</a:t>
             </a:r>
             <a:endParaRPr lang="en-US" dirty="0"/>
           </a:p>
@@ -2542,7 +2453,7 @@
                 <a:ea typeface="Arial" pitchFamily="34" charset="-122"/>
                 <a:cs typeface="Arial" pitchFamily="34" charset="-120"/>
               </a:rPr>
-              <a:t>modelled and simulated in MATLAB &amp; Simulink</a:t>
+              <a:t>modelled and simulated in MATLAB</a:t>
             </a:r>
             <a:endParaRPr lang="en-US" sz="1800" dirty="0"/>
           </a:p>
@@ -2840,7 +2751,7 @@
                 <a:ea typeface="Arial" pitchFamily="34" charset="-122"/>
                 <a:cs typeface="Arial" pitchFamily="34" charset="-120"/>
               </a:rPr>
-              <a:t>The MATLAB code, section by section</a:t>
+              <a:t>The MATLAB code, step by step</a:t>
             </a:r>
             <a:endParaRPr lang="en-US" sz="3200" dirty="0"/>
           </a:p>
@@ -3037,7 +2948,7 @@
                           <a:ea typeface="Arial" pitchFamily="34" charset="-122"/>
                           <a:cs typeface="Arial" pitchFamily="34" charset="-120"/>
                         </a:rPr>
-                        <a:t>Plant parameters</a:t>
+                        <a:t>Plant</a:t>
                       </a:r>
                       <a:endParaRPr lang="en-US" sz="1300" dirty="0">
                         <a:latin typeface="Arial" charset="0"/>
@@ -3068,282 +2979,6 @@
                     <a:lnT w="12700" cap="flat" cmpd="sng" algn="ctr">
                       <a:solidFill>
                         <a:srgbClr val="B6B5B2"/>
-                      </a:solidFill>
-                      <a:prstDash val="solid"/>
-                      <a:round/>
-                      <a:headEnd type="none" w="med" len="med"/>
-                      <a:tailEnd type="none" w="med" len="med"/>
-                    </a:lnT>
-                    <a:lnB w="12700" cap="flat" cmpd="sng" algn="ctr">
-                      <a:solidFill>
-                        <a:srgbClr val="C4C4C0"/>
-                      </a:solidFill>
-                      <a:prstDash val="solid"/>
-                      <a:round/>
-                      <a:headEnd type="none" w="med" len="med"/>
-                      <a:tailEnd type="none" w="med" len="med"/>
-                    </a:lnB>
-                  </a:tcPr>
-                </a:tc>
-                <a:tc>
-                  <a:txBody>
-                    <a:bodyPr/>
-                    <a:lstStyle/>
-                    <a:p>
-                      <a:pPr indent="0" marL="0">
-                        <a:lnSpc>
-                          <a:spcPts val="1820"/>
-                        </a:lnSpc>
-                        <a:buNone/>
-                      </a:pPr>
-                      <a:r>
-                        <a:rPr lang="en-US" sz="1300" dirty="0">
-                          <a:solidFill>
-                            <a:srgbClr val="15233B"/>
-                          </a:solidFill>
-                          <a:latin typeface="Arial" pitchFamily="34" charset="0"/>
-                          <a:ea typeface="Arial" pitchFamily="34" charset="-122"/>
-                          <a:cs typeface="Arial" pitchFamily="34" charset="-120"/>
-                        </a:rPr>
-                        <a:t>Published data → C, τ and K by energy balance</a:t>
-                      </a:r>
-                      <a:endParaRPr lang="en-US" sz="1300" dirty="0">
-                        <a:latin typeface="Arial" charset="0"/>
-                        <a:ea typeface="Arial" charset="0"/>
-                        <a:cs typeface="Arial" charset="0"/>
-                      </a:endParaRPr>
-                    </a:p>
-                  </a:txBody>
-                  <a:tcPr marL="57785" marR="57785" marT="57785" marB="57785" anchor="t">
-                    <a:lnL w="12700" cap="flat" cmpd="sng" algn="ctr">
-                      <a:solidFill>
-                        <a:srgbClr val="C4C4C0"/>
-                      </a:solidFill>
-                      <a:prstDash val="solid"/>
-                      <a:round/>
-                      <a:headEnd type="none" w="med" len="med"/>
-                      <a:tailEnd type="none" w="med" len="med"/>
-                    </a:lnL>
-                    <a:lnR w="12700" cap="flat" cmpd="sng" algn="ctr">
-                      <a:solidFill>
-                        <a:srgbClr val="C4C4C0"/>
-                      </a:solidFill>
-                      <a:prstDash val="solid"/>
-                      <a:round/>
-                      <a:headEnd type="none" w="med" len="med"/>
-                      <a:tailEnd type="none" w="med" len="med"/>
-                    </a:lnR>
-                    <a:lnT w="12700" cap="flat" cmpd="sng" algn="ctr">
-                      <a:solidFill>
-                        <a:srgbClr val="B6B5B2"/>
-                      </a:solidFill>
-                      <a:prstDash val="solid"/>
-                      <a:round/>
-                      <a:headEnd type="none" w="med" len="med"/>
-                      <a:tailEnd type="none" w="med" len="med"/>
-                    </a:lnT>
-                    <a:lnB w="12700" cap="flat" cmpd="sng" algn="ctr">
-                      <a:solidFill>
-                        <a:srgbClr val="C4C4C0"/>
-                      </a:solidFill>
-                      <a:prstDash val="solid"/>
-                      <a:round/>
-                      <a:headEnd type="none" w="med" len="med"/>
-                      <a:tailEnd type="none" w="med" len="med"/>
-                    </a:lnB>
-                  </a:tcPr>
-                </a:tc>
-              </a:tr>
-              <a:tr h="359370">
-                <a:tc>
-                  <a:txBody>
-                    <a:bodyPr/>
-                    <a:lstStyle/>
-                    <a:p>
-                      <a:pPr indent="0" marL="0">
-                        <a:lnSpc>
-                          <a:spcPts val="1820"/>
-                        </a:lnSpc>
-                        <a:buNone/>
-                      </a:pPr>
-                      <a:r>
-                        <a:rPr lang="en-US" sz="1300" dirty="0">
-                          <a:solidFill>
-                            <a:srgbClr val="15233B"/>
-                          </a:solidFill>
-                          <a:latin typeface="Arial" pitchFamily="34" charset="0"/>
-                          <a:ea typeface="Arial" pitchFamily="34" charset="-122"/>
-                          <a:cs typeface="Arial" pitchFamily="34" charset="-120"/>
-                        </a:rPr>
-                        <a:t>PID gains</a:t>
-                      </a:r>
-                      <a:endParaRPr lang="en-US" sz="1300" dirty="0">
-                        <a:latin typeface="Arial" charset="0"/>
-                        <a:ea typeface="Arial" charset="0"/>
-                        <a:cs typeface="Arial" charset="0"/>
-                      </a:endParaRPr>
-                    </a:p>
-                  </a:txBody>
-                  <a:tcPr marL="57785" marR="57785" marT="57785" marB="57785" anchor="t">
-                    <a:lnL w="12700" cap="flat" cmpd="sng" algn="ctr">
-                      <a:solidFill>
-                        <a:srgbClr val="C4C4C0"/>
-                      </a:solidFill>
-                      <a:prstDash val="solid"/>
-                      <a:round/>
-                      <a:headEnd type="none" w="med" len="med"/>
-                      <a:tailEnd type="none" w="med" len="med"/>
-                    </a:lnL>
-                    <a:lnR w="12700" cap="flat" cmpd="sng" algn="ctr">
-                      <a:solidFill>
-                        <a:srgbClr val="C4C4C0"/>
-                      </a:solidFill>
-                      <a:prstDash val="solid"/>
-                      <a:round/>
-                      <a:headEnd type="none" w="med" len="med"/>
-                      <a:tailEnd type="none" w="med" len="med"/>
-                    </a:lnR>
-                    <a:lnT w="12700" cap="flat" cmpd="sng" algn="ctr">
-                      <a:solidFill>
-                        <a:srgbClr val="C4C4C0"/>
-                      </a:solidFill>
-                      <a:prstDash val="solid"/>
-                      <a:round/>
-                      <a:headEnd type="none" w="med" len="med"/>
-                      <a:tailEnd type="none" w="med" len="med"/>
-                    </a:lnT>
-                    <a:lnB w="12700" cap="flat" cmpd="sng" algn="ctr">
-                      <a:solidFill>
-                        <a:srgbClr val="C4C4C0"/>
-                      </a:solidFill>
-                      <a:prstDash val="solid"/>
-                      <a:round/>
-                      <a:headEnd type="none" w="med" len="med"/>
-                      <a:tailEnd type="none" w="med" len="med"/>
-                    </a:lnB>
-                  </a:tcPr>
-                </a:tc>
-                <a:tc>
-                  <a:txBody>
-                    <a:bodyPr/>
-                    <a:lstStyle/>
-                    <a:p>
-                      <a:pPr indent="0" marL="0">
-                        <a:lnSpc>
-                          <a:spcPts val="1820"/>
-                        </a:lnSpc>
-                        <a:buNone/>
-                      </a:pPr>
-                      <a:r>
-                        <a:rPr lang="en-US" sz="1300" dirty="0">
-                          <a:solidFill>
-                            <a:srgbClr val="15233B"/>
-                          </a:solidFill>
-                          <a:latin typeface="Arial" pitchFamily="34" charset="0"/>
-                          <a:ea typeface="Arial" pitchFamily="34" charset="-122"/>
-                          <a:cs typeface="Arial" pitchFamily="34" charset="-120"/>
-                        </a:rPr>
-                        <a:t>Kp, Ki, Kd from the SIMC tuning rule</a:t>
-                      </a:r>
-                      <a:endParaRPr lang="en-US" sz="1300" dirty="0">
-                        <a:latin typeface="Arial" charset="0"/>
-                        <a:ea typeface="Arial" charset="0"/>
-                        <a:cs typeface="Arial" charset="0"/>
-                      </a:endParaRPr>
-                    </a:p>
-                  </a:txBody>
-                  <a:tcPr marL="57785" marR="57785" marT="57785" marB="57785" anchor="t">
-                    <a:lnL w="12700" cap="flat" cmpd="sng" algn="ctr">
-                      <a:solidFill>
-                        <a:srgbClr val="C4C4C0"/>
-                      </a:solidFill>
-                      <a:prstDash val="solid"/>
-                      <a:round/>
-                      <a:headEnd type="none" w="med" len="med"/>
-                      <a:tailEnd type="none" w="med" len="med"/>
-                    </a:lnL>
-                    <a:lnR w="12700" cap="flat" cmpd="sng" algn="ctr">
-                      <a:solidFill>
-                        <a:srgbClr val="C4C4C0"/>
-                      </a:solidFill>
-                      <a:prstDash val="solid"/>
-                      <a:round/>
-                      <a:headEnd type="none" w="med" len="med"/>
-                      <a:tailEnd type="none" w="med" len="med"/>
-                    </a:lnR>
-                    <a:lnT w="12700" cap="flat" cmpd="sng" algn="ctr">
-                      <a:solidFill>
-                        <a:srgbClr val="C4C4C0"/>
-                      </a:solidFill>
-                      <a:prstDash val="solid"/>
-                      <a:round/>
-                      <a:headEnd type="none" w="med" len="med"/>
-                      <a:tailEnd type="none" w="med" len="med"/>
-                    </a:lnT>
-                    <a:lnB w="12700" cap="flat" cmpd="sng" algn="ctr">
-                      <a:solidFill>
-                        <a:srgbClr val="C4C4C0"/>
-                      </a:solidFill>
-                      <a:prstDash val="solid"/>
-                      <a:round/>
-                      <a:headEnd type="none" w="med" len="med"/>
-                      <a:tailEnd type="none" w="med" len="med"/>
-                    </a:lnB>
-                  </a:tcPr>
-                </a:tc>
-              </a:tr>
-              <a:tr h="359370">
-                <a:tc>
-                  <a:txBody>
-                    <a:bodyPr/>
-                    <a:lstStyle/>
-                    <a:p>
-                      <a:pPr indent="0" marL="0">
-                        <a:lnSpc>
-                          <a:spcPts val="1820"/>
-                        </a:lnSpc>
-                        <a:buNone/>
-                      </a:pPr>
-                      <a:r>
-                        <a:rPr lang="en-US" sz="1300" dirty="0">
-                          <a:solidFill>
-                            <a:srgbClr val="15233B"/>
-                          </a:solidFill>
-                          <a:latin typeface="Arial" pitchFamily="34" charset="0"/>
-                          <a:ea typeface="Arial" pitchFamily="34" charset="-122"/>
-                          <a:cs typeface="Arial" pitchFamily="34" charset="-120"/>
-                        </a:rPr>
-                        <a:t>Transfer functions</a:t>
-                      </a:r>
-                      <a:endParaRPr lang="en-US" sz="1300" dirty="0">
-                        <a:latin typeface="Arial" charset="0"/>
-                        <a:ea typeface="Arial" charset="0"/>
-                        <a:cs typeface="Arial" charset="0"/>
-                      </a:endParaRPr>
-                    </a:p>
-                  </a:txBody>
-                  <a:tcPr marL="57785" marR="57785" marT="57785" marB="57785" anchor="t">
-                    <a:lnL w="12700" cap="flat" cmpd="sng" algn="ctr">
-                      <a:solidFill>
-                        <a:srgbClr val="C4C4C0"/>
-                      </a:solidFill>
-                      <a:prstDash val="solid"/>
-                      <a:round/>
-                      <a:headEnd type="none" w="med" len="med"/>
-                      <a:tailEnd type="none" w="med" len="med"/>
-                    </a:lnL>
-                    <a:lnR w="12700" cap="flat" cmpd="sng" algn="ctr">
-                      <a:solidFill>
-                        <a:srgbClr val="C4C4C0"/>
-                      </a:solidFill>
-                      <a:prstDash val="solid"/>
-                      <a:round/>
-                      <a:headEnd type="none" w="med" len="med"/>
-                      <a:tailEnd type="none" w="med" len="med"/>
-                    </a:lnR>
-                    <a:lnT w="12700" cap="flat" cmpd="sng" algn="ctr">
-                      <a:solidFill>
-                        <a:srgbClr val="C4C4C0"/>
                       </a:solidFill>
                       <a:prstDash val="solid"/>
                       <a:round/>
@@ -3411,7 +3046,7 @@
                     </a:lnR>
                     <a:lnT w="12700" cap="flat" cmpd="sng" algn="ctr">
                       <a:solidFill>
-                        <a:srgbClr val="C4C4C0"/>
+                        <a:srgbClr val="B6B5B2"/>
                       </a:solidFill>
                       <a:prstDash val="solid"/>
                       <a:round/>
@@ -3451,7 +3086,7 @@
                           <a:ea typeface="Arial" pitchFamily="34" charset="-122"/>
                           <a:cs typeface="Arial" pitchFamily="34" charset="-120"/>
                         </a:rPr>
-                        <a:t>Controllers</a:t>
+                        <a:t>PID</a:t>
                       </a:r>
                       <a:endParaRPr lang="en-US" sz="1300" dirty="0">
                         <a:latin typeface="Arial" charset="0"/>
@@ -3519,7 +3154,7 @@
                           <a:ea typeface="Arial" pitchFamily="34" charset="-122"/>
                           <a:cs typeface="Arial" pitchFamily="34" charset="-120"/>
                         </a:rPr>
-                        <a:t>P, PI and PID built as transfer functions</a:t>
+                        <a:t>Kp + Ki/s + Kd·s, built by adding three tf</a:t>
                       </a:r>
                       <a:endParaRPr lang="en-US" sz="1300" dirty="0">
                         <a:latin typeface="Arial" charset="0"/>
@@ -3589,7 +3224,7 @@
                           <a:ea typeface="Arial" pitchFamily="34" charset="-122"/>
                           <a:cs typeface="Arial" pitchFamily="34" charset="-120"/>
                         </a:rPr>
-                        <a:t>Closed loop + poles</a:t>
+                        <a:t>No controller</a:t>
                       </a:r>
                       <a:endParaRPr lang="en-US" sz="1300" dirty="0">
                         <a:latin typeface="Arial" charset="0"/>
@@ -3657,7 +3292,7 @@
                           <a:ea typeface="Arial" pitchFamily="34" charset="-122"/>
                           <a:cs typeface="Arial" pitchFamily="34" charset="-120"/>
                         </a:rPr>
-                        <a:t>feedback() for set-point and load; pole() checks stability</a:t>
+                        <a:t>step(40*Gd): load 30 → 70 %, plot 1</a:t>
                       </a:r>
                       <a:endParaRPr lang="en-US" sz="1300" dirty="0">
                         <a:latin typeface="Arial" charset="0"/>
@@ -3727,7 +3362,7 @@
                           <a:ea typeface="Arial" pitchFamily="34" charset="-122"/>
                           <a:cs typeface="Arial" pitchFamily="34" charset="-120"/>
                         </a:rPr>
-                        <a:t>Experiment 1</a:t>
+                        <a:t>With PID</a:t>
                       </a:r>
                       <a:endParaRPr lang="en-US" sz="1300" dirty="0">
                         <a:latin typeface="Arial" charset="0"/>
@@ -3795,7 +3430,7 @@
                           <a:ea typeface="Arial" pitchFamily="34" charset="-122"/>
                           <a:cs typeface="Arial" pitchFamily="34" charset="-120"/>
                         </a:rPr>
-                        <a:t>Set-point step 90 → 95 °C with step() and stepinfo()</a:t>
+                        <a:t>Gd*feedback(1, C*G), step(), plot 2</a:t>
                       </a:r>
                       <a:endParaRPr lang="en-US" sz="1300" dirty="0">
                         <a:latin typeface="Arial" charset="0"/>
@@ -3865,7 +3500,7 @@
                           <a:ea typeface="Arial" pitchFamily="34" charset="-122"/>
                           <a:cs typeface="Arial" pitchFamily="34" charset="-120"/>
                         </a:rPr>
-                        <a:t>Experiment 2</a:t>
+                        <a:t>Results</a:t>
                       </a:r>
                       <a:endParaRPr lang="en-US" sz="1300" dirty="0">
                         <a:latin typeface="Arial" charset="0"/>
@@ -3933,7 +3568,7 @@
                           <a:ea typeface="Arial" pitchFamily="34" charset="-122"/>
                           <a:cs typeface="Arial" pitchFamily="34" charset="-120"/>
                         </a:rPr>
-                        <a:t>Load step 30 → 70 %: peak, offset and settling time</a:t>
+                        <a:t>disp(): final, peak and end temperature</a:t>
                       </a:r>
                       <a:endParaRPr lang="en-US" sz="1300" dirty="0">
                         <a:latin typeface="Arial" charset="0"/>
@@ -3964,484 +3599,6 @@
                     <a:lnT w="12700" cap="flat" cmpd="sng" algn="ctr">
                       <a:solidFill>
                         <a:srgbClr val="C4C4C0"/>
-                      </a:solidFill>
-                      <a:prstDash val="solid"/>
-                      <a:round/>
-                      <a:headEnd type="none" w="med" len="med"/>
-                      <a:tailEnd type="none" w="med" len="med"/>
-                    </a:lnT>
-                    <a:lnB w="12700" cap="flat" cmpd="sng" algn="ctr">
-                      <a:solidFill>
-                        <a:srgbClr val="C4C4C0"/>
-                      </a:solidFill>
-                      <a:prstDash val="solid"/>
-                      <a:round/>
-                      <a:headEnd type="none" w="med" len="med"/>
-                      <a:tailEnd type="none" w="med" len="med"/>
-                    </a:lnB>
-                  </a:tcPr>
-                </a:tc>
-              </a:tr>
-            </a:tbl>
-          </a:graphicData>
-        </a:graphic>
-      </p:graphicFrame>
-      <p:sp>
-        <p:nvSpPr>
-          <p:cNvPr id="5" name="Text 2"/>
-          <p:cNvSpPr/>
-          <p:nvPr/>
-        </p:nvSpPr>
-        <p:spPr>
-          <a:xfrm>
-            <a:off x="812800" y="6238249"/>
-            <a:ext cx="10883392" cy="238753"/>
-          </a:xfrm>
-          <a:prstGeom prst="rect">
-            <a:avLst/>
-          </a:prstGeom>
-          <a:noFill/>
-          <a:ln/>
-        </p:spPr>
-        <p:txBody>
-          <a:bodyPr wrap="square" lIns="0" tIns="0" rIns="0" bIns="0" rtlCol="0" anchor="t">
-            <a:normAutofit/>
-          </a:bodyPr>
-          <a:lstStyle/>
-          <a:p>
-            <a:pPr algn="l" indent="0" marL="0">
-              <a:lnSpc>
-                <a:spcPts val="1680"/>
-              </a:lnSpc>
-              <a:buNone/>
-            </a:pPr>
-            <a:r>
-              <a:rPr lang="en-US" sz="1200" dirty="0">
-                <a:solidFill>
-                  <a:srgbClr val="6B7486"/>
-                </a:solidFill>
-                <a:latin typeface="Arial" pitchFamily="34" charset="0"/>
-                <a:ea typeface="Arial" pitchFamily="34" charset="-122"/>
-                <a:cs typeface="Arial" pitchFamily="34" charset="-120"/>
-              </a:rPr>
-              <a:t>PID Thermal Control for Heavy-Duty Trucks · 10</a:t>
-            </a:r>
-            <a:endParaRPr lang="en-US" sz="1200" dirty="0"/>
-          </a:p>
-        </p:txBody>
-      </p:sp>
-    </p:spTree>
-  </p:cSld>
-  <p:clrMapOvr>
-    <a:masterClrMapping/>
-  </p:clrMapOvr>
-</p:sld>
-</file>
-
-<file path=ppt/slides/slide11.xml><?xml version="1.0" encoding="utf-8"?>
-<p:sld xmlns:a="http://schemas.openxmlformats.org/drawingml/2006/main" xmlns:r="http://schemas.openxmlformats.org/officeDocument/2006/relationships" xmlns:p="http://schemas.openxmlformats.org/presentationml/2006/main">
-  <p:cSld name="Slide 11">
-    <p:bg>
-      <p:bgPr>
-        <a:solidFill>
-          <a:srgbClr val="F6F5F1"/>
-        </a:solidFill>
-      </p:bgPr>
-    </p:bg>
-    <p:spTree>
-      <p:nvGrpSpPr>
-        <p:cNvPr id="1" name=""/>
-        <p:cNvGrpSpPr/>
-        <p:nvPr/>
-      </p:nvGrpSpPr>
-      <p:grpSpPr>
-        <a:xfrm>
-          <a:off x="0" y="0"/>
-          <a:ext cx="0" cy="0"/>
-          <a:chOff x="0" y="0"/>
-          <a:chExt cx="0" cy="0"/>
-        </a:xfrm>
-      </p:grpSpPr>
-      <p:sp>
-        <p:nvSpPr>
-          <p:cNvPr id="2" name="Text 0"/>
-          <p:cNvSpPr/>
-          <p:nvPr/>
-        </p:nvSpPr>
-        <p:spPr>
-          <a:xfrm>
-            <a:off x="812800" y="812800"/>
-            <a:ext cx="10883392" cy="238753"/>
-          </a:xfrm>
-          <a:prstGeom prst="rect">
-            <a:avLst/>
-          </a:prstGeom>
-          <a:noFill/>
-          <a:ln/>
-        </p:spPr>
-        <p:txBody>
-          <a:bodyPr wrap="square" lIns="0" tIns="0" rIns="0" bIns="0" rtlCol="0" anchor="t">
-            <a:normAutofit/>
-          </a:bodyPr>
-          <a:lstStyle/>
-          <a:p>
-            <a:pPr algn="l" indent="0" marL="0">
-              <a:lnSpc>
-                <a:spcPts val="1680"/>
-              </a:lnSpc>
-              <a:buNone/>
-            </a:pPr>
-            <a:r>
-              <a:rPr lang="en-US" sz="1200" b="1" spc="150" kern="0" dirty="0">
-                <a:solidFill>
-                  <a:srgbClr val="B4501F"/>
-                </a:solidFill>
-                <a:latin typeface="Arial" pitchFamily="34" charset="0"/>
-                <a:ea typeface="Arial" pitchFamily="34" charset="-122"/>
-                <a:cs typeface="Arial" pitchFamily="34" charset="-120"/>
-              </a:rPr>
-              <a:t>IMPLEMENTATION</a:t>
-            </a:r>
-            <a:endParaRPr lang="en-US" sz="1200" dirty="0"/>
-          </a:p>
-        </p:txBody>
-      </p:sp>
-      <p:sp>
-        <p:nvSpPr>
-          <p:cNvPr id="3" name="Text 1"/>
-          <p:cNvSpPr/>
-          <p:nvPr>
-            <p:ph type="title"/>
-          </p:nvPr>
-        </p:nvSpPr>
-        <p:spPr>
-          <a:xfrm>
-            <a:off x="812800" y="1102358"/>
-            <a:ext cx="10883392" cy="472414"/>
-          </a:xfrm>
-          <a:prstGeom prst="rect">
-            <a:avLst/>
-          </a:prstGeom>
-          <a:noFill/>
-          <a:ln/>
-        </p:spPr>
-        <p:txBody>
-          <a:bodyPr wrap="square" lIns="0" tIns="0" rIns="0" bIns="0" rtlCol="0" anchor="t">
-            <a:normAutofit/>
-          </a:bodyPr>
-          <a:lstStyle/>
-          <a:p>
-            <a:pPr algn="l" indent="0" marL="0">
-              <a:lnSpc>
-                <a:spcPts val="3520"/>
-              </a:lnSpc>
-              <a:buNone/>
-            </a:pPr>
-            <a:r>
-              <a:rPr lang="en-US" sz="3200" b="1" i="0" dirty="0">
-                <a:solidFill>
-                  <a:srgbClr val="15233B"/>
-                </a:solidFill>
-                <a:latin typeface="Arial" pitchFamily="34" charset="0"/>
-                <a:ea typeface="Arial" pitchFamily="34" charset="-122"/>
-                <a:cs typeface="Arial" pitchFamily="34" charset="-120"/>
-              </a:rPr>
-              <a:t>The same loop, built in Simulink</a:t>
-            </a:r>
-            <a:endParaRPr lang="en-US" sz="3200" dirty="0"/>
-          </a:p>
-        </p:txBody>
-      </p:sp>
-      <p:graphicFrame>
-        <p:nvGraphicFramePr>
-          <p:cNvPr id="4" name="Table 0"/>
-          <p:cNvGraphicFramePr>
-            <a:graphicFrameLocks noGrp="1"/>
-          </p:cNvGraphicFramePr>
-          <p:nvPr>
-            <p:extLst>
-              <p:ext uri="{D42A27DB-BD31-4B8C-83A1-F6EECF244321}">
-                <p14:modId xmlns:p14="http://schemas.microsoft.com/office/powerpoint/2010/main" val="1579011935"/>
-              </p:ext>
-            </p:extLst>
-          </p:nvPr>
-        </p:nvGraphicFramePr>
-        <p:xfrm>
-          <a:off x="825500" y="1790669"/>
-          <a:ext cx="10553700" cy="3234333"/>
-        </p:xfrm>
-        <a:graphic>
-          <a:graphicData uri="http://schemas.openxmlformats.org/drawingml/2006/table">
-            <a:tbl>
-              <a:tblPr/>
-              <a:tblGrid>
-                <a:gridCol w="3588258"/>
-                <a:gridCol w="6965442"/>
-              </a:tblGrid>
-              <a:tr h="359370">
-                <a:tc>
-                  <a:txBody>
-                    <a:bodyPr/>
-                    <a:lstStyle/>
-                    <a:p>
-                      <a:pPr indent="0" marL="0">
-                        <a:lnSpc>
-                          <a:spcPts val="1820"/>
-                        </a:lnSpc>
-                        <a:buNone/>
-                      </a:pPr>
-                      <a:r>
-                        <a:rPr lang="en-US" sz="1300" b="1" dirty="0">
-                          <a:solidFill>
-                            <a:srgbClr val="15233B"/>
-                          </a:solidFill>
-                          <a:latin typeface="Arial" pitchFamily="34" charset="0"/>
-                          <a:ea typeface="Arial" pitchFamily="34" charset="-122"/>
-                          <a:cs typeface="Arial" pitchFamily="34" charset="-120"/>
-                        </a:rPr>
-                        <a:t>Block</a:t>
-                      </a:r>
-                      <a:endParaRPr lang="en-US" sz="1300" dirty="0">
-                        <a:latin typeface="Arial" charset="0"/>
-                        <a:ea typeface="Arial" charset="0"/>
-                        <a:cs typeface="Arial" charset="0"/>
-                      </a:endParaRPr>
-                    </a:p>
-                  </a:txBody>
-                  <a:tcPr marL="57785" marR="57785" marT="57785" marB="57785" anchor="t">
-                    <a:lnL w="12700" cap="flat" cmpd="sng" algn="ctr">
-                      <a:solidFill>
-                        <a:srgbClr val="C4C4C0"/>
-                      </a:solidFill>
-                      <a:prstDash val="solid"/>
-                      <a:round/>
-                      <a:headEnd type="none" w="med" len="med"/>
-                      <a:tailEnd type="none" w="med" len="med"/>
-                    </a:lnL>
-                    <a:lnR w="12700" cap="flat" cmpd="sng" algn="ctr">
-                      <a:solidFill>
-                        <a:srgbClr val="B6B5B2"/>
-                      </a:solidFill>
-                      <a:prstDash val="solid"/>
-                      <a:round/>
-                      <a:headEnd type="none" w="med" len="med"/>
-                      <a:tailEnd type="none" w="med" len="med"/>
-                    </a:lnR>
-                    <a:lnT w="12700" cap="flat" cmpd="sng" algn="ctr">
-                      <a:solidFill>
-                        <a:srgbClr val="C4C4C0"/>
-                      </a:solidFill>
-                      <a:prstDash val="solid"/>
-                      <a:round/>
-                      <a:headEnd type="none" w="med" len="med"/>
-                      <a:tailEnd type="none" w="med" len="med"/>
-                    </a:lnT>
-                    <a:lnB w="12700" cap="flat" cmpd="sng" algn="ctr">
-                      <a:solidFill>
-                        <a:srgbClr val="B6B5B2"/>
-                      </a:solidFill>
-                      <a:prstDash val="solid"/>
-                      <a:round/>
-                      <a:headEnd type="none" w="med" len="med"/>
-                      <a:tailEnd type="none" w="med" len="med"/>
-                    </a:lnB>
-                    <a:solidFill>
-                      <a:srgbClr val="E4E3DF"/>
-                    </a:solidFill>
-                  </a:tcPr>
-                </a:tc>
-                <a:tc>
-                  <a:txBody>
-                    <a:bodyPr/>
-                    <a:lstStyle/>
-                    <a:p>
-                      <a:pPr indent="0" marL="0">
-                        <a:lnSpc>
-                          <a:spcPts val="1820"/>
-                        </a:lnSpc>
-                        <a:buNone/>
-                      </a:pPr>
-                      <a:r>
-                        <a:rPr lang="en-US" sz="1300" b="1" dirty="0">
-                          <a:solidFill>
-                            <a:srgbClr val="15233B"/>
-                          </a:solidFill>
-                          <a:latin typeface="Arial" pitchFamily="34" charset="0"/>
-                          <a:ea typeface="Arial" pitchFamily="34" charset="-122"/>
-                          <a:cs typeface="Arial" pitchFamily="34" charset="-120"/>
-                        </a:rPr>
-                        <a:t>Role</a:t>
-                      </a:r>
-                      <a:endParaRPr lang="en-US" sz="1300" dirty="0">
-                        <a:latin typeface="Arial" charset="0"/>
-                        <a:ea typeface="Arial" charset="0"/>
-                        <a:cs typeface="Arial" charset="0"/>
-                      </a:endParaRPr>
-                    </a:p>
-                  </a:txBody>
-                  <a:tcPr marL="57785" marR="57785" marT="57785" marB="57785" anchor="t">
-                    <a:lnL w="12700" cap="flat" cmpd="sng" algn="ctr">
-                      <a:solidFill>
-                        <a:srgbClr val="B6B5B2"/>
-                      </a:solidFill>
-                      <a:prstDash val="solid"/>
-                      <a:round/>
-                      <a:headEnd type="none" w="med" len="med"/>
-                      <a:tailEnd type="none" w="med" len="med"/>
-                    </a:lnL>
-                    <a:lnR w="12700" cap="flat" cmpd="sng" algn="ctr">
-                      <a:solidFill>
-                        <a:srgbClr val="B6B5B2"/>
-                      </a:solidFill>
-                      <a:prstDash val="solid"/>
-                      <a:round/>
-                      <a:headEnd type="none" w="med" len="med"/>
-                      <a:tailEnd type="none" w="med" len="med"/>
-                    </a:lnR>
-                    <a:lnT w="12700" cap="flat" cmpd="sng" algn="ctr">
-                      <a:solidFill>
-                        <a:srgbClr val="C4C4C0"/>
-                      </a:solidFill>
-                      <a:prstDash val="solid"/>
-                      <a:round/>
-                      <a:headEnd type="none" w="med" len="med"/>
-                      <a:tailEnd type="none" w="med" len="med"/>
-                    </a:lnT>
-                    <a:lnB w="12700" cap="flat" cmpd="sng" algn="ctr">
-                      <a:solidFill>
-                        <a:srgbClr val="B6B5B2"/>
-                      </a:solidFill>
-                      <a:prstDash val="solid"/>
-                      <a:round/>
-                      <a:headEnd type="none" w="med" len="med"/>
-                      <a:tailEnd type="none" w="med" len="med"/>
-                    </a:lnB>
-                    <a:solidFill>
-                      <a:srgbClr val="E4E3DF"/>
-                    </a:solidFill>
-                  </a:tcPr>
-                </a:tc>
-              </a:tr>
-              <a:tr h="359370">
-                <a:tc>
-                  <a:txBody>
-                    <a:bodyPr/>
-                    <a:lstStyle/>
-                    <a:p>
-                      <a:pPr indent="0" marL="0">
-                        <a:lnSpc>
-                          <a:spcPts val="1820"/>
-                        </a:lnSpc>
-                        <a:buNone/>
-                      </a:pPr>
-                      <a:r>
-                        <a:rPr lang="en-US" sz="1300" dirty="0">
-                          <a:solidFill>
-                            <a:srgbClr val="15233B"/>
-                          </a:solidFill>
-                          <a:latin typeface="Arial" pitchFamily="34" charset="0"/>
-                          <a:ea typeface="Arial" pitchFamily="34" charset="-122"/>
-                          <a:cs typeface="Arial" pitchFamily="34" charset="-120"/>
-                        </a:rPr>
-                        <a:t>Step → Set-point</a:t>
-                      </a:r>
-                      <a:endParaRPr lang="en-US" sz="1300" dirty="0">
-                        <a:latin typeface="Arial" charset="0"/>
-                        <a:ea typeface="Arial" charset="0"/>
-                        <a:cs typeface="Arial" charset="0"/>
-                      </a:endParaRPr>
-                    </a:p>
-                  </a:txBody>
-                  <a:tcPr marL="57785" marR="57785" marT="57785" marB="57785" anchor="t">
-                    <a:lnL w="12700" cap="flat" cmpd="sng" algn="ctr">
-                      <a:solidFill>
-                        <a:srgbClr val="C4C4C0"/>
-                      </a:solidFill>
-                      <a:prstDash val="solid"/>
-                      <a:round/>
-                      <a:headEnd type="none" w="med" len="med"/>
-                      <a:tailEnd type="none" w="med" len="med"/>
-                    </a:lnL>
-                    <a:lnR w="12700" cap="flat" cmpd="sng" algn="ctr">
-                      <a:solidFill>
-                        <a:srgbClr val="C4C4C0"/>
-                      </a:solidFill>
-                      <a:prstDash val="solid"/>
-                      <a:round/>
-                      <a:headEnd type="none" w="med" len="med"/>
-                      <a:tailEnd type="none" w="med" len="med"/>
-                    </a:lnR>
-                    <a:lnT w="12700" cap="flat" cmpd="sng" algn="ctr">
-                      <a:solidFill>
-                        <a:srgbClr val="B6B5B2"/>
-                      </a:solidFill>
-                      <a:prstDash val="solid"/>
-                      <a:round/>
-                      <a:headEnd type="none" w="med" len="med"/>
-                      <a:tailEnd type="none" w="med" len="med"/>
-                    </a:lnT>
-                    <a:lnB w="12700" cap="flat" cmpd="sng" algn="ctr">
-                      <a:solidFill>
-                        <a:srgbClr val="C4C4C0"/>
-                      </a:solidFill>
-                      <a:prstDash val="solid"/>
-                      <a:round/>
-                      <a:headEnd type="none" w="med" len="med"/>
-                      <a:tailEnd type="none" w="med" len="med"/>
-                    </a:lnB>
-                  </a:tcPr>
-                </a:tc>
-                <a:tc>
-                  <a:txBody>
-                    <a:bodyPr/>
-                    <a:lstStyle/>
-                    <a:p>
-                      <a:pPr indent="0" marL="0">
-                        <a:lnSpc>
-                          <a:spcPts val="1820"/>
-                        </a:lnSpc>
-                        <a:buNone/>
-                      </a:pPr>
-                      <a:r>
-                        <a:rPr lang="en-US" sz="1300" dirty="0">
-                          <a:solidFill>
-                            <a:srgbClr val="15233B"/>
-                          </a:solidFill>
-                          <a:latin typeface="Arial" pitchFamily="34" charset="0"/>
-                          <a:ea typeface="Arial" pitchFamily="34" charset="-122"/>
-                          <a:cs typeface="Arial" pitchFamily="34" charset="-120"/>
-                        </a:rPr>
-                        <a:t>90 °C, steps to 95 °C at 1200 s</a:t>
-                      </a:r>
-                      <a:endParaRPr lang="en-US" sz="1300" dirty="0">
-                        <a:latin typeface="Arial" charset="0"/>
-                        <a:ea typeface="Arial" charset="0"/>
-                        <a:cs typeface="Arial" charset="0"/>
-                      </a:endParaRPr>
-                    </a:p>
-                  </a:txBody>
-                  <a:tcPr marL="57785" marR="57785" marT="57785" marB="57785" anchor="t">
-                    <a:lnL w="12700" cap="flat" cmpd="sng" algn="ctr">
-                      <a:solidFill>
-                        <a:srgbClr val="C4C4C0"/>
-                      </a:solidFill>
-                      <a:prstDash val="solid"/>
-                      <a:round/>
-                      <a:headEnd type="none" w="med" len="med"/>
-                      <a:tailEnd type="none" w="med" len="med"/>
-                    </a:lnL>
-                    <a:lnR w="12700" cap="flat" cmpd="sng" algn="ctr">
-                      <a:solidFill>
-                        <a:srgbClr val="C4C4C0"/>
-                      </a:solidFill>
-                      <a:prstDash val="solid"/>
-                      <a:round/>
-                      <a:headEnd type="none" w="med" len="med"/>
-                      <a:tailEnd type="none" w="med" len="med"/>
-                    </a:lnR>
-                    <a:lnT w="12700" cap="flat" cmpd="sng" algn="ctr">
-                      <a:solidFill>
-                        <a:srgbClr val="B6B5B2"/>
                       </a:solidFill>
                       <a:prstDash val="solid"/>
                       <a:round/>
@@ -4481,7 +3638,7 @@
                           <a:ea typeface="Arial" pitchFamily="34" charset="-122"/>
                           <a:cs typeface="Arial" pitchFamily="34" charset="-120"/>
                         </a:rPr>
-                        <a:t>Sum (+ −)</a:t>
+                        <a:t>Stability</a:t>
                       </a:r>
                       <a:endParaRPr lang="en-US" sz="1300" dirty="0">
                         <a:latin typeface="Arial" charset="0"/>
@@ -4549,7 +3706,7 @@
                           <a:ea typeface="Arial" pitchFamily="34" charset="-122"/>
                           <a:cs typeface="Arial" pitchFamily="34" charset="-120"/>
                         </a:rPr>
-                        <a:t>Error e = T_c − T_ref</a:t>
+                        <a:t>pole(): all closed-loop poles negative</a:t>
                       </a:r>
                       <a:endParaRPr lang="en-US" sz="1300" dirty="0">
                         <a:latin typeface="Arial" charset="0"/>
@@ -4619,7 +3776,7 @@
                           <a:ea typeface="Arial" pitchFamily="34" charset="-122"/>
                           <a:cs typeface="Arial" pitchFamily="34" charset="-120"/>
                         </a:rPr>
-                        <a:t>PID Controller</a:t>
+                        <a:t>Inference</a:t>
                       </a:r>
                       <a:endParaRPr lang="en-US" sz="1300" dirty="0">
                         <a:latin typeface="Arial" charset="0"/>
@@ -4687,7 +3844,7 @@
                           <a:ea typeface="Arial" pitchFamily="34" charset="-122"/>
                           <a:cs typeface="Arial" pitchFamily="34" charset="-120"/>
                         </a:rPr>
-                        <a:t>P 2.476, I 0.0439, D 22.35, N 100; limits −1.58 to 2.92</a:t>
+                        <a:t>What the two graphs show</a:t>
                       </a:r>
                       <a:endParaRPr lang="en-US" sz="1300" dirty="0">
                         <a:latin typeface="Arial" charset="0"/>
@@ -4736,696 +3893,6 @@
                   </a:tcPr>
                 </a:tc>
               </a:tr>
-              <a:tr h="359370">
-                <a:tc>
-                  <a:txBody>
-                    <a:bodyPr/>
-                    <a:lstStyle/>
-                    <a:p>
-                      <a:pPr indent="0" marL="0">
-                        <a:lnSpc>
-                          <a:spcPts val="1820"/>
-                        </a:lnSpc>
-                        <a:buNone/>
-                      </a:pPr>
-                      <a:r>
-                        <a:rPr lang="en-US" sz="1300" dirty="0">
-                          <a:solidFill>
-                            <a:srgbClr val="15233B"/>
-                          </a:solidFill>
-                          <a:latin typeface="Arial" pitchFamily="34" charset="0"/>
-                          <a:ea typeface="Arial" pitchFamily="34" charset="-122"/>
-                          <a:cs typeface="Arial" pitchFamily="34" charset="-120"/>
-                        </a:rPr>
-                        <a:t>Transfer Fcn G(s)</a:t>
-                      </a:r>
-                      <a:endParaRPr lang="en-US" sz="1300" dirty="0">
-                        <a:latin typeface="Arial" charset="0"/>
-                        <a:ea typeface="Arial" charset="0"/>
-                        <a:cs typeface="Arial" charset="0"/>
-                      </a:endParaRPr>
-                    </a:p>
-                  </a:txBody>
-                  <a:tcPr marL="57785" marR="57785" marT="57785" marB="57785" anchor="t">
-                    <a:lnL w="12700" cap="flat" cmpd="sng" algn="ctr">
-                      <a:solidFill>
-                        <a:srgbClr val="C4C4C0"/>
-                      </a:solidFill>
-                      <a:prstDash val="solid"/>
-                      <a:round/>
-                      <a:headEnd type="none" w="med" len="med"/>
-                      <a:tailEnd type="none" w="med" len="med"/>
-                    </a:lnL>
-                    <a:lnR w="12700" cap="flat" cmpd="sng" algn="ctr">
-                      <a:solidFill>
-                        <a:srgbClr val="C4C4C0"/>
-                      </a:solidFill>
-                      <a:prstDash val="solid"/>
-                      <a:round/>
-                      <a:headEnd type="none" w="med" len="med"/>
-                      <a:tailEnd type="none" w="med" len="med"/>
-                    </a:lnR>
-                    <a:lnT w="12700" cap="flat" cmpd="sng" algn="ctr">
-                      <a:solidFill>
-                        <a:srgbClr val="C4C4C0"/>
-                      </a:solidFill>
-                      <a:prstDash val="solid"/>
-                      <a:round/>
-                      <a:headEnd type="none" w="med" len="med"/>
-                      <a:tailEnd type="none" w="med" len="med"/>
-                    </a:lnT>
-                    <a:lnB w="12700" cap="flat" cmpd="sng" algn="ctr">
-                      <a:solidFill>
-                        <a:srgbClr val="C4C4C0"/>
-                      </a:solidFill>
-                      <a:prstDash val="solid"/>
-                      <a:round/>
-                      <a:headEnd type="none" w="med" len="med"/>
-                      <a:tailEnd type="none" w="med" len="med"/>
-                    </a:lnB>
-                  </a:tcPr>
-                </a:tc>
-                <a:tc>
-                  <a:txBody>
-                    <a:bodyPr/>
-                    <a:lstStyle/>
-                    <a:p>
-                      <a:pPr indent="0" marL="0">
-                        <a:lnSpc>
-                          <a:spcPts val="1820"/>
-                        </a:lnSpc>
-                        <a:buNone/>
-                      </a:pPr>
-                      <a:r>
-                        <a:rPr lang="en-US" sz="1300" dirty="0">
-                          <a:solidFill>
-                            <a:srgbClr val="15233B"/>
-                          </a:solidFill>
-                          <a:latin typeface="Arial" pitchFamily="34" charset="0"/>
-                          <a:ea typeface="Arial" pitchFamily="34" charset="-122"/>
-                          <a:cs typeface="Arial" pitchFamily="34" charset="-120"/>
-                        </a:rPr>
-                        <a:t>Fan path: −38.09 / (9611s² + 862.8s + 1)</a:t>
-                      </a:r>
-                      <a:endParaRPr lang="en-US" sz="1300" dirty="0">
-                        <a:latin typeface="Arial" charset="0"/>
-                        <a:ea typeface="Arial" charset="0"/>
-                        <a:cs typeface="Arial" charset="0"/>
-                      </a:endParaRPr>
-                    </a:p>
-                  </a:txBody>
-                  <a:tcPr marL="57785" marR="57785" marT="57785" marB="57785" anchor="t">
-                    <a:lnL w="12700" cap="flat" cmpd="sng" algn="ctr">
-                      <a:solidFill>
-                        <a:srgbClr val="C4C4C0"/>
-                      </a:solidFill>
-                      <a:prstDash val="solid"/>
-                      <a:round/>
-                      <a:headEnd type="none" w="med" len="med"/>
-                      <a:tailEnd type="none" w="med" len="med"/>
-                    </a:lnL>
-                    <a:lnR w="12700" cap="flat" cmpd="sng" algn="ctr">
-                      <a:solidFill>
-                        <a:srgbClr val="C4C4C0"/>
-                      </a:solidFill>
-                      <a:prstDash val="solid"/>
-                      <a:round/>
-                      <a:headEnd type="none" w="med" len="med"/>
-                      <a:tailEnd type="none" w="med" len="med"/>
-                    </a:lnR>
-                    <a:lnT w="12700" cap="flat" cmpd="sng" algn="ctr">
-                      <a:solidFill>
-                        <a:srgbClr val="C4C4C0"/>
-                      </a:solidFill>
-                      <a:prstDash val="solid"/>
-                      <a:round/>
-                      <a:headEnd type="none" w="med" len="med"/>
-                      <a:tailEnd type="none" w="med" len="med"/>
-                    </a:lnT>
-                    <a:lnB w="12700" cap="flat" cmpd="sng" algn="ctr">
-                      <a:solidFill>
-                        <a:srgbClr val="C4C4C0"/>
-                      </a:solidFill>
-                      <a:prstDash val="solid"/>
-                      <a:round/>
-                      <a:headEnd type="none" w="med" len="med"/>
-                      <a:tailEnd type="none" w="med" len="med"/>
-                    </a:lnB>
-                  </a:tcPr>
-                </a:tc>
-              </a:tr>
-              <a:tr h="359370">
-                <a:tc>
-                  <a:txBody>
-                    <a:bodyPr/>
-                    <a:lstStyle/>
-                    <a:p>
-                      <a:pPr indent="0" marL="0">
-                        <a:lnSpc>
-                          <a:spcPts val="1820"/>
-                        </a:lnSpc>
-                        <a:buNone/>
-                      </a:pPr>
-                      <a:r>
-                        <a:rPr lang="en-US" sz="1300" dirty="0">
-                          <a:solidFill>
-                            <a:srgbClr val="15233B"/>
-                          </a:solidFill>
-                          <a:latin typeface="Arial" pitchFamily="34" charset="0"/>
-                          <a:ea typeface="Arial" pitchFamily="34" charset="-122"/>
-                          <a:cs typeface="Arial" pitchFamily="34" charset="-120"/>
-                        </a:rPr>
-                        <a:t>Step → Transfer Fcn Gd(s)</a:t>
-                      </a:r>
-                      <a:endParaRPr lang="en-US" sz="1300" dirty="0">
-                        <a:latin typeface="Arial" charset="0"/>
-                        <a:ea typeface="Arial" charset="0"/>
-                        <a:cs typeface="Arial" charset="0"/>
-                      </a:endParaRPr>
-                    </a:p>
-                  </a:txBody>
-                  <a:tcPr marL="57785" marR="57785" marT="57785" marB="57785" anchor="t">
-                    <a:lnL w="12700" cap="flat" cmpd="sng" algn="ctr">
-                      <a:solidFill>
-                        <a:srgbClr val="C4C4C0"/>
-                      </a:solidFill>
-                      <a:prstDash val="solid"/>
-                      <a:round/>
-                      <a:headEnd type="none" w="med" len="med"/>
-                      <a:tailEnd type="none" w="med" len="med"/>
-                    </a:lnL>
-                    <a:lnR w="12700" cap="flat" cmpd="sng" algn="ctr">
-                      <a:solidFill>
-                        <a:srgbClr val="C4C4C0"/>
-                      </a:solidFill>
-                      <a:prstDash val="solid"/>
-                      <a:round/>
-                      <a:headEnd type="none" w="med" len="med"/>
-                      <a:tailEnd type="none" w="med" len="med"/>
-                    </a:lnR>
-                    <a:lnT w="12700" cap="flat" cmpd="sng" algn="ctr">
-                      <a:solidFill>
-                        <a:srgbClr val="C4C4C0"/>
-                      </a:solidFill>
-                      <a:prstDash val="solid"/>
-                      <a:round/>
-                      <a:headEnd type="none" w="med" len="med"/>
-                      <a:tailEnd type="none" w="med" len="med"/>
-                    </a:lnT>
-                    <a:lnB w="12700" cap="flat" cmpd="sng" algn="ctr">
-                      <a:solidFill>
-                        <a:srgbClr val="C4C4C0"/>
-                      </a:solidFill>
-                      <a:prstDash val="solid"/>
-                      <a:round/>
-                      <a:headEnd type="none" w="med" len="med"/>
-                      <a:tailEnd type="none" w="med" len="med"/>
-                    </a:lnB>
-                  </a:tcPr>
-                </a:tc>
-                <a:tc>
-                  <a:txBody>
-                    <a:bodyPr/>
-                    <a:lstStyle/>
-                    <a:p>
-                      <a:pPr indent="0" marL="0">
-                        <a:lnSpc>
-                          <a:spcPts val="1820"/>
-                        </a:lnSpc>
-                        <a:buNone/>
-                      </a:pPr>
-                      <a:r>
-                        <a:rPr lang="en-US" sz="1300" dirty="0">
-                          <a:solidFill>
-                            <a:srgbClr val="15233B"/>
-                          </a:solidFill>
-                          <a:latin typeface="Arial" pitchFamily="34" charset="0"/>
-                          <a:ea typeface="Arial" pitchFamily="34" charset="-122"/>
-                          <a:cs typeface="Arial" pitchFamily="34" charset="-120"/>
-                        </a:rPr>
-                        <a:t>Load +40 % at 600 s through 2.0 / (851.5s + 1)</a:t>
-                      </a:r>
-                      <a:endParaRPr lang="en-US" sz="1300" dirty="0">
-                        <a:latin typeface="Arial" charset="0"/>
-                        <a:ea typeface="Arial" charset="0"/>
-                        <a:cs typeface="Arial" charset="0"/>
-                      </a:endParaRPr>
-                    </a:p>
-                  </a:txBody>
-                  <a:tcPr marL="57785" marR="57785" marT="57785" marB="57785" anchor="t">
-                    <a:lnL w="12700" cap="flat" cmpd="sng" algn="ctr">
-                      <a:solidFill>
-                        <a:srgbClr val="C4C4C0"/>
-                      </a:solidFill>
-                      <a:prstDash val="solid"/>
-                      <a:round/>
-                      <a:headEnd type="none" w="med" len="med"/>
-                      <a:tailEnd type="none" w="med" len="med"/>
-                    </a:lnL>
-                    <a:lnR w="12700" cap="flat" cmpd="sng" algn="ctr">
-                      <a:solidFill>
-                        <a:srgbClr val="C4C4C0"/>
-                      </a:solidFill>
-                      <a:prstDash val="solid"/>
-                      <a:round/>
-                      <a:headEnd type="none" w="med" len="med"/>
-                      <a:tailEnd type="none" w="med" len="med"/>
-                    </a:lnR>
-                    <a:lnT w="12700" cap="flat" cmpd="sng" algn="ctr">
-                      <a:solidFill>
-                        <a:srgbClr val="C4C4C0"/>
-                      </a:solidFill>
-                      <a:prstDash val="solid"/>
-                      <a:round/>
-                      <a:headEnd type="none" w="med" len="med"/>
-                      <a:tailEnd type="none" w="med" len="med"/>
-                    </a:lnT>
-                    <a:lnB w="12700" cap="flat" cmpd="sng" algn="ctr">
-                      <a:solidFill>
-                        <a:srgbClr val="C4C4C0"/>
-                      </a:solidFill>
-                      <a:prstDash val="solid"/>
-                      <a:round/>
-                      <a:headEnd type="none" w="med" len="med"/>
-                      <a:tailEnd type="none" w="med" len="med"/>
-                    </a:lnB>
-                  </a:tcPr>
-                </a:tc>
-              </a:tr>
-              <a:tr h="359370">
-                <a:tc>
-                  <a:txBody>
-                    <a:bodyPr/>
-                    <a:lstStyle/>
-                    <a:p>
-                      <a:pPr indent="0" marL="0">
-                        <a:lnSpc>
-                          <a:spcPts val="1820"/>
-                        </a:lnSpc>
-                        <a:buNone/>
-                      </a:pPr>
-                      <a:r>
-                        <a:rPr lang="en-US" sz="1300" dirty="0">
-                          <a:solidFill>
-                            <a:srgbClr val="15233B"/>
-                          </a:solidFill>
-                          <a:latin typeface="Arial" pitchFamily="34" charset="0"/>
-                          <a:ea typeface="Arial" pitchFamily="34" charset="-122"/>
-                          <a:cs typeface="Arial" pitchFamily="34" charset="-120"/>
-                        </a:rPr>
-                        <a:t>Constant + Sum (+ + +)</a:t>
-                      </a:r>
-                      <a:endParaRPr lang="en-US" sz="1300" dirty="0">
-                        <a:latin typeface="Arial" charset="0"/>
-                        <a:ea typeface="Arial" charset="0"/>
-                        <a:cs typeface="Arial" charset="0"/>
-                      </a:endParaRPr>
-                    </a:p>
-                  </a:txBody>
-                  <a:tcPr marL="57785" marR="57785" marT="57785" marB="57785" anchor="t">
-                    <a:lnL w="12700" cap="flat" cmpd="sng" algn="ctr">
-                      <a:solidFill>
-                        <a:srgbClr val="C4C4C0"/>
-                      </a:solidFill>
-                      <a:prstDash val="solid"/>
-                      <a:round/>
-                      <a:headEnd type="none" w="med" len="med"/>
-                      <a:tailEnd type="none" w="med" len="med"/>
-                    </a:lnL>
-                    <a:lnR w="12700" cap="flat" cmpd="sng" algn="ctr">
-                      <a:solidFill>
-                        <a:srgbClr val="C4C4C0"/>
-                      </a:solidFill>
-                      <a:prstDash val="solid"/>
-                      <a:round/>
-                      <a:headEnd type="none" w="med" len="med"/>
-                      <a:tailEnd type="none" w="med" len="med"/>
-                    </a:lnR>
-                    <a:lnT w="12700" cap="flat" cmpd="sng" algn="ctr">
-                      <a:solidFill>
-                        <a:srgbClr val="C4C4C0"/>
-                      </a:solidFill>
-                      <a:prstDash val="solid"/>
-                      <a:round/>
-                      <a:headEnd type="none" w="med" len="med"/>
-                      <a:tailEnd type="none" w="med" len="med"/>
-                    </a:lnT>
-                    <a:lnB w="12700" cap="flat" cmpd="sng" algn="ctr">
-                      <a:solidFill>
-                        <a:srgbClr val="C4C4C0"/>
-                      </a:solidFill>
-                      <a:prstDash val="solid"/>
-                      <a:round/>
-                      <a:headEnd type="none" w="med" len="med"/>
-                      <a:tailEnd type="none" w="med" len="med"/>
-                    </a:lnB>
-                  </a:tcPr>
-                </a:tc>
-                <a:tc>
-                  <a:txBody>
-                    <a:bodyPr/>
-                    <a:lstStyle/>
-                    <a:p>
-                      <a:pPr indent="0" marL="0">
-                        <a:lnSpc>
-                          <a:spcPts val="1820"/>
-                        </a:lnSpc>
-                        <a:buNone/>
-                      </a:pPr>
-                      <a:r>
-                        <a:rPr lang="en-US" sz="1300" dirty="0">
-                          <a:solidFill>
-                            <a:srgbClr val="15233B"/>
-                          </a:solidFill>
-                          <a:latin typeface="Arial" pitchFamily="34" charset="0"/>
-                          <a:ea typeface="Arial" pitchFamily="34" charset="-122"/>
-                          <a:cs typeface="Arial" pitchFamily="34" charset="-120"/>
-                        </a:rPr>
-                        <a:t>T_c = 90 + cooling effect + load effect</a:t>
-                      </a:r>
-                      <a:endParaRPr lang="en-US" sz="1300" dirty="0">
-                        <a:latin typeface="Arial" charset="0"/>
-                        <a:ea typeface="Arial" charset="0"/>
-                        <a:cs typeface="Arial" charset="0"/>
-                      </a:endParaRPr>
-                    </a:p>
-                  </a:txBody>
-                  <a:tcPr marL="57785" marR="57785" marT="57785" marB="57785" anchor="t">
-                    <a:lnL w="12700" cap="flat" cmpd="sng" algn="ctr">
-                      <a:solidFill>
-                        <a:srgbClr val="C4C4C0"/>
-                      </a:solidFill>
-                      <a:prstDash val="solid"/>
-                      <a:round/>
-                      <a:headEnd type="none" w="med" len="med"/>
-                      <a:tailEnd type="none" w="med" len="med"/>
-                    </a:lnL>
-                    <a:lnR w="12700" cap="flat" cmpd="sng" algn="ctr">
-                      <a:solidFill>
-                        <a:srgbClr val="C4C4C0"/>
-                      </a:solidFill>
-                      <a:prstDash val="solid"/>
-                      <a:round/>
-                      <a:headEnd type="none" w="med" len="med"/>
-                      <a:tailEnd type="none" w="med" len="med"/>
-                    </a:lnR>
-                    <a:lnT w="12700" cap="flat" cmpd="sng" algn="ctr">
-                      <a:solidFill>
-                        <a:srgbClr val="C4C4C0"/>
-                      </a:solidFill>
-                      <a:prstDash val="solid"/>
-                      <a:round/>
-                      <a:headEnd type="none" w="med" len="med"/>
-                      <a:tailEnd type="none" w="med" len="med"/>
-                    </a:lnT>
-                    <a:lnB w="12700" cap="flat" cmpd="sng" algn="ctr">
-                      <a:solidFill>
-                        <a:srgbClr val="C4C4C0"/>
-                      </a:solidFill>
-                      <a:prstDash val="solid"/>
-                      <a:round/>
-                      <a:headEnd type="none" w="med" len="med"/>
-                      <a:tailEnd type="none" w="med" len="med"/>
-                    </a:lnB>
-                  </a:tcPr>
-                </a:tc>
-              </a:tr>
-              <a:tr h="359370">
-                <a:tc>
-                  <a:txBody>
-                    <a:bodyPr/>
-                    <a:lstStyle/>
-                    <a:p>
-                      <a:pPr indent="0" marL="0">
-                        <a:lnSpc>
-                          <a:spcPts val="1820"/>
-                        </a:lnSpc>
-                        <a:buNone/>
-                      </a:pPr>
-                      <a:r>
-                        <a:rPr lang="en-US" sz="1300" dirty="0">
-                          <a:solidFill>
-                            <a:srgbClr val="15233B"/>
-                          </a:solidFill>
-                          <a:latin typeface="Arial" pitchFamily="34" charset="0"/>
-                          <a:ea typeface="Arial" pitchFamily="34" charset="-122"/>
-                          <a:cs typeface="Arial" pitchFamily="34" charset="-120"/>
-                        </a:rPr>
-                        <a:t>Bias</a:t>
-                      </a:r>
-                      <a:endParaRPr lang="en-US" sz="1300" dirty="0">
-                        <a:latin typeface="Arial" charset="0"/>
-                        <a:ea typeface="Arial" charset="0"/>
-                        <a:cs typeface="Arial" charset="0"/>
-                      </a:endParaRPr>
-                    </a:p>
-                  </a:txBody>
-                  <a:tcPr marL="57785" marR="57785" marT="57785" marB="57785" anchor="t">
-                    <a:lnL w="12700" cap="flat" cmpd="sng" algn="ctr">
-                      <a:solidFill>
-                        <a:srgbClr val="C4C4C0"/>
-                      </a:solidFill>
-                      <a:prstDash val="solid"/>
-                      <a:round/>
-                      <a:headEnd type="none" w="med" len="med"/>
-                      <a:tailEnd type="none" w="med" len="med"/>
-                    </a:lnL>
-                    <a:lnR w="12700" cap="flat" cmpd="sng" algn="ctr">
-                      <a:solidFill>
-                        <a:srgbClr val="C4C4C0"/>
-                      </a:solidFill>
-                      <a:prstDash val="solid"/>
-                      <a:round/>
-                      <a:headEnd type="none" w="med" len="med"/>
-                      <a:tailEnd type="none" w="med" len="med"/>
-                    </a:lnR>
-                    <a:lnT w="12700" cap="flat" cmpd="sng" algn="ctr">
-                      <a:solidFill>
-                        <a:srgbClr val="C4C4C0"/>
-                      </a:solidFill>
-                      <a:prstDash val="solid"/>
-                      <a:round/>
-                      <a:headEnd type="none" w="med" len="med"/>
-                      <a:tailEnd type="none" w="med" len="med"/>
-                    </a:lnT>
-                    <a:lnB w="12700" cap="flat" cmpd="sng" algn="ctr">
-                      <a:solidFill>
-                        <a:srgbClr val="C4C4C0"/>
-                      </a:solidFill>
-                      <a:prstDash val="solid"/>
-                      <a:round/>
-                      <a:headEnd type="none" w="med" len="med"/>
-                      <a:tailEnd type="none" w="med" len="med"/>
-                    </a:lnB>
-                  </a:tcPr>
-                </a:tc>
-                <a:tc>
-                  <a:txBody>
-                    <a:bodyPr/>
-                    <a:lstStyle/>
-                    <a:p>
-                      <a:pPr indent="0" marL="0">
-                        <a:lnSpc>
-                          <a:spcPts val="1820"/>
-                        </a:lnSpc>
-                        <a:buNone/>
-                      </a:pPr>
-                      <a:r>
-                        <a:rPr lang="en-US" sz="1300" dirty="0">
-                          <a:solidFill>
-                            <a:srgbClr val="15233B"/>
-                          </a:solidFill>
-                          <a:latin typeface="Arial" pitchFamily="34" charset="0"/>
-                          <a:ea typeface="Arial" pitchFamily="34" charset="-122"/>
-                          <a:cs typeface="Arial" pitchFamily="34" charset="-120"/>
-                        </a:rPr>
-                        <a:t>Fan air flow y = 1.58 + PID output [kg/s]</a:t>
-                      </a:r>
-                      <a:endParaRPr lang="en-US" sz="1300" dirty="0">
-                        <a:latin typeface="Arial" charset="0"/>
-                        <a:ea typeface="Arial" charset="0"/>
-                        <a:cs typeface="Arial" charset="0"/>
-                      </a:endParaRPr>
-                    </a:p>
-                  </a:txBody>
-                  <a:tcPr marL="57785" marR="57785" marT="57785" marB="57785" anchor="t">
-                    <a:lnL w="12700" cap="flat" cmpd="sng" algn="ctr">
-                      <a:solidFill>
-                        <a:srgbClr val="C4C4C0"/>
-                      </a:solidFill>
-                      <a:prstDash val="solid"/>
-                      <a:round/>
-                      <a:headEnd type="none" w="med" len="med"/>
-                      <a:tailEnd type="none" w="med" len="med"/>
-                    </a:lnL>
-                    <a:lnR w="12700" cap="flat" cmpd="sng" algn="ctr">
-                      <a:solidFill>
-                        <a:srgbClr val="C4C4C0"/>
-                      </a:solidFill>
-                      <a:prstDash val="solid"/>
-                      <a:round/>
-                      <a:headEnd type="none" w="med" len="med"/>
-                      <a:tailEnd type="none" w="med" len="med"/>
-                    </a:lnR>
-                    <a:lnT w="12700" cap="flat" cmpd="sng" algn="ctr">
-                      <a:solidFill>
-                        <a:srgbClr val="C4C4C0"/>
-                      </a:solidFill>
-                      <a:prstDash val="solid"/>
-                      <a:round/>
-                      <a:headEnd type="none" w="med" len="med"/>
-                      <a:tailEnd type="none" w="med" len="med"/>
-                    </a:lnT>
-                    <a:lnB w="12700" cap="flat" cmpd="sng" algn="ctr">
-                      <a:solidFill>
-                        <a:srgbClr val="C4C4C0"/>
-                      </a:solidFill>
-                      <a:prstDash val="solid"/>
-                      <a:round/>
-                      <a:headEnd type="none" w="med" len="med"/>
-                      <a:tailEnd type="none" w="med" len="med"/>
-                    </a:lnB>
-                  </a:tcPr>
-                </a:tc>
-              </a:tr>
-              <a:tr h="359370">
-                <a:tc>
-                  <a:txBody>
-                    <a:bodyPr/>
-                    <a:lstStyle/>
-                    <a:p>
-                      <a:pPr indent="0" marL="0">
-                        <a:lnSpc>
-                          <a:spcPts val="1820"/>
-                        </a:lnSpc>
-                        <a:buNone/>
-                      </a:pPr>
-                      <a:r>
-                        <a:rPr lang="en-US" sz="1300" dirty="0">
-                          <a:solidFill>
-                            <a:srgbClr val="15233B"/>
-                          </a:solidFill>
-                          <a:latin typeface="Arial" pitchFamily="34" charset="0"/>
-                          <a:ea typeface="Arial" pitchFamily="34" charset="-122"/>
-                          <a:cs typeface="Arial" pitchFamily="34" charset="-120"/>
-                        </a:rPr>
-                        <a:t>Mux → Scope</a:t>
-                      </a:r>
-                      <a:endParaRPr lang="en-US" sz="1300" dirty="0">
-                        <a:latin typeface="Arial" charset="0"/>
-                        <a:ea typeface="Arial" charset="0"/>
-                        <a:cs typeface="Arial" charset="0"/>
-                      </a:endParaRPr>
-                    </a:p>
-                  </a:txBody>
-                  <a:tcPr marL="57785" marR="57785" marT="57785" marB="57785" anchor="t">
-                    <a:lnL w="12700" cap="flat" cmpd="sng" algn="ctr">
-                      <a:solidFill>
-                        <a:srgbClr val="C4C4C0"/>
-                      </a:solidFill>
-                      <a:prstDash val="solid"/>
-                      <a:round/>
-                      <a:headEnd type="none" w="med" len="med"/>
-                      <a:tailEnd type="none" w="med" len="med"/>
-                    </a:lnL>
-                    <a:lnR w="12700" cap="flat" cmpd="sng" algn="ctr">
-                      <a:solidFill>
-                        <a:srgbClr val="C4C4C0"/>
-                      </a:solidFill>
-                      <a:prstDash val="solid"/>
-                      <a:round/>
-                      <a:headEnd type="none" w="med" len="med"/>
-                      <a:tailEnd type="none" w="med" len="med"/>
-                    </a:lnR>
-                    <a:lnT w="12700" cap="flat" cmpd="sng" algn="ctr">
-                      <a:solidFill>
-                        <a:srgbClr val="C4C4C0"/>
-                      </a:solidFill>
-                      <a:prstDash val="solid"/>
-                      <a:round/>
-                      <a:headEnd type="none" w="med" len="med"/>
-                      <a:tailEnd type="none" w="med" len="med"/>
-                    </a:lnT>
-                    <a:lnB w="12700" cap="flat" cmpd="sng" algn="ctr">
-                      <a:solidFill>
-                        <a:srgbClr val="C4C4C0"/>
-                      </a:solidFill>
-                      <a:prstDash val="solid"/>
-                      <a:round/>
-                      <a:headEnd type="none" w="med" len="med"/>
-                      <a:tailEnd type="none" w="med" len="med"/>
-                    </a:lnB>
-                  </a:tcPr>
-                </a:tc>
-                <a:tc>
-                  <a:txBody>
-                    <a:bodyPr/>
-                    <a:lstStyle/>
-                    <a:p>
-                      <a:pPr indent="0" marL="0">
-                        <a:lnSpc>
-                          <a:spcPts val="1820"/>
-                        </a:lnSpc>
-                        <a:buNone/>
-                      </a:pPr>
-                      <a:r>
-                        <a:rPr lang="en-US" sz="1300" dirty="0">
-                          <a:solidFill>
-                            <a:srgbClr val="15233B"/>
-                          </a:solidFill>
-                          <a:latin typeface="Arial" pitchFamily="34" charset="0"/>
-                          <a:ea typeface="Arial" pitchFamily="34" charset="-122"/>
-                          <a:cs typeface="Arial" pitchFamily="34" charset="-120"/>
-                        </a:rPr>
-                        <a:t>T_c with the set-point, and the fan air flow</a:t>
-                      </a:r>
-                      <a:endParaRPr lang="en-US" sz="1300" dirty="0">
-                        <a:latin typeface="Arial" charset="0"/>
-                        <a:ea typeface="Arial" charset="0"/>
-                        <a:cs typeface="Arial" charset="0"/>
-                      </a:endParaRPr>
-                    </a:p>
-                  </a:txBody>
-                  <a:tcPr marL="57785" marR="57785" marT="57785" marB="57785" anchor="t">
-                    <a:lnL w="12700" cap="flat" cmpd="sng" algn="ctr">
-                      <a:solidFill>
-                        <a:srgbClr val="C4C4C0"/>
-                      </a:solidFill>
-                      <a:prstDash val="solid"/>
-                      <a:round/>
-                      <a:headEnd type="none" w="med" len="med"/>
-                      <a:tailEnd type="none" w="med" len="med"/>
-                    </a:lnL>
-                    <a:lnR w="12700" cap="flat" cmpd="sng" algn="ctr">
-                      <a:solidFill>
-                        <a:srgbClr val="C4C4C0"/>
-                      </a:solidFill>
-                      <a:prstDash val="solid"/>
-                      <a:round/>
-                      <a:headEnd type="none" w="med" len="med"/>
-                      <a:tailEnd type="none" w="med" len="med"/>
-                    </a:lnR>
-                    <a:lnT w="12700" cap="flat" cmpd="sng" algn="ctr">
-                      <a:solidFill>
-                        <a:srgbClr val="C4C4C0"/>
-                      </a:solidFill>
-                      <a:prstDash val="solid"/>
-                      <a:round/>
-                      <a:headEnd type="none" w="med" len="med"/>
-                      <a:tailEnd type="none" w="med" len="med"/>
-                    </a:lnT>
-                    <a:lnB w="12700" cap="flat" cmpd="sng" algn="ctr">
-                      <a:solidFill>
-                        <a:srgbClr val="C4C4C0"/>
-                      </a:solidFill>
-                      <a:prstDash val="solid"/>
-                      <a:round/>
-                      <a:headEnd type="none" w="med" len="med"/>
-                      <a:tailEnd type="none" w="med" len="med"/>
-                    </a:lnB>
-                  </a:tcPr>
-                </a:tc>
-              </a:tr>
             </a:tbl>
           </a:graphicData>
         </a:graphic>
@@ -5438,7 +3905,7 @@
         </p:nvSpPr>
         <p:spPr>
           <a:xfrm>
-            <a:off x="812800" y="5253602"/>
+            <a:off x="812800" y="6238249"/>
             <a:ext cx="10883392" cy="238753"/>
           </a:xfrm>
           <a:prstGeom prst="rect">
@@ -5462,57 +3929,13 @@
             <a:r>
               <a:rPr lang="en-US" sz="1200" dirty="0">
                 <a:solidFill>
-                  <a:srgbClr val="4A5568"/>
-                </a:solidFill>
-                <a:latin typeface="Arial" pitchFamily="34" charset="0"/>
-                <a:ea typeface="Arial" pitchFamily="34" charset="-122"/>
-                <a:cs typeface="Arial" pitchFamily="34" charset="-120"/>
-              </a:rPr>
-              <a:t>Default solver, 30-minute run · built by hand</a:t>
-            </a:r>
-            <a:endParaRPr lang="en-US" sz="1200" dirty="0"/>
-          </a:p>
-        </p:txBody>
-      </p:sp>
-      <p:sp>
-        <p:nvSpPr>
-          <p:cNvPr id="6" name="Text 3"/>
-          <p:cNvSpPr/>
-          <p:nvPr/>
-        </p:nvSpPr>
-        <p:spPr>
-          <a:xfrm>
-            <a:off x="812800" y="6238249"/>
-            <a:ext cx="10883392" cy="238753"/>
-          </a:xfrm>
-          <a:prstGeom prst="rect">
-            <a:avLst/>
-          </a:prstGeom>
-          <a:noFill/>
-          <a:ln/>
-        </p:spPr>
-        <p:txBody>
-          <a:bodyPr wrap="square" lIns="0" tIns="0" rIns="0" bIns="0" rtlCol="0" anchor="t">
-            <a:normAutofit/>
-          </a:bodyPr>
-          <a:lstStyle/>
-          <a:p>
-            <a:pPr algn="l" indent="0" marL="0">
-              <a:lnSpc>
-                <a:spcPts val="1680"/>
-              </a:lnSpc>
-              <a:buNone/>
-            </a:pPr>
-            <a:r>
-              <a:rPr lang="en-US" sz="1200" dirty="0">
-                <a:solidFill>
                   <a:srgbClr val="6B7486"/>
                 </a:solidFill>
                 <a:latin typeface="Arial" pitchFamily="34" charset="0"/>
                 <a:ea typeface="Arial" pitchFamily="34" charset="-122"/>
                 <a:cs typeface="Arial" pitchFamily="34" charset="-120"/>
               </a:rPr>
-              <a:t>PID Thermal Control for Heavy-Duty Trucks · 11</a:t>
+              <a:t>PID Thermal Control for Heavy-Duty Trucks · 10</a:t>
             </a:r>
             <a:endParaRPr lang="en-US" sz="1200" dirty="0"/>
           </a:p>
@@ -5588,7 +4011,7 @@
                 <a:ea typeface="Arial" pitchFamily="34" charset="-122"/>
                 <a:cs typeface="Arial" pitchFamily="34" charset="-120"/>
               </a:rPr>
-              <a:t>EXPERIMENT 2 · LOAD STEP 30 % → 70 %</a:t>
+              <a:t>EXPERIMENT 2 · WITH PID</a:t>
             </a:r>
             <a:endParaRPr lang="en-US" sz="1200" dirty="0"/>
           </a:p>
@@ -5634,7 +4057,7 @@
                 <a:ea typeface="Arial" pitchFamily="34" charset="-122"/>
                 <a:cs typeface="Arial" pitchFamily="34" charset="-120"/>
               </a:rPr>
-              <a:t>I removes the offset, D trims the peak</a:t>
+              <a:t>The PID holds the engine at 90 °C</a:t>
             </a:r>
             <a:endParaRPr lang="en-US" sz="3200" dirty="0"/>
           </a:p>
@@ -5761,7 +4184,7 @@
                           <a:ea typeface="Arial" pitchFamily="34" charset="-122"/>
                           <a:cs typeface="Arial" pitchFamily="34" charset="-120"/>
                         </a:rPr>
-                        <a:t>Ctrl</a:t>
+                        <a:t>Case</a:t>
                       </a:r>
                       <a:endParaRPr lang="en-US" sz="1300" dirty="0">
                         <a:latin typeface="Arial" charset="0"/>
@@ -6047,7 +4470,7 @@
                           <a:ea typeface="Arial" pitchFamily="34" charset="-122"/>
                           <a:cs typeface="Arial" pitchFamily="34" charset="-120"/>
                         </a:rPr>
-                        <a:t>P only</a:t>
+                        <a:t>No control</a:t>
                       </a:r>
                       <a:endParaRPr lang="en-US" sz="1300" dirty="0">
                         <a:latin typeface="Arial" charset="0"/>
@@ -6115,7 +4538,7 @@
                           <a:ea typeface="Arial" pitchFamily="34" charset="-122"/>
                           <a:cs typeface="Arial" pitchFamily="34" charset="-120"/>
                         </a:rPr>
-                        <a:t>1.18 K</a:t>
+                        <a:t>78.8 K</a:t>
                       </a:r>
                       <a:endParaRPr lang="en-US" sz="1300" dirty="0">
                         <a:latin typeface="Arial" charset="0"/>
@@ -6183,7 +4606,7 @@
                           <a:ea typeface="Arial" pitchFamily="34" charset="-122"/>
                           <a:cs typeface="Arial" pitchFamily="34" charset="-120"/>
                         </a:rPr>
-                        <a:t>39 s</a:t>
+                        <a:t>never</a:t>
                       </a:r>
                       <a:endParaRPr lang="en-US" sz="1300" dirty="0">
                         <a:latin typeface="Arial" charset="0"/>
@@ -6251,7 +4674,7 @@
                           <a:ea typeface="Arial" pitchFamily="34" charset="-122"/>
                           <a:cs typeface="Arial" pitchFamily="34" charset="-120"/>
                         </a:rPr>
-                        <a:t>0.84 K</a:t>
+                        <a:t>78.8 K</a:t>
                       </a:r>
                       <a:endParaRPr lang="en-US" sz="1300" dirty="0">
                         <a:latin typeface="Arial" charset="0"/>
@@ -6282,280 +4705,6 @@
                     <a:lnT w="12700" cap="flat" cmpd="sng" algn="ctr">
                       <a:solidFill>
                         <a:srgbClr val="B6B5B2"/>
-                      </a:solidFill>
-                      <a:prstDash val="solid"/>
-                      <a:round/>
-                      <a:headEnd type="none" w="med" len="med"/>
-                      <a:tailEnd type="none" w="med" len="med"/>
-                    </a:lnT>
-                    <a:lnB w="12700" cap="flat" cmpd="sng" algn="ctr">
-                      <a:solidFill>
-                        <a:srgbClr val="C4C4C0"/>
-                      </a:solidFill>
-                      <a:prstDash val="solid"/>
-                      <a:round/>
-                      <a:headEnd type="none" w="med" len="med"/>
-                      <a:tailEnd type="none" w="med" len="med"/>
-                    </a:lnB>
-                  </a:tcPr>
-                </a:tc>
-              </a:tr>
-              <a:tr h="359370">
-                <a:tc>
-                  <a:txBody>
-                    <a:bodyPr/>
-                    <a:lstStyle/>
-                    <a:p>
-                      <a:pPr indent="0" marL="0">
-                        <a:lnSpc>
-                          <a:spcPts val="1820"/>
-                        </a:lnSpc>
-                        <a:buNone/>
-                      </a:pPr>
-                      <a:r>
-                        <a:rPr lang="en-US" sz="1300" dirty="0">
-                          <a:solidFill>
-                            <a:srgbClr val="15233B"/>
-                          </a:solidFill>
-                          <a:latin typeface="Arial" pitchFamily="34" charset="0"/>
-                          <a:ea typeface="Arial" pitchFamily="34" charset="-122"/>
-                          <a:cs typeface="Arial" pitchFamily="34" charset="-120"/>
-                        </a:rPr>
-                        <a:t>PI</a:t>
-                      </a:r>
-                      <a:endParaRPr lang="en-US" sz="1300" dirty="0">
-                        <a:latin typeface="Arial" charset="0"/>
-                        <a:ea typeface="Arial" charset="0"/>
-                        <a:cs typeface="Arial" charset="0"/>
-                      </a:endParaRPr>
-                    </a:p>
-                  </a:txBody>
-                  <a:tcPr marL="57785" marR="57785" marT="57785" marB="57785" anchor="t">
-                    <a:lnL w="12700" cap="flat" cmpd="sng" algn="ctr">
-                      <a:solidFill>
-                        <a:srgbClr val="C4C4C0"/>
-                      </a:solidFill>
-                      <a:prstDash val="solid"/>
-                      <a:round/>
-                      <a:headEnd type="none" w="med" len="med"/>
-                      <a:tailEnd type="none" w="med" len="med"/>
-                    </a:lnL>
-                    <a:lnR w="12700" cap="flat" cmpd="sng" algn="ctr">
-                      <a:solidFill>
-                        <a:srgbClr val="C4C4C0"/>
-                      </a:solidFill>
-                      <a:prstDash val="solid"/>
-                      <a:round/>
-                      <a:headEnd type="none" w="med" len="med"/>
-                      <a:tailEnd type="none" w="med" len="med"/>
-                    </a:lnR>
-                    <a:lnT w="12700" cap="flat" cmpd="sng" algn="ctr">
-                      <a:solidFill>
-                        <a:srgbClr val="C4C4C0"/>
-                      </a:solidFill>
-                      <a:prstDash val="solid"/>
-                      <a:round/>
-                      <a:headEnd type="none" w="med" len="med"/>
-                      <a:tailEnd type="none" w="med" len="med"/>
-                    </a:lnT>
-                    <a:lnB w="12700" cap="flat" cmpd="sng" algn="ctr">
-                      <a:solidFill>
-                        <a:srgbClr val="C4C4C0"/>
-                      </a:solidFill>
-                      <a:prstDash val="solid"/>
-                      <a:round/>
-                      <a:headEnd type="none" w="med" len="med"/>
-                      <a:tailEnd type="none" w="med" len="med"/>
-                    </a:lnB>
-                  </a:tcPr>
-                </a:tc>
-                <a:tc>
-                  <a:txBody>
-                    <a:bodyPr/>
-                    <a:lstStyle/>
-                    <a:p>
-                      <a:pPr algn="r" indent="0" marL="0">
-                        <a:lnSpc>
-                          <a:spcPts val="1820"/>
-                        </a:lnSpc>
-                        <a:buNone/>
-                      </a:pPr>
-                      <a:r>
-                        <a:rPr lang="en-US" sz="1300" dirty="0">
-                          <a:solidFill>
-                            <a:srgbClr val="15233B"/>
-                          </a:solidFill>
-                          <a:latin typeface="Arial" pitchFamily="34" charset="0"/>
-                          <a:ea typeface="Arial" pitchFamily="34" charset="-122"/>
-                          <a:cs typeface="Arial" pitchFamily="34" charset="-120"/>
-                        </a:rPr>
-                        <a:t>1.10 K</a:t>
-                      </a:r>
-                      <a:endParaRPr lang="en-US" sz="1300" dirty="0">
-                        <a:latin typeface="Arial" charset="0"/>
-                        <a:ea typeface="Arial" charset="0"/>
-                        <a:cs typeface="Arial" charset="0"/>
-                      </a:endParaRPr>
-                    </a:p>
-                  </a:txBody>
-                  <a:tcPr marL="57785" marR="57785" marT="57785" marB="57785" anchor="t">
-                    <a:lnL w="12700" cap="flat" cmpd="sng" algn="ctr">
-                      <a:solidFill>
-                        <a:srgbClr val="C4C4C0"/>
-                      </a:solidFill>
-                      <a:prstDash val="solid"/>
-                      <a:round/>
-                      <a:headEnd type="none" w="med" len="med"/>
-                      <a:tailEnd type="none" w="med" len="med"/>
-                    </a:lnL>
-                    <a:lnR w="12700" cap="flat" cmpd="sng" algn="ctr">
-                      <a:solidFill>
-                        <a:srgbClr val="C4C4C0"/>
-                      </a:solidFill>
-                      <a:prstDash val="solid"/>
-                      <a:round/>
-                      <a:headEnd type="none" w="med" len="med"/>
-                      <a:tailEnd type="none" w="med" len="med"/>
-                    </a:lnR>
-                    <a:lnT w="12700" cap="flat" cmpd="sng" algn="ctr">
-                      <a:solidFill>
-                        <a:srgbClr val="C4C4C0"/>
-                      </a:solidFill>
-                      <a:prstDash val="solid"/>
-                      <a:round/>
-                      <a:headEnd type="none" w="med" len="med"/>
-                      <a:tailEnd type="none" w="med" len="med"/>
-                    </a:lnT>
-                    <a:lnB w="12700" cap="flat" cmpd="sng" algn="ctr">
-                      <a:solidFill>
-                        <a:srgbClr val="C4C4C0"/>
-                      </a:solidFill>
-                      <a:prstDash val="solid"/>
-                      <a:round/>
-                      <a:headEnd type="none" w="med" len="med"/>
-                      <a:tailEnd type="none" w="med" len="med"/>
-                    </a:lnB>
-                  </a:tcPr>
-                </a:tc>
-                <a:tc>
-                  <a:txBody>
-                    <a:bodyPr/>
-                    <a:lstStyle/>
-                    <a:p>
-                      <a:pPr algn="r" indent="0" marL="0">
-                        <a:lnSpc>
-                          <a:spcPts val="1820"/>
-                        </a:lnSpc>
-                        <a:buNone/>
-                      </a:pPr>
-                      <a:r>
-                        <a:rPr lang="en-US" sz="1300" dirty="0">
-                          <a:solidFill>
-                            <a:srgbClr val="15233B"/>
-                          </a:solidFill>
-                          <a:latin typeface="Arial" pitchFamily="34" charset="0"/>
-                          <a:ea typeface="Arial" pitchFamily="34" charset="-122"/>
-                          <a:cs typeface="Arial" pitchFamily="34" charset="-120"/>
-                        </a:rPr>
-                        <a:t>112 s</a:t>
-                      </a:r>
-                      <a:endParaRPr lang="en-US" sz="1300" dirty="0">
-                        <a:latin typeface="Arial" charset="0"/>
-                        <a:ea typeface="Arial" charset="0"/>
-                        <a:cs typeface="Arial" charset="0"/>
-                      </a:endParaRPr>
-                    </a:p>
-                  </a:txBody>
-                  <a:tcPr marL="57785" marR="57785" marT="57785" marB="57785" anchor="t">
-                    <a:lnL w="12700" cap="flat" cmpd="sng" algn="ctr">
-                      <a:solidFill>
-                        <a:srgbClr val="C4C4C0"/>
-                      </a:solidFill>
-                      <a:prstDash val="solid"/>
-                      <a:round/>
-                      <a:headEnd type="none" w="med" len="med"/>
-                      <a:tailEnd type="none" w="med" len="med"/>
-                    </a:lnL>
-                    <a:lnR w="12700" cap="flat" cmpd="sng" algn="ctr">
-                      <a:solidFill>
-                        <a:srgbClr val="C4C4C0"/>
-                      </a:solidFill>
-                      <a:prstDash val="solid"/>
-                      <a:round/>
-                      <a:headEnd type="none" w="med" len="med"/>
-                      <a:tailEnd type="none" w="med" len="med"/>
-                    </a:lnR>
-                    <a:lnT w="12700" cap="flat" cmpd="sng" algn="ctr">
-                      <a:solidFill>
-                        <a:srgbClr val="C4C4C0"/>
-                      </a:solidFill>
-                      <a:prstDash val="solid"/>
-                      <a:round/>
-                      <a:headEnd type="none" w="med" len="med"/>
-                      <a:tailEnd type="none" w="med" len="med"/>
-                    </a:lnT>
-                    <a:lnB w="12700" cap="flat" cmpd="sng" algn="ctr">
-                      <a:solidFill>
-                        <a:srgbClr val="C4C4C0"/>
-                      </a:solidFill>
-                      <a:prstDash val="solid"/>
-                      <a:round/>
-                      <a:headEnd type="none" w="med" len="med"/>
-                      <a:tailEnd type="none" w="med" len="med"/>
-                    </a:lnB>
-                  </a:tcPr>
-                </a:tc>
-                <a:tc>
-                  <a:txBody>
-                    <a:bodyPr/>
-                    <a:lstStyle/>
-                    <a:p>
-                      <a:pPr algn="r" indent="0" marL="0">
-                        <a:lnSpc>
-                          <a:spcPts val="1820"/>
-                        </a:lnSpc>
-                        <a:buNone/>
-                      </a:pPr>
-                      <a:r>
-                        <a:rPr lang="en-US" sz="1300" dirty="0">
-                          <a:solidFill>
-                            <a:srgbClr val="15233B"/>
-                          </a:solidFill>
-                          <a:latin typeface="Arial" pitchFamily="34" charset="0"/>
-                          <a:ea typeface="Arial" pitchFamily="34" charset="-122"/>
-                          <a:cs typeface="Arial" pitchFamily="34" charset="-120"/>
-                        </a:rPr>
-                        <a:t>0</a:t>
-                      </a:r>
-                      <a:endParaRPr lang="en-US" sz="1300" dirty="0">
-                        <a:latin typeface="Arial" charset="0"/>
-                        <a:ea typeface="Arial" charset="0"/>
-                        <a:cs typeface="Arial" charset="0"/>
-                      </a:endParaRPr>
-                    </a:p>
-                  </a:txBody>
-                  <a:tcPr marL="57785" marR="57785" marT="57785" marB="57785" anchor="t">
-                    <a:lnL w="12700" cap="flat" cmpd="sng" algn="ctr">
-                      <a:solidFill>
-                        <a:srgbClr val="C4C4C0"/>
-                      </a:solidFill>
-                      <a:prstDash val="solid"/>
-                      <a:round/>
-                      <a:headEnd type="none" w="med" len="med"/>
-                      <a:tailEnd type="none" w="med" len="med"/>
-                    </a:lnL>
-                    <a:lnR w="12700" cap="flat" cmpd="sng" algn="ctr">
-                      <a:solidFill>
-                        <a:srgbClr val="C4C4C0"/>
-                      </a:solidFill>
-                      <a:prstDash val="solid"/>
-                      <a:round/>
-                      <a:headEnd type="none" w="med" len="med"/>
-                      <a:tailEnd type="none" w="med" len="med"/>
-                    </a:lnR>
-                    <a:lnT w="12700" cap="flat" cmpd="sng" algn="ctr">
-                      <a:solidFill>
-                        <a:srgbClr val="C4C4C0"/>
                       </a:solidFill>
                       <a:prstDash val="solid"/>
                       <a:round/>
@@ -6890,7 +5039,7 @@
                 <a:ea typeface="Arial" pitchFamily="34" charset="-122"/>
                 <a:cs typeface="Arial" pitchFamily="34" charset="-120"/>
               </a:rPr>
-              <a:t>P alone needs an error to produce output, so it settles </a:t>
+              <a:t>The fan reacts at once: the temperature rises only </a:t>
             </a:r>
             <a:r>
               <a:rPr lang="en-US" sz="1400" b="1" dirty="0">
@@ -6901,7 +5050,7 @@
                 <a:ea typeface="Arial" pitchFamily="34" charset="-122"/>
                 <a:cs typeface="Arial" pitchFamily="34" charset="-120"/>
               </a:rPr>
-              <a:t>0.8 K too hot</a:t>
+              <a:t>0.77 K</a:t>
             </a:r>
             <a:r>
               <a:rPr lang="en-US" sz="1400" dirty="0">
@@ -6912,7 +5061,7 @@
                 <a:ea typeface="Arial" pitchFamily="34" charset="-122"/>
                 <a:cs typeface="Arial" pitchFamily="34" charset="-120"/>
               </a:rPr>
-              <a:t>. Adding I brings it back to exactly 90 °C. Adding D cuts the peak by about 30 %.</a:t>
+              <a:t> and is back at exactly 90 °C in under 2 minutes.</a:t>
             </a:r>
             <a:endParaRPr lang="en-US" sz="1400" dirty="0"/>
           </a:p>
@@ -6956,7 +5105,7 @@
                 <a:ea typeface="Arial" pitchFamily="34" charset="-122"/>
                 <a:cs typeface="Arial" pitchFamily="34" charset="-120"/>
               </a:rPr>
-              <a:t>PID Thermal Control for Heavy-Duty Trucks · 13</a:t>
+              <a:t>PID Thermal Control for Heavy-Duty Trucks · 12</a:t>
             </a:r>
             <a:endParaRPr lang="en-US" sz="1200" dirty="0"/>
           </a:p>
@@ -7032,7 +5181,7 @@
                 <a:ea typeface="Arial" pitchFamily="34" charset="-122"/>
                 <a:cs typeface="Arial" pitchFamily="34" charset="-120"/>
               </a:rPr>
-              <a:t>EXPERIMENT 1 · SET-POINT 90 → 95 °C</a:t>
+              <a:t>EXPERIMENT 1 · NO CONTROLLER</a:t>
             </a:r>
             <a:endParaRPr lang="en-US" sz="1200" dirty="0"/>
           </a:p>
@@ -7078,7 +5227,7 @@
                 <a:ea typeface="Arial" pitchFamily="34" charset="-122"/>
                 <a:cs typeface="Arial" pitchFamily="34" charset="-120"/>
               </a:rPr>
-              <a:t>The temperature follows a new set-point</a:t>
+              <a:t>Without control, the engine overheats</a:t>
             </a:r>
             <a:endParaRPr lang="en-US" sz="3200" dirty="0"/>
           </a:p>
@@ -7194,7 +5343,7 @@
                 <a:ea typeface="Arial" pitchFamily="34" charset="-122"/>
                 <a:cs typeface="Arial" pitchFamily="34" charset="-120"/>
               </a:rPr>
-              <a:t>Tracking</a:t>
+              <a:t>Load 30 → 70 %</a:t>
             </a:r>
             <a:endParaRPr lang="en-US" sz="1600" dirty="0"/>
           </a:p>
@@ -7238,7 +5387,7 @@
                 <a:ea typeface="Arial" pitchFamily="34" charset="-122"/>
                 <a:cs typeface="Arial" pitchFamily="34" charset="-120"/>
               </a:rPr>
-              <a:t>PID reaches 95 °C with 12.6 % overshoot and settles in about 121 s.</a:t>
+              <a:t>The temperature keeps rising: 169 °C after one hour.</a:t>
             </a:r>
             <a:endParaRPr lang="en-US" sz="1300" dirty="0"/>
           </a:p>
@@ -7282,7 +5431,7 @@
                 <a:ea typeface="Arial" pitchFamily="34" charset="-122"/>
                 <a:cs typeface="Arial" pitchFamily="34" charset="-120"/>
               </a:rPr>
-              <a:t>P only</a:t>
+              <a:t>Why</a:t>
             </a:r>
             <a:endParaRPr lang="en-US" sz="1600" dirty="0"/>
           </a:p>
@@ -7326,7 +5475,7 @@
                 <a:ea typeface="Arial" pitchFamily="34" charset="-122"/>
                 <a:cs typeface="Arial" pitchFamily="34" charset="-120"/>
               </a:rPr>
-              <a:t>Stops 0.05 K short. PI removes that but overshoots 41 %.</a:t>
+              <a:t>Nothing removes the extra 68 kW. It only stops at 90 + 40 × 2.0 = 170 °C.</a:t>
             </a:r>
             <a:endParaRPr lang="en-US" sz="1300" dirty="0"/>
           </a:p>
@@ -7370,7 +5519,7 @@
                 <a:ea typeface="Arial" pitchFamily="34" charset="-122"/>
                 <a:cs typeface="Arial" pitchFamily="34" charset="-120"/>
               </a:rPr>
-              <a:t>PID Thermal Control for Heavy-Duty Trucks · 12</a:t>
+              <a:t>PID Thermal Control for Heavy-Duty Trucks · 11</a:t>
             </a:r>
             <a:endParaRPr lang="en-US" sz="1200" dirty="0"/>
           </a:p>
@@ -7630,7 +5779,7 @@
                 <a:ea typeface="Arial" pitchFamily="34" charset="-122"/>
                 <a:cs typeface="Arial" pitchFamily="34" charset="-120"/>
               </a:rPr>
-              <a:t>PID holds 90 °C with zero offset. P only, like today's wax thermostat, stays 0.8 K too hot. D cuts the peak by about 30 %.</a:t>
+              <a:t>Without control the engine would reach 170 °C. The PID keeps it within 0.8 K and brings it back to 90 °C.</a:t>
             </a:r>
             <a:endParaRPr lang="en-US" sz="1300" dirty="0"/>
           </a:p>
@@ -7768,7 +5917,7 @@
                 <a:ea typeface="Arial" pitchFamily="34" charset="-122"/>
                 <a:cs typeface="Arial" pitchFamily="34" charset="-120"/>
               </a:rPr>
-              <a:t>Linear, one lumped mass, fan only. Data from published sources (slide 15), not our own tests.</a:t>
+              <a:t>Linear, one lumped mass, fan only. Data from published sources (slide 14), not our own tests.</a:t>
             </a:r>
             <a:endParaRPr lang="en-US" sz="1300" dirty="0"/>
           </a:p>
@@ -7972,7 +6121,7 @@
                 <a:ea typeface="Arial" pitchFamily="34" charset="-122"/>
                 <a:cs typeface="Arial" pitchFamily="34" charset="-120"/>
               </a:rPr>
-              <a:t>PID Thermal Control for Heavy-Duty Trucks · 14</a:t>
+              <a:t>PID Thermal Control for Heavy-Duty Trucks · 13</a:t>
             </a:r>
             <a:endParaRPr lang="en-US" sz="1200" dirty="0"/>
           </a:p>
@@ -9970,7 +8119,7 @@
                           <a:ea typeface="Arial" pitchFamily="34" charset="-122"/>
                           <a:cs typeface="Arial" pitchFamily="34" charset="-120"/>
                         </a:rPr>
-                        <a:t>N = 100; final value theorem</a:t>
+                        <a:t>Closed loop Gd / (1 + C·G)</a:t>
                       </a:r>
                       <a:endParaRPr lang="en-US" sz="1300" dirty="0">
                         <a:latin typeface="Arial" charset="0"/>
@@ -10038,7 +8187,7 @@
                           <a:ea typeface="Arial" pitchFamily="34" charset="-122"/>
                           <a:cs typeface="Arial" pitchFamily="34" charset="-120"/>
                         </a:rPr>
-                        <a:t>Simulink PID default; Nise, Control Systems Eng.</a:t>
+                        <a:t>Nise, Control Systems Engineering</a:t>
                       </a:r>
                       <a:endParaRPr lang="en-US" sz="1300" dirty="0">
                         <a:latin typeface="Arial" charset="0"/>
@@ -10129,7 +8278,7 @@
                 <a:ea typeface="Arial" pitchFamily="34" charset="-122"/>
                 <a:cs typeface="Arial" pitchFamily="34" charset="-120"/>
               </a:rPr>
-              <a:t>PID Thermal Control for Heavy-Duty Trucks · 15</a:t>
+              <a:t>PID Thermal Control for Heavy-Duty Trucks · 14</a:t>
             </a:r>
             <a:endParaRPr lang="en-US" sz="1200" dirty="0"/>
           </a:p>
@@ -11224,7 +9373,7 @@
                 <a:ea typeface="Arial" pitchFamily="34" charset="-122"/>
                 <a:cs typeface="Arial" pitchFamily="34" charset="-120"/>
               </a:rPr>
-              <a:t>PID with filter, output limit and anti-windup</a:t>
+              <a:t>PID with gains from the SIMC tuning rule</a:t>
             </a:r>
             <a:endParaRPr lang="en-US" sz="1400" dirty="0"/>
           </a:p>
@@ -11383,7 +9532,7 @@
                 <a:ea typeface="Arial" pitchFamily="34" charset="-122"/>
                 <a:cs typeface="Arial" pitchFamily="34" charset="-120"/>
               </a:rPr>
-              <a:t>Set-point and load steps in MATLAB, same loop in Simulink</a:t>
+              <a:t>One load step in MATLAB, with and without the PID</a:t>
             </a:r>
             <a:endParaRPr lang="en-US" sz="1400" dirty="0"/>
           </a:p>
@@ -11542,7 +9691,7 @@
                 <a:ea typeface="Arial" pitchFamily="34" charset="-122"/>
                 <a:cs typeface="Arial" pitchFamily="34" charset="-120"/>
               </a:rPr>
-              <a:t>P only vs PI vs PID: offset, peak and settling time</a:t>
+              <a:t>No controller vs PID: how hot does the engine get?</a:t>
             </a:r>
             <a:endParaRPr lang="en-US" sz="1400" dirty="0"/>
           </a:p>
@@ -14146,7 +12295,7 @@
                 <a:ea typeface="Arial" pitchFamily="34" charset="-122"/>
                 <a:cs typeface="Arial" pitchFamily="34" charset="-120"/>
               </a:rPr>
-              <a:t>Data: Volvo D13 fact sheet, COBEM 2009, IOSR 2018, Chalmers 2011, Engineering ToolBox (slide 15)</a:t>
+              <a:t>Data: Volvo D13 fact sheet, COBEM 2009, IOSR 2018, Chalmers 2011, Engineering ToolBox (slide 14)</a:t>
             </a:r>
             <a:endParaRPr lang="en-US" sz="1300" dirty="0"/>
           </a:p>
@@ -14999,7 +13148,7 @@
                 <a:ea typeface="Arial" pitchFamily="34" charset="-122"/>
                 <a:cs typeface="Arial" pitchFamily="34" charset="-120"/>
               </a:rPr>
-              <a:t>Three additions make it work on a real system</a:t>
+              <a:t>How the PID is set up</a:t>
             </a:r>
             <a:endParaRPr lang="en-US" sz="3200" dirty="0"/>
           </a:p>
@@ -15773,7 +13922,7 @@
                 <a:ea typeface="Arial" pitchFamily="34" charset="-122"/>
                 <a:cs typeface="Arial" pitchFamily="34" charset="-120"/>
               </a:rPr>
-              <a:t>Anti-windup</a:t>
+              <a:t>SIMC tuning</a:t>
             </a:r>
             <a:endParaRPr lang="en-US" sz="1700" dirty="0"/>
           </a:p>
@@ -15817,7 +13966,7 @@
                 <a:ea typeface="Arial" pitchFamily="34" charset="-122"/>
                 <a:cs typeface="Arial" pitchFamily="34" charset="-120"/>
               </a:rPr>
-              <a:t>When the actuators are already at their limit, the integral stops adding up. Without it, I grows huge and the temperature overshoots.</a:t>
+              <a:t>The gains are calculated from the plant with Skogestad's SIMC rule (2003), not found by trial and error.</a:t>
             </a:r>
             <a:endParaRPr lang="en-US" sz="1300" dirty="0"/>
           </a:p>
@@ -15932,7 +14081,7 @@
                 <a:ea typeface="Arial" pitchFamily="34" charset="-122"/>
                 <a:cs typeface="Arial" pitchFamily="34" charset="-120"/>
               </a:rPr>
-              <a:t>Simulink's default filter (N = 100) on the D term, so sensor noise is not amplified.</a:t>
+              <a:t>A 0.01 s filter on the D term, Kd·s/(0.01s + 1), so noise is not amplified.</a:t>
             </a:r>
             <a:endParaRPr lang="en-US" sz="1300" dirty="0"/>
           </a:p>
@@ -15976,7 +14125,7 @@
                 <a:ea typeface="Arial" pitchFamily="34" charset="-122"/>
                 <a:cs typeface="Arial" pitchFamily="34" charset="-120"/>
               </a:rPr>
-              <a:t>SIMC gains</a:t>
+              <a:t>PID gains</a:t>
             </a:r>
             <a:endParaRPr lang="en-US" sz="1400" dirty="0"/>
           </a:p>
@@ -16168,7 +14317,7 @@
                 <a:ea typeface="Arial" pitchFamily="34" charset="-122"/>
                 <a:cs typeface="Arial" pitchFamily="34" charset="-120"/>
               </a:rPr>
-              <a:t>N = 100</a:t>
+              <a:t>Tf = 0.01 s</a:t>
             </a:r>
             <a:endParaRPr lang="en-US" sz="1400" dirty="0"/>
           </a:p>

</xml_diff>

<commit_message>
Deck: use the combined no-PID vs PID graph and the zoomed graph
Co-Authored-By: Claude Opus 5.5 <noreply@anthropic.com>
Claude-Session: https://claude.ai/code/session_01KYcVruEhgF1vnL4e2wj7fD
</commit_message>
<xml_diff>
--- a/PID_Thermal_Control_for_Heavy-Duty_Trucks_v2.pptx
+++ b/PID_Thermal_Control_for_Heavy-Duty_Trucks_v2.pptx
@@ -692,7 +692,7 @@
           <a:p>
             <a:r>
               <a:rPr lang="en-US" dirty="0"/>
-              <a:t>Now the same load step with the PID. As soon as the temperature starts to rise, the PID increases the fan air flow, from 1.58 to about 3.7 kg per second. The temperature peaks only 0.77 K above 90 °C, and the integral term brings it back to exactly 90 °C, staying within 0.1 K after about 104 seconds. Compared with no control, that is 0.77 K instead of 79 K. The poles printed by pole() all have negative real parts, so the loop is stable.</a:t>
+              <a:t>Here we zoom in on the moment the load goes up, at the green line. Before that, both cases sit at 90 °C. After it, the red line with no PID climbs straight up and leaves the graph in under 30 seconds. The blue line with the PID rises only 0.77 K, because the PID increases the fan air flow as soon as the temperature starts to rise, from 1.58 to about 3.7 kg per second. The integral term then brings it back to exactly 90 °C, within 0.1 K after about 104 seconds. In the table, no control gives a 70 K rise after 30 minutes; the PID gives 0.77 K and no offset.</a:t>
             </a:r>
             <a:endParaRPr lang="en-US" dirty="0"/>
           </a:p>
@@ -780,7 +780,7 @@
           <a:p>
             <a:r>
               <a:rPr lang="en-US" dirty="0"/>
-              <a:t>First, what happens with no controller. The engine load jumps from 30 to 70 percent, which adds 68 kW of heat to the coolant, and the fan stays where it was. The temperature keeps climbing with the engine's 851-second time constant: after one hour it is at 169 °C, far above the 105 °C limit, and it would only stop at 90 plus 40 times 2, which is 170 °C. In a real engine the coolant would boil long before that. This is why the engine needs a controller.</a:t>
+              <a:t>This is our main result. At time zero the engine load jumps from 30 to 70 percent, which adds 68 kW of heat to the coolant. The red line is the engine with no PID: nothing removes the extra heat, so the temperature passes the 105 °C limit after about three minutes and is at 160 °C after half an hour. It would only stop at 90 plus 40 times 2, which is 170 °C. The blue line is the same engine with our PID controlling the fan: it stays at 90 °C the whole time. The next slide zooms in on the first two and a half minutes.</a:t>
             </a:r>
             <a:endParaRPr lang="en-US" dirty="0"/>
           </a:p>
@@ -4011,7 +4011,7 @@
                 <a:ea typeface="Arial" pitchFamily="34" charset="-122"/>
                 <a:cs typeface="Arial" pitchFamily="34" charset="-120"/>
               </a:rPr>
-              <a:t>EXPERIMENT 2 · WITH PID</a:t>
+              <a:t>ZOOM · FIRST 150 SECONDS</a:t>
             </a:r>
             <a:endParaRPr lang="en-US" sz="1200" dirty="0"/>
           </a:p>
@@ -4057,7 +4057,7 @@
                 <a:ea typeface="Arial" pitchFamily="34" charset="-122"/>
                 <a:cs typeface="Arial" pitchFamily="34" charset="-120"/>
               </a:rPr>
-              <a:t>The PID holds the engine at 90 °C</a:t>
+              <a:t>The PID pulls the temperature back to 90 °C</a:t>
             </a:r>
             <a:endParaRPr lang="en-US" sz="3200" dirty="0"/>
           </a:p>
@@ -4538,7 +4538,7 @@
                           <a:ea typeface="Arial" pitchFamily="34" charset="-122"/>
                           <a:cs typeface="Arial" pitchFamily="34" charset="-120"/>
                         </a:rPr>
-                        <a:t>78.8 K</a:t>
+                        <a:t>70.3 K</a:t>
                       </a:r>
                       <a:endParaRPr lang="en-US" sz="1300" dirty="0">
                         <a:latin typeface="Arial" charset="0"/>
@@ -4674,7 +4674,7 @@
                           <a:ea typeface="Arial" pitchFamily="34" charset="-122"/>
                           <a:cs typeface="Arial" pitchFamily="34" charset="-120"/>
                         </a:rPr>
-                        <a:t>78.8 K</a:t>
+                        <a:t>70.3 K</a:t>
                       </a:r>
                       <a:endParaRPr lang="en-US" sz="1300" dirty="0">
                         <a:latin typeface="Arial" charset="0"/>
@@ -5181,7 +5181,7 @@
                 <a:ea typeface="Arial" pitchFamily="34" charset="-122"/>
                 <a:cs typeface="Arial" pitchFamily="34" charset="-120"/>
               </a:rPr>
-              <a:t>EXPERIMENT 1 · NO CONTROLLER</a:t>
+              <a:t>EXPERIMENT · LOAD 30 → 70 %</a:t>
             </a:r>
             <a:endParaRPr lang="en-US" sz="1200" dirty="0"/>
           </a:p>
@@ -5227,7 +5227,7 @@
                 <a:ea typeface="Arial" pitchFamily="34" charset="-122"/>
                 <a:cs typeface="Arial" pitchFamily="34" charset="-120"/>
               </a:rPr>
-              <a:t>Without control, the engine overheats</a:t>
+              <a:t>Without PID the engine overheats</a:t>
             </a:r>
             <a:endParaRPr lang="en-US" sz="3200" dirty="0"/>
           </a:p>
@@ -5343,7 +5343,7 @@
                 <a:ea typeface="Arial" pitchFamily="34" charset="-122"/>
                 <a:cs typeface="Arial" pitchFamily="34" charset="-120"/>
               </a:rPr>
-              <a:t>Load 30 → 70 %</a:t>
+              <a:t>No PID</a:t>
             </a:r>
             <a:endParaRPr lang="en-US" sz="1600" dirty="0"/>
           </a:p>
@@ -5387,7 +5387,7 @@
                 <a:ea typeface="Arial" pitchFamily="34" charset="-122"/>
                 <a:cs typeface="Arial" pitchFamily="34" charset="-120"/>
               </a:rPr>
-              <a:t>The temperature keeps rising: 169 °C after one hour.</a:t>
+              <a:t>Passes 105 °C after about 3 minutes, 160 °C after 30 minutes.</a:t>
             </a:r>
             <a:endParaRPr lang="en-US" sz="1300" dirty="0"/>
           </a:p>
@@ -5431,7 +5431,7 @@
                 <a:ea typeface="Arial" pitchFamily="34" charset="-122"/>
                 <a:cs typeface="Arial" pitchFamily="34" charset="-120"/>
               </a:rPr>
-              <a:t>Why</a:t>
+              <a:t>With PID</a:t>
             </a:r>
             <a:endParaRPr lang="en-US" sz="1600" dirty="0"/>
           </a:p>
@@ -5475,7 +5475,7 @@
                 <a:ea typeface="Arial" pitchFamily="34" charset="-122"/>
                 <a:cs typeface="Arial" pitchFamily="34" charset="-120"/>
               </a:rPr>
-              <a:t>Nothing removes the extra 68 kW. It only stops at 90 + 40 × 2.0 = 170 °C.</a:t>
+              <a:t>Stays at 90 °C the whole time: the blue line is almost flat.</a:t>
             </a:r>
             <a:endParaRPr lang="en-US" sz="1300" dirty="0"/>
           </a:p>

</xml_diff>

<commit_message>
Deck graphs: add engine load under the temperature
Co-Authored-By: Claude Opus 5.5 <noreply@anthropic.com>
Claude-Session: https://claude.ai/code/session_01KYcVruEhgF1vnL4e2wj7fD
</commit_message>
<xml_diff>
--- a/PID_Thermal_Control_for_Heavy-Duty_Trucks_v2.pptx
+++ b/PID_Thermal_Control_for_Heavy-Duty_Trucks_v2.pptx
@@ -692,7 +692,7 @@
           <a:p>
             <a:r>
               <a:rPr lang="en-US" dirty="0"/>
-              <a:t>Here we zoom in on the moment the load goes up, at the green line. Before that, both cases sit at 90 °C. After it, the red line with no PID climbs straight up and leaves the graph in under 30 seconds. The blue line with the PID rises only 0.77 K, because the PID increases the fan air flow as soon as the temperature starts to rise, from 1.58 to about 3.7 kg per second. The integral term then brings it back to exactly 90 °C, within 0.1 K after about 104 seconds. In the table, no control gives a 70 K rise after 30 minutes; the PID gives 0.77 K and no offset.</a:t>
+              <a:t>Here we zoom in on the moment the load goes up; the green line in the lower plot is the engine load, stepping from 30 to 70 percent at time zero. Before that, both cases sit at 90 °C. After it, the red line with no PID climbs straight up and leaves the graph in under 30 seconds. The blue line with the PID rises only 0.77 K, because the PID increases the fan air flow as soon as the temperature starts to rise, from 1.58 to about 3.7 kg per second. The integral term then brings it back to exactly 90 °C, within 0.1 K after about 104 seconds. In the table, no control gives a 70 K rise after 30 minutes; the PID gives 0.77 K and no offset.</a:t>
             </a:r>
             <a:endParaRPr lang="en-US" dirty="0"/>
           </a:p>
@@ -780,7 +780,7 @@
           <a:p>
             <a:r>
               <a:rPr lang="en-US" dirty="0"/>
-              <a:t>This is our main result. At time zero the engine load jumps from 30 to 70 percent, which adds 68 kW of heat to the coolant. The red line is the engine with no PID: nothing removes the extra heat, so the temperature passes the 105 °C limit after about three minutes and is at 160 °C after half an hour. It would only stop at 90 plus 40 times 2, which is 170 °C. The blue line is the same engine with our PID controlling the fan: it stays at 90 °C the whole time. The next slide zooms in on the first two and a half minutes.</a:t>
+              <a:t>This is our main result. The lower plot shows the engine load: at time zero it jumps from 30 to 70 percent, which adds 68 kW of heat to the coolant. The red line is the engine with no PID: nothing removes the extra heat, so the temperature passes the 105 °C limit after about three minutes and is at 160 °C after half an hour. It would only stop at 90 plus 40 times 2, which is 170 °C. The blue line is the same engine with our PID controlling the fan: it stays at 90 °C the whole time. The next slide zooms in on the first two and a half minutes.</a:t>
             </a:r>
             <a:endParaRPr lang="en-US" dirty="0"/>
           </a:p>

</xml_diff>

<commit_message>
Ramp the engine load linearly over 60 s and show it on a right axis; two graphs only
Co-Authored-By: Claude Opus 5.5 <noreply@anthropic.com>
Claude-Session: https://claude.ai/code/session_01KYcVruEhgF1vnL4e2wj7fD
</commit_message>
<xml_diff>
--- a/PID_Thermal_Control_for_Heavy-Duty_Trucks_v2.pptx
+++ b/PID_Thermal_Control_for_Heavy-Duty_Trucks_v2.pptx
@@ -604,7 +604,7 @@
           <a:p>
             <a:r>
               <a:rPr lang="en-US" dirty="0"/>
-              <a:t>All the MATLAB code is one short file, pid_truck_cooling.m. It defines the two plant transfer functions with num, den and tf, and the PID by adding three transfer functions. Then it runs one test twice: the engine load steps from 30 to 70 percent, first with no controller using step on Gd, then with the PID using Gd times feedback of 1 and C times G. It plots the two responses, prints the temperatures, and uses pole() to check that all closed-loop poles are negative, so the loop is stable.</a:t>
+              <a:t>All the MATLAB code is one short file, pid_truck_cooling.m. It takes every number from the sources, calculates the two plant transfer functions with num, den and tf, and the PID gains with the SIMC rule. The engine load is a ramp: 30 percent for 20 seconds, then rising linearly to 70 percent over 60 seconds. lsim runs that load through the plant twice, first with no controller and then with the PID closed by feedback. Two graphs show the temperature with and without the PID, with the engine load on the right-hand axis. pole() checks that all closed-loop poles are negative, so the loop is stable.</a:t>
             </a:r>
             <a:endParaRPr lang="en-US" dirty="0"/>
           </a:p>
@@ -692,7 +692,7 @@
           <a:p>
             <a:r>
               <a:rPr lang="en-US" dirty="0"/>
-              <a:t>Here we zoom in on the moment the load goes up; the green line in the lower plot is the engine load, stepping from 30 to 70 percent at time zero. Before that, both cases sit at 90 °C. After it, the red line with no PID climbs straight up and leaves the graph in under 30 seconds. The blue line with the PID rises only 0.77 K, because the PID increases the fan air flow as soon as the temperature starts to rise, from 1.58 to about 3.7 kg per second. The integral term then brings it back to exactly 90 °C, within 0.1 K after about 104 seconds. In the table, no control gives a 70 K rise after 30 minutes; the PID gives 0.77 K and no offset.</a:t>
+              <a:t>Here we zoom in on the first 200 seconds. The green line is the engine load, rising from 30 to 70 percent between 20 and 80 seconds. The red line with no PID climbs faster and faster and leaves the graph at about 85 seconds. The blue line with the PID rises only 0.60 K while the load is going up, because the PID increases the fan air flow as soon as the temperature starts to rise. Once the load stops rising, the integral term brings the temperature back to exactly 90 °C; it is within 0.1 K at 159 seconds. In the table, no control gives a 70 K rise after 30 minutes; the PID gives 0.60 K and no offset.</a:t>
             </a:r>
             <a:endParaRPr lang="en-US" dirty="0"/>
           </a:p>
@@ -780,7 +780,7 @@
           <a:p>
             <a:r>
               <a:rPr lang="en-US" dirty="0"/>
-              <a:t>This is our main result. The lower plot shows the engine load: at time zero it jumps from 30 to 70 percent, which adds 68 kW of heat to the coolant. The red line is the engine with no PID: nothing removes the extra heat, so the temperature passes the 105 °C limit after about three minutes and is at 160 °C after half an hour. It would only stop at 90 plus 40 times 2, which is 170 °C. The blue line is the same engine with our PID controlling the fan: it stays at 90 °C the whole time. The next slide zooms in on the first two and a half minutes.</a:t>
+              <a:t>This is our main result. The green line, on the right-hand axis, is the engine load: it rises linearly from 30 to 70 percent over one minute, like the truck starting up a hill. That adds 68 kW of heat to the coolant. The red line is the engine with no PID: nothing removes the extra heat, so the temperature passes the 105 °C limit after about four minutes and is at 160 °C after half an hour. The blue line is the same engine with our PID controlling the fan: it stays at 90 °C the whole time. The next slide zooms in on the first 200 seconds.</a:t>
             </a:r>
             <a:endParaRPr lang="en-US" dirty="0"/>
           </a:p>
@@ -3292,7 +3292,7 @@
                           <a:ea typeface="Arial" pitchFamily="34" charset="-122"/>
                           <a:cs typeface="Arial" pitchFamily="34" charset="-120"/>
                         </a:rPr>
-                        <a:t>step(40*Gd): load 30 → 70 %, plot 1</a:t>
+                        <a:t>lsim(Gd, load): load ramps 30 → 70 %</a:t>
                       </a:r>
                       <a:endParaRPr lang="en-US" sz="1300" dirty="0">
                         <a:latin typeface="Arial" charset="0"/>
@@ -3430,7 +3430,7 @@
                           <a:ea typeface="Arial" pitchFamily="34" charset="-122"/>
                           <a:cs typeface="Arial" pitchFamily="34" charset="-120"/>
                         </a:rPr>
-                        <a:t>Gd*feedback(1, C*G), step(), plot 2</a:t>
+                        <a:t>Gd*feedback(1, C*G), lsim(); 2 graphs</a:t>
                       </a:r>
                       <a:endParaRPr lang="en-US" sz="1300" dirty="0">
                         <a:latin typeface="Arial" charset="0"/>
@@ -4011,7 +4011,7 @@
                 <a:ea typeface="Arial" pitchFamily="34" charset="-122"/>
                 <a:cs typeface="Arial" pitchFamily="34" charset="-120"/>
               </a:rPr>
-              <a:t>ZOOM · FIRST 150 SECONDS</a:t>
+              <a:t>ZOOM · FIRST 200 SECONDS</a:t>
             </a:r>
             <a:endParaRPr lang="en-US" sz="1200" dirty="0"/>
           </a:p>
@@ -4538,7 +4538,7 @@
                           <a:ea typeface="Arial" pitchFamily="34" charset="-122"/>
                           <a:cs typeface="Arial" pitchFamily="34" charset="-120"/>
                         </a:rPr>
-                        <a:t>70.3 K</a:t>
+                        <a:t>69.8 K</a:t>
                       </a:r>
                       <a:endParaRPr lang="en-US" sz="1300" dirty="0">
                         <a:latin typeface="Arial" charset="0"/>
@@ -4674,7 +4674,7 @@
                           <a:ea typeface="Arial" pitchFamily="34" charset="-122"/>
                           <a:cs typeface="Arial" pitchFamily="34" charset="-120"/>
                         </a:rPr>
-                        <a:t>70.3 K</a:t>
+                        <a:t>69.8 K</a:t>
                       </a:r>
                       <a:endParaRPr lang="en-US" sz="1300" dirty="0">
                         <a:latin typeface="Arial" charset="0"/>
@@ -4812,7 +4812,7 @@
                           <a:ea typeface="Arial" pitchFamily="34" charset="-122"/>
                           <a:cs typeface="Arial" pitchFamily="34" charset="-120"/>
                         </a:rPr>
-                        <a:t>0.77 K</a:t>
+                        <a:t>0.60 K</a:t>
                       </a:r>
                       <a:endParaRPr lang="en-US" sz="1300" dirty="0">
                         <a:latin typeface="Arial" charset="0"/>
@@ -4880,7 +4880,7 @@
                           <a:ea typeface="Arial" pitchFamily="34" charset="-122"/>
                           <a:cs typeface="Arial" pitchFamily="34" charset="-120"/>
                         </a:rPr>
-                        <a:t>104 s</a:t>
+                        <a:t>159 s</a:t>
                       </a:r>
                       <a:endParaRPr lang="en-US" sz="1300" dirty="0">
                         <a:latin typeface="Arial" charset="0"/>
@@ -5050,7 +5050,7 @@
                 <a:ea typeface="Arial" pitchFamily="34" charset="-122"/>
                 <a:cs typeface="Arial" pitchFamily="34" charset="-120"/>
               </a:rPr>
-              <a:t>0.77 K</a:t>
+              <a:t>0.60 K</a:t>
             </a:r>
             <a:r>
               <a:rPr lang="en-US" sz="1400" dirty="0">
@@ -5061,7 +5061,7 @@
                 <a:ea typeface="Arial" pitchFamily="34" charset="-122"/>
                 <a:cs typeface="Arial" pitchFamily="34" charset="-120"/>
               </a:rPr>
-              <a:t> and is back at exactly 90 °C in under 2 minutes.</a:t>
+              <a:t> and is back at 90 °C about 80 s after the load stops rising.</a:t>
             </a:r>
             <a:endParaRPr lang="en-US" sz="1400" dirty="0"/>
           </a:p>
@@ -5181,7 +5181,7 @@
                 <a:ea typeface="Arial" pitchFamily="34" charset="-122"/>
                 <a:cs typeface="Arial" pitchFamily="34" charset="-120"/>
               </a:rPr>
-              <a:t>EXPERIMENT · LOAD 30 → 70 %</a:t>
+              <a:t>EXPERIMENT · LOAD 30 → 70 % IN 60 s</a:t>
             </a:r>
             <a:endParaRPr lang="en-US" sz="1200" dirty="0"/>
           </a:p>
@@ -5387,7 +5387,7 @@
                 <a:ea typeface="Arial" pitchFamily="34" charset="-122"/>
                 <a:cs typeface="Arial" pitchFamily="34" charset="-120"/>
               </a:rPr>
-              <a:t>Passes 105 °C after about 3 minutes, 160 °C after 30 minutes.</a:t>
+              <a:t>Passes 105 °C after about 4 minutes, 160 °C after 30 minutes.</a:t>
             </a:r>
             <a:endParaRPr lang="en-US" sz="1300" dirty="0"/>
           </a:p>
@@ -5779,7 +5779,7 @@
                 <a:ea typeface="Arial" pitchFamily="34" charset="-122"/>
                 <a:cs typeface="Arial" pitchFamily="34" charset="-120"/>
               </a:rPr>
-              <a:t>Without control the engine would reach 170 °C. The PID keeps it within 0.8 K and brings it back to 90 °C.</a:t>
+              <a:t>Without control the engine would reach 170 °C. The PID keeps it within 0.6 K and brings it back to 90 °C.</a:t>
             </a:r>
             <a:endParaRPr lang="en-US" sz="1300" dirty="0"/>
           </a:p>
@@ -9532,7 +9532,7 @@
                 <a:ea typeface="Arial" pitchFamily="34" charset="-122"/>
                 <a:cs typeface="Arial" pitchFamily="34" charset="-120"/>
               </a:rPr>
-              <a:t>One load step in MATLAB, with and without the PID</a:t>
+              <a:t>Load rises 30 → 70 % in 60 s, with and without PID</a:t>
             </a:r>
             <a:endParaRPr lang="en-US" sz="1400" dirty="0"/>
           </a:p>

</xml_diff>